<commit_message>
Make repo public-ready: genericize deck, add MIT license, update README
- Deck: remove internal briefing framing (executive/our-teams/assign-owner) -> neutral open explainer
- Add LICENSE (MIT), with a note to cite the original checklist publications
- README (.md/.html): replace "keep private" note with open/MIT sharing note

Co-Authored-By: Claude Opus 4.8 <noreply@anthropic.com>
</commit_message>
<xml_diff>
--- a/Evidence_Appraisal_Skill_explainer.pptx
+++ b/Evidence_Appraisal_Skill_explainer.pptx
@@ -4,9 +4,6 @@
   <p:sldMasterIdLst>
     <p:sldMasterId id="2147483648" r:id="rId1"/>
   </p:sldMasterIdLst>
-  <p:notesMasterIdLst>
-    <p:notesMasterId r:id="rId14"/>
-  </p:notesMasterIdLst>
   <p:sldIdLst>
     <p:sldId id="256" r:id="rId2"/>
     <p:sldId id="257" r:id="rId3"/>
@@ -21,8 +18,11 @@
     <p:sldId id="266" r:id="rId12"/>
     <p:sldId id="267" r:id="rId13"/>
   </p:sldIdLst>
-  <p:sldSz cx="12192000" cy="6858000"/>
-  <p:notesSz cx="6858000" cy="12192000"/>
+  <p:notesMasterIdLst>
+    <p:notesMasterId r:id="rId14"/>
+  </p:notesMasterIdLst>
+  <p:sldSz cx="12191695" cy="6858000"/>
+  <p:notesSz cx="6858000" cy="12191695"/>
   <p:defaultTextStyle>
     <a:lvl1pPr marL="0" algn="l" defTabSz="914400" rtl="0" eaLnBrk="1" latinLnBrk="0" hangingPunct="1">
       <a:defRPr sz="1800" kern="1200">
@@ -115,20 +115,13 @@
       </a:defRPr>
     </a:lvl9pPr>
   </p:defaultTextStyle>
-  <p:extLst>
-    <p:ext uri="{EFAFB233-063F-42B5-8137-9DF3F51BA10A}">
-      <p15:sldGuideLst xmlns:p15="http://schemas.microsoft.com/office/powerpoint/2012/main"/>
-    </p:ext>
-  </p:extLst>
 </p:presentation>
 </file>
 
 <file path=ppt/charts/chart1.xml><?xml version="1.0" encoding="utf-8"?>
-<c:chartSpace xmlns:c="http://schemas.openxmlformats.org/drawingml/2006/chart" xmlns:a="http://schemas.openxmlformats.org/drawingml/2006/main" xmlns:r="http://schemas.openxmlformats.org/officeDocument/2006/relationships" xmlns:c16r2="http://schemas.microsoft.com/office/drawing/2015/06/chart">
+<c:chartSpace xmlns:c="http://schemas.openxmlformats.org/drawingml/2006/chart" xmlns:a="http://schemas.openxmlformats.org/drawingml/2006/main" xmlns:r="http://schemas.openxmlformats.org/officeDocument/2006/relationships">
   <c:date1904 val="0"/>
-  <c:lang val="en-US"/>
   <c:roundedCorners val="1"/>
-  <c:style val="2"/>
   <c:chart>
     <c:autoTitleDeleted val="1"/>
     <c:plotArea>
@@ -158,15 +151,40 @@
             <a:effectLst/>
           </c:spPr>
           <c:invertIfNegative val="0"/>
+          <c:dLbls>
+            <c:numFmt formatCode="0.0&quot;%&quot;" sourceLinked="0"/>
+            <c:txPr>
+              <a:bodyPr/>
+              <a:lstStyle/>
+              <a:p>
+                <a:pPr>
+                  <a:defRPr b="0" i="0" strike="noStrike" sz="1100" u="none">
+                    <a:solidFill>
+                      <a:srgbClr val="0E2E36"/>
+                    </a:solidFill>
+                    <a:latin typeface="Calibri"/>
+                  </a:defRPr>
+                </a:pPr>
+              </a:p>
+            </c:txPr>
+            <c:showLegendKey val="0"/>
+            <c:showVal val="1"/>
+            <c:showCatName val="0"/>
+            <c:showSerName val="0"/>
+            <c:showPercent val="0"/>
+            <c:showBubbleSize val="0"/>
+            <c:showLeaderLines val="0"/>
+          </c:dLbls>
           <c:dPt>
             <c:idx val="0"/>
             <c:invertIfNegative val="0"/>
             <c:bubble3D val="0"/>
-            <c:extLst>
-              <c:ext xmlns:c16="http://schemas.microsoft.com/office/drawing/2014/chart" uri="{C3380CC4-5D6E-409C-BE32-E72D297353CC}">
-                <c16:uniqueId val="{00000001-AAFD-4426-BDDA-C6A4D28D9023}"/>
-              </c:ext>
-            </c:extLst>
+            <c:spPr>
+              <a:solidFill>
+                <a:srgbClr val="0E5A6B"/>
+              </a:solidFill>
+              <a:effectLst/>
+            </c:spPr>
           </c:dPt>
           <c:dPt>
             <c:idx val="1"/>
@@ -178,11 +196,6 @@
               </a:solidFill>
               <a:effectLst/>
             </c:spPr>
-            <c:extLst>
-              <c:ext xmlns:c16="http://schemas.microsoft.com/office/drawing/2014/chart" uri="{C3380CC4-5D6E-409C-BE32-E72D297353CC}">
-                <c16:uniqueId val="{00000003-AAFD-4426-BDDA-C6A4D28D9023}"/>
-              </c:ext>
-            </c:extLst>
           </c:dPt>
           <c:dPt>
             <c:idx val="2"/>
@@ -194,11 +207,6 @@
               </a:solidFill>
               <a:effectLst/>
             </c:spPr>
-            <c:extLst>
-              <c:ext xmlns:c16="http://schemas.microsoft.com/office/drawing/2014/chart" uri="{C3380CC4-5D6E-409C-BE32-E72D297353CC}">
-                <c16:uniqueId val="{00000005-AAFD-4426-BDDA-C6A4D28D9023}"/>
-              </c:ext>
-            </c:extLst>
           </c:dPt>
           <c:dPt>
             <c:idx val="3"/>
@@ -210,11 +218,6 @@
               </a:solidFill>
               <a:effectLst/>
             </c:spPr>
-            <c:extLst>
-              <c:ext xmlns:c16="http://schemas.microsoft.com/office/drawing/2014/chart" uri="{C3380CC4-5D6E-409C-BE32-E72D297353CC}">
-                <c16:uniqueId val="{00000007-AAFD-4426-BDDA-C6A4D28D9023}"/>
-              </c:ext>
-            </c:extLst>
           </c:dPt>
           <c:dPt>
             <c:idx val="4"/>
@@ -226,71 +229,31 @@
               </a:solidFill>
               <a:effectLst/>
             </c:spPr>
-            <c:extLst>
-              <c:ext xmlns:c16="http://schemas.microsoft.com/office/drawing/2014/chart" uri="{C3380CC4-5D6E-409C-BE32-E72D297353CC}">
-                <c16:uniqueId val="{00000009-AAFD-4426-BDDA-C6A4D28D9023}"/>
-              </c:ext>
-            </c:extLst>
           </c:dPt>
-          <c:dLbls>
-            <c:numFmt formatCode="0.0&quot;%&quot;" sourceLinked="0"/>
-            <c:spPr>
-              <a:noFill/>
-              <a:ln>
-                <a:noFill/>
-              </a:ln>
-              <a:effectLst/>
-            </c:spPr>
-            <c:txPr>
-              <a:bodyPr/>
-              <a:lstStyle/>
-              <a:p>
-                <a:pPr>
-                  <a:defRPr sz="1100" b="0" i="0" u="none" strike="noStrike">
-                    <a:solidFill>
-                      <a:srgbClr val="0E2E36"/>
-                    </a:solidFill>
-                    <a:latin typeface="Calibri"/>
-                  </a:defRPr>
-                </a:pPr>
-                <a:endParaRPr lang="en-CH"/>
-              </a:p>
-            </c:txPr>
-            <c:showLegendKey val="0"/>
-            <c:showVal val="1"/>
-            <c:showCatName val="0"/>
-            <c:showSerName val="0"/>
-            <c:showPercent val="0"/>
-            <c:showBubbleSize val="0"/>
-            <c:showLeaderLines val="0"/>
-            <c:extLst>
-              <c:ext xmlns:c15="http://schemas.microsoft.com/office/drawing/2012/chart" uri="{CE6537A1-D6FC-4f65-9D91-7224C49458BB}">
-                <c15:showLeaderLines val="0"/>
-              </c:ext>
-            </c:extLst>
-          </c:dLbls>
           <c:cat>
-            <c:strRef>
+            <c:multiLvlStrRef>
               <c:f>Sheet1!$A$2:$A$6</c:f>
-              <c:strCache>
+              <c:multiLvlStrCache>
                 <c:ptCount val="5"/>
-                <c:pt idx="0">
-                  <c:v>MiniMed 780G</c:v>
-                </c:pt>
-                <c:pt idx="1">
-                  <c:v>Control-IQ</c:v>
-                </c:pt>
-                <c:pt idx="2">
-                  <c:v>MiniMed 670G</c:v>
-                </c:pt>
-                <c:pt idx="3">
-                  <c:v>CamAPS Fx</c:v>
-                </c:pt>
-                <c:pt idx="4">
-                  <c:v>DBLG1</c:v>
-                </c:pt>
-              </c:strCache>
-            </c:strRef>
+                <c:lvl>
+                  <c:pt idx="0">
+                    <c:v>MiniMed 780G</c:v>
+                  </c:pt>
+                  <c:pt idx="1">
+                    <c:v>Control-IQ</c:v>
+                  </c:pt>
+                  <c:pt idx="2">
+                    <c:v>MiniMed 670G</c:v>
+                  </c:pt>
+                  <c:pt idx="3">
+                    <c:v>CamAPS Fx</c:v>
+                  </c:pt>
+                  <c:pt idx="4">
+                    <c:v>DBLG1</c:v>
+                  </c:pt>
+                </c:lvl>
+              </c:multiLvlStrCache>
+            </c:multiLvlStrRef>
           </c:cat>
           <c:val>
             <c:numRef>
@@ -316,23 +279,36 @@
               </c:numCache>
             </c:numRef>
           </c:val>
-          <c:extLst>
-            <c:ext xmlns:c16="http://schemas.microsoft.com/office/drawing/2014/chart" uri="{C3380CC4-5D6E-409C-BE32-E72D297353CC}">
-              <c16:uniqueId val="{0000000A-AAFD-4426-BDDA-C6A4D28D9023}"/>
-            </c:ext>
-          </c:extLst>
         </c:ser>
         <c:dLbls>
+          <c:numFmt formatCode="0.0&quot;%&quot;" sourceLinked="0"/>
+          <c:txPr>
+            <a:bodyPr/>
+            <a:lstStyle/>
+            <a:p>
+              <a:pPr>
+                <a:defRPr b="0" i="0" strike="noStrike" sz="1100" u="none">
+                  <a:solidFill>
+                    <a:srgbClr val="0E2E36"/>
+                  </a:solidFill>
+                  <a:latin typeface="Calibri"/>
+                </a:defRPr>
+              </a:pPr>
+            </a:p>
+          </c:txPr>
           <c:showLegendKey val="0"/>
           <c:showVal val="1"/>
           <c:showCatName val="0"/>
           <c:showSerName val="0"/>
           <c:showPercent val="0"/>
           <c:showBubbleSize val="0"/>
+          <c:showLeaderLines val="0"/>
         </c:dLbls>
         <c:gapWidth val="150"/>
+        <c:overlap val="0"/>
         <c:axId val="2094734554"/>
         <c:axId val="2094734552"/>
+        <c:axId val="2094734556"/>
       </c:barChart>
       <c:catAx>
         <c:axId val="2094734554"/>
@@ -373,7 +349,6 @@
         <c:crosses val="autoZero"/>
         <c:auto val="1"/>
         <c:lblAlgn val="ctr"/>
-        <c:lblOffset val="100"/>
         <c:noMultiLvlLbl val="1"/>
       </c:catAx>
       <c:valAx>
@@ -387,6 +362,30 @@
         <c:majorTickMark val="out"/>
         <c:minorTickMark val="none"/>
         <c:tickLblPos val="nextTo"/>
+        <c:spPr>
+          <a:ln w="12700" cap="flat">
+            <a:solidFill>
+              <a:srgbClr val="888888"/>
+            </a:solidFill>
+            <a:prstDash val="solid"/>
+            <a:round/>
+          </a:ln>
+        </c:spPr>
+        <c:txPr>
+          <a:bodyPr/>
+          <a:lstStyle/>
+          <a:p>
+            <a:pPr>
+              <a:defRPr sz="1200" b="0" i="0" u="none" strike="noStrike">
+                <a:solidFill>
+                  <a:srgbClr val="000000"/>
+                </a:solidFill>
+                <a:latin typeface="Arial"/>
+              </a:defRPr>
+            </a:pPr>
+            <a:endParaRPr lang="en-US"/>
+          </a:p>
+        </c:txPr>
         <c:crossAx val="2094734554"/>
         <c:crosses val="autoZero"/>
         <c:crossBetween val="between"/>
@@ -401,7 +400,6 @@
     </c:plotArea>
     <c:plotVisOnly val="1"/>
     <c:dispBlanksAs val="span"/>
-    <c:showDLblsOverMax val="1"/>
   </c:chart>
   <c:spPr>
     <a:solidFill>
@@ -440,10 +438,234 @@
           <a:chExt cx="0" cy="0"/>
         </a:xfrm>
       </p:grpSpPr>
+      <p:sp>
+        <p:nvSpPr>
+          <p:cNvPr id="2" name="Header Placeholder 1"/>
+          <p:cNvSpPr>
+            <a:spLocks noGrp="1"/>
+          </p:cNvSpPr>
+          <p:nvPr>
+            <p:ph type="hdr" sz="quarter"/>
+          </p:nvPr>
+        </p:nvSpPr>
+        <p:spPr>
+          <a:xfrm>
+            <a:off x="0" y="0"/>
+            <a:ext cx="2971800" cy="458788"/>
+          </a:xfrm>
+          <a:prstGeom prst="rect">
+            <a:avLst/>
+          </a:prstGeom>
+        </p:spPr>
+        <p:txBody>
+          <a:bodyPr vert="horz" lIns="91440" tIns="45720" rIns="91440" bIns="45720" rtlCol="0"/>
+          <a:lstStyle>
+            <a:lvl1pPr algn="l">
+              <a:defRPr sz="1200"/>
+            </a:lvl1pPr>
+          </a:lstStyle>
+          <a:p>
+            <a:endParaRPr lang="en-US"/>
+          </a:p>
+        </p:txBody>
+      </p:sp>
+      <p:sp>
+        <p:nvSpPr>
+          <p:cNvPr id="3" name="Date Placeholder 2"/>
+          <p:cNvSpPr>
+            <a:spLocks noGrp="1"/>
+          </p:cNvSpPr>
+          <p:nvPr>
+            <p:ph type="dt" idx="1"/>
+          </p:nvPr>
+        </p:nvSpPr>
+        <p:spPr>
+          <a:xfrm>
+            <a:off x="3884613" y="0"/>
+            <a:ext cx="2971800" cy="458788"/>
+          </a:xfrm>
+          <a:prstGeom prst="rect">
+            <a:avLst/>
+          </a:prstGeom>
+        </p:spPr>
+        <p:txBody>
+          <a:bodyPr vert="horz" lIns="91440" tIns="45720" rIns="91440" bIns="45720" rtlCol="0"/>
+          <a:lstStyle>
+            <a:lvl1pPr algn="r">
+              <a:defRPr sz="1200"/>
+            </a:lvl1pPr>
+          </a:lstStyle>
+          <a:p>
+            <a:fld id="{5282F153-3F37-0F45-9E97-73ACFA13230C}" type="datetimeFigureOut">
+              <a:rPr lang="en-US"/>
+              <a:t>7/23/19</a:t>
+            </a:fld>
+            <a:endParaRPr lang="en-US"/>
+          </a:p>
+        </p:txBody>
+      </p:sp>
+      <p:sp>
+        <p:nvSpPr>
+          <p:cNvPr id="4" name="Slide Image Placeholder 3"/>
+          <p:cNvSpPr>
+            <a:spLocks noGrp="1" noRot="1" noChangeAspect="1"/>
+          </p:cNvSpPr>
+          <p:nvPr>
+            <p:ph type="sldImg" idx="2"/>
+          </p:nvPr>
+        </p:nvSpPr>
+        <p:spPr>
+          <a:xfrm>
+            <a:off x="685800" y="1143000"/>
+            <a:ext cx="5486400" cy="3086100"/>
+          </a:xfrm>
+          <a:prstGeom prst="rect">
+            <a:avLst/>
+          </a:prstGeom>
+          <a:noFill/>
+          <a:ln w="12700">
+            <a:solidFill>
+              <a:prstClr val="black"/>
+            </a:solidFill>
+          </a:ln>
+        </p:spPr>
+        <p:txBody>
+          <a:bodyPr vert="horz" lIns="91440" tIns="45720" rIns="91440" bIns="45720" rtlCol="0" anchor="ctr"/>
+          <a:lstStyle/>
+          <a:p>
+            <a:endParaRPr lang="en-US"/>
+          </a:p>
+        </p:txBody>
+      </p:sp>
+      <p:sp>
+        <p:nvSpPr>
+          <p:cNvPr id="5" name="Notes Placeholder 4"/>
+          <p:cNvSpPr>
+            <a:spLocks noGrp="1"/>
+          </p:cNvSpPr>
+          <p:nvPr>
+            <p:ph type="body" sz="quarter" idx="3"/>
+          </p:nvPr>
+        </p:nvSpPr>
+        <p:spPr>
+          <a:xfrm>
+            <a:off x="685800" y="4400550"/>
+            <a:ext cx="5486400" cy="3600450"/>
+          </a:xfrm>
+          <a:prstGeom prst="rect">
+            <a:avLst/>
+          </a:prstGeom>
+        </p:spPr>
+        <p:txBody>
+          <a:bodyPr vert="horz" lIns="91440" tIns="45720" rIns="91440" bIns="45720" rtlCol="0"/>
+          <a:lstStyle/>
+          <a:p>
+            <a:pPr lvl="0"/>
+            <a:r>
+              <a:rPr lang="en-US"/>
+              <a:t>Click to edit Master text styles</a:t>
+            </a:r>
+          </a:p>
+          <a:p>
+            <a:pPr lvl="1"/>
+            <a:r>
+              <a:rPr lang="en-US"/>
+              <a:t>Second level</a:t>
+            </a:r>
+          </a:p>
+          <a:p>
+            <a:pPr lvl="2"/>
+            <a:r>
+              <a:rPr lang="en-US"/>
+              <a:t>Third level</a:t>
+            </a:r>
+          </a:p>
+          <a:p>
+            <a:pPr lvl="3"/>
+            <a:r>
+              <a:rPr lang="en-US"/>
+              <a:t>Fourth level</a:t>
+            </a:r>
+          </a:p>
+          <a:p>
+            <a:pPr lvl="4"/>
+            <a:r>
+              <a:rPr lang="en-US"/>
+              <a:t>Fifth level</a:t>
+            </a:r>
+          </a:p>
+        </p:txBody>
+      </p:sp>
+      <p:sp>
+        <p:nvSpPr>
+          <p:cNvPr id="6" name="Footer Placeholder 5"/>
+          <p:cNvSpPr>
+            <a:spLocks noGrp="1"/>
+          </p:cNvSpPr>
+          <p:nvPr>
+            <p:ph type="ftr" sz="quarter" idx="4"/>
+          </p:nvPr>
+        </p:nvSpPr>
+        <p:spPr>
+          <a:xfrm>
+            <a:off x="0" y="8685213"/>
+            <a:ext cx="2971800" cy="458787"/>
+          </a:xfrm>
+          <a:prstGeom prst="rect">
+            <a:avLst/>
+          </a:prstGeom>
+        </p:spPr>
+        <p:txBody>
+          <a:bodyPr vert="horz" lIns="91440" tIns="45720" rIns="91440" bIns="45720" rtlCol="0" anchor="b"/>
+          <a:lstStyle>
+            <a:lvl1pPr algn="l">
+              <a:defRPr sz="1200"/>
+            </a:lvl1pPr>
+          </a:lstStyle>
+          <a:p>
+            <a:endParaRPr lang="en-US"/>
+          </a:p>
+        </p:txBody>
+      </p:sp>
+      <p:sp>
+        <p:nvSpPr>
+          <p:cNvPr id="7" name="Slide Number Placeholder 6"/>
+          <p:cNvSpPr>
+            <a:spLocks noGrp="1"/>
+          </p:cNvSpPr>
+          <p:nvPr>
+            <p:ph type="sldNum" sz="quarter" idx="5"/>
+          </p:nvPr>
+        </p:nvSpPr>
+        <p:spPr>
+          <a:xfrm>
+            <a:off x="3884613" y="8685213"/>
+            <a:ext cx="2971800" cy="458787"/>
+          </a:xfrm>
+          <a:prstGeom prst="rect">
+            <a:avLst/>
+          </a:prstGeom>
+        </p:spPr>
+        <p:txBody>
+          <a:bodyPr vert="horz" lIns="91440" tIns="45720" rIns="91440" bIns="45720" rtlCol="0" anchor="b"/>
+          <a:lstStyle>
+            <a:lvl1pPr algn="r">
+              <a:defRPr sz="1200"/>
+            </a:lvl1pPr>
+          </a:lstStyle>
+          <a:p>
+            <a:fld id="{CE5E9CC1-C706-0F49-92D6-E571CC5EEA8F}" type="slidenum">
+              <a:rPr lang="en-US"/>
+              <a:t>‹#›</a:t>
+            </a:fld>
+            <a:endParaRPr lang="en-US"/>
+          </a:p>
+        </p:txBody>
+      </p:sp>
     </p:spTree>
     <p:extLst>
       <p:ext uri="{BB962C8B-B14F-4D97-AF65-F5344CB8AC3E}">
-        <p14:creationId xmlns:p14="http://schemas.microsoft.com/office/powerpoint/2010/main" val="3747715259"/>
+        <p14:creationId xmlns:p14="http://schemas.microsoft.com/office/powerpoint/2010/main" val="1024086991"/>
       </p:ext>
     </p:extLst>
   </p:cSld>
@@ -587,6 +809,10 @@
           <a:bodyPr/>
           <a:lstStyle/>
           <a:p>
+            <a:r>
+              <a:rPr lang="en-US" dirty="0"/>
+              <a:t/>
+            </a:r>
             <a:endParaRPr lang="en-US" dirty="0"/>
           </a:p>
         </p:txBody>
@@ -671,6 +897,10 @@
           <a:bodyPr/>
           <a:lstStyle/>
           <a:p>
+            <a:r>
+              <a:rPr lang="en-US" dirty="0"/>
+              <a:t/>
+            </a:r>
             <a:endParaRPr lang="en-US" dirty="0"/>
           </a:p>
         </p:txBody>
@@ -755,6 +985,10 @@
           <a:bodyPr/>
           <a:lstStyle/>
           <a:p>
+            <a:r>
+              <a:rPr lang="en-US" dirty="0"/>
+              <a:t/>
+            </a:r>
             <a:endParaRPr lang="en-US" dirty="0"/>
           </a:p>
         </p:txBody>
@@ -839,6 +1073,10 @@
           <a:bodyPr/>
           <a:lstStyle/>
           <a:p>
+            <a:r>
+              <a:rPr lang="en-US" dirty="0"/>
+              <a:t/>
+            </a:r>
             <a:endParaRPr lang="en-US" dirty="0"/>
           </a:p>
         </p:txBody>
@@ -923,6 +1161,10 @@
           <a:bodyPr/>
           <a:lstStyle/>
           <a:p>
+            <a:r>
+              <a:rPr lang="en-US" dirty="0"/>
+              <a:t/>
+            </a:r>
             <a:endParaRPr lang="en-US" dirty="0"/>
           </a:p>
         </p:txBody>
@@ -1007,6 +1249,10 @@
           <a:bodyPr/>
           <a:lstStyle/>
           <a:p>
+            <a:r>
+              <a:rPr lang="en-US" dirty="0"/>
+              <a:t/>
+            </a:r>
             <a:endParaRPr lang="en-US" dirty="0"/>
           </a:p>
         </p:txBody>
@@ -1091,6 +1337,10 @@
           <a:bodyPr/>
           <a:lstStyle/>
           <a:p>
+            <a:r>
+              <a:rPr lang="en-US" dirty="0"/>
+              <a:t/>
+            </a:r>
             <a:endParaRPr lang="en-US" dirty="0"/>
           </a:p>
         </p:txBody>
@@ -1175,6 +1425,10 @@
           <a:bodyPr/>
           <a:lstStyle/>
           <a:p>
+            <a:r>
+              <a:rPr lang="en-US" dirty="0"/>
+              <a:t/>
+            </a:r>
             <a:endParaRPr lang="en-US" dirty="0"/>
           </a:p>
         </p:txBody>
@@ -1259,6 +1513,10 @@
           <a:bodyPr/>
           <a:lstStyle/>
           <a:p>
+            <a:r>
+              <a:rPr lang="en-US" dirty="0"/>
+              <a:t/>
+            </a:r>
             <a:endParaRPr lang="en-US" dirty="0"/>
           </a:p>
         </p:txBody>
@@ -1343,6 +1601,10 @@
           <a:bodyPr/>
           <a:lstStyle/>
           <a:p>
+            <a:r>
+              <a:rPr lang="en-US" dirty="0"/>
+              <a:t/>
+            </a:r>
             <a:endParaRPr lang="en-US" dirty="0"/>
           </a:p>
         </p:txBody>
@@ -1427,6 +1689,10 @@
           <a:bodyPr/>
           <a:lstStyle/>
           <a:p>
+            <a:r>
+              <a:rPr lang="en-US" dirty="0"/>
+              <a:t/>
+            </a:r>
             <a:endParaRPr lang="en-US" dirty="0"/>
           </a:p>
         </p:txBody>
@@ -1511,6 +1777,10 @@
           <a:bodyPr/>
           <a:lstStyle/>
           <a:p>
+            <a:r>
+              <a:rPr lang="en-US" dirty="0"/>
+              <a:t/>
+            </a:r>
             <a:endParaRPr lang="en-US" dirty="0"/>
           </a:p>
         </p:txBody>
@@ -1584,11 +1854,6 @@
 <file path=ppt/slideMasters/slideMaster1.xml><?xml version="1.0" encoding="utf-8"?>
 <p:sldMaster xmlns:a="http://schemas.openxmlformats.org/drawingml/2006/main" xmlns:r="http://schemas.openxmlformats.org/officeDocument/2006/relationships" xmlns:p="http://schemas.openxmlformats.org/presentationml/2006/main">
   <p:cSld>
-    <p:bg>
-      <p:bgRef idx="1001">
-        <a:schemeClr val="bg1"/>
-      </p:bgRef>
-    </p:bg>
     <p:spTree>
       <p:nvGrpSpPr>
         <p:cNvPr id="1" name=""/>
@@ -1871,7 +2136,6 @@
         <a:solidFill>
           <a:srgbClr val="0E2E36"/>
         </a:solidFill>
-        <a:effectLst/>
       </p:bgPr>
     </p:bg>
     <p:spTree>
@@ -1909,13 +2173,6 @@
           </a:solidFill>
           <a:ln/>
         </p:spPr>
-        <p:txBody>
-          <a:bodyPr/>
-          <a:lstStyle/>
-          <a:p>
-            <a:endParaRPr lang="en-CH"/>
-          </a:p>
-        </p:txBody>
       </p:sp>
       <p:sp>
         <p:nvSpPr>
@@ -1938,13 +2195,6 @@
           </a:solidFill>
           <a:ln/>
         </p:spPr>
-        <p:txBody>
-          <a:bodyPr/>
-          <a:lstStyle/>
-          <a:p>
-            <a:endParaRPr lang="en-CH"/>
-          </a:p>
-        </p:txBody>
       </p:sp>
       <p:sp>
         <p:nvSpPr>
@@ -1967,11 +2217,11 @@
           <a:bodyPr wrap="square" lIns="0" tIns="0" rIns="0" bIns="0" rtlCol="0" anchor="ctr"/>
           <a:lstStyle/>
           <a:p>
-            <a:pPr marL="0" indent="0">
-              <a:buNone/>
-            </a:pPr>
-            <a:r>
-              <a:rPr lang="en-US" sz="1300" b="1" kern="0" spc="300" dirty="0">
+            <a:pPr indent="0" marL="0">
+              <a:buNone/>
+            </a:pPr>
+            <a:r>
+              <a:rPr lang="en-US" sz="1300" b="1" spc="300" kern="0" dirty="0">
                 <a:solidFill>
                   <a:srgbClr val="1FA598"/>
                 </a:solidFill>
@@ -1979,7 +2229,7 @@
                 <a:ea typeface="Calibri" pitchFamily="34" charset="-122"/>
                 <a:cs typeface="Calibri" pitchFamily="34" charset="-120"/>
               </a:rPr>
-              <a:t>AI CAPABILITY BRIEFING</a:t>
+              <a:t>AN OPEN EXPLAINER</a:t>
             </a:r>
             <a:endParaRPr lang="en-US" sz="1300" dirty="0"/>
           </a:p>
@@ -2006,7 +2256,7 @@
           <a:bodyPr wrap="square" lIns="0" tIns="0" rIns="0" bIns="0" rtlCol="0" anchor="ctr"/>
           <a:lstStyle/>
           <a:p>
-            <a:pPr marL="0" indent="0">
+            <a:pPr indent="0" marL="0">
               <a:lnSpc>
                 <a:spcPct val="98000"/>
               </a:lnSpc>
@@ -2048,7 +2298,7 @@
           <a:bodyPr wrap="square" lIns="0" tIns="0" rIns="0" bIns="0" rtlCol="0" anchor="ctr"/>
           <a:lstStyle/>
           <a:p>
-            <a:pPr marL="0" indent="0">
+            <a:pPr indent="0" marL="0">
               <a:lnSpc>
                 <a:spcPct val="106000"/>
               </a:lnSpc>
@@ -2090,7 +2340,7 @@
           <a:bodyPr wrap="square" lIns="0" tIns="0" rIns="0" bIns="0" rtlCol="0" anchor="ctr"/>
           <a:lstStyle/>
           <a:p>
-            <a:pPr marL="0" indent="0">
+            <a:pPr indent="0" marL="0">
               <a:buNone/>
             </a:pPr>
             <a:r>
@@ -2104,6 +2354,9 @@
               </a:rPr>
               <a:t>No model retraining</a:t>
             </a:r>
+            <a:pPr indent="0" marL="0">
+              <a:buNone/>
+            </a:pPr>
             <a:r>
               <a:rPr lang="en-US" sz="1300" b="1" dirty="0">
                 <a:solidFill>
@@ -2115,6 +2368,9 @@
               </a:rPr>
               <a:t>     </a:t>
             </a:r>
+            <a:pPr indent="0" marL="0">
+              <a:buNone/>
+            </a:pPr>
             <a:r>
               <a:rPr lang="en-US" sz="1300" b="1" dirty="0">
                 <a:solidFill>
@@ -2126,6 +2382,9 @@
               </a:rPr>
               <a:t>Loaded only when needed</a:t>
             </a:r>
+            <a:pPr indent="0" marL="0">
+              <a:buNone/>
+            </a:pPr>
             <a:r>
               <a:rPr lang="en-US" sz="1300" b="1" dirty="0">
                 <a:solidFill>
@@ -2137,6 +2396,9 @@
               </a:rPr>
               <a:t>     </a:t>
             </a:r>
+            <a:pPr indent="0" marL="0">
+              <a:buNone/>
+            </a:pPr>
             <a:r>
               <a:rPr lang="en-US" sz="1300" b="1" dirty="0">
                 <a:solidFill>
@@ -2173,7 +2435,7 @@
           <a:bodyPr wrap="square" lIns="0" tIns="0" rIns="0" bIns="0" rtlCol="0" anchor="ctr"/>
           <a:lstStyle/>
           <a:p>
-            <a:pPr marL="0" indent="0">
+            <a:pPr indent="0" marL="0">
               <a:buNone/>
             </a:pPr>
             <a:r>
@@ -2207,7 +2469,6 @@
         <a:solidFill>
           <a:srgbClr val="F2F6F7"/>
         </a:solidFill>
-        <a:effectLst/>
       </p:bgPr>
     </p:bg>
     <p:spTree>
@@ -2245,11 +2506,11 @@
           <a:bodyPr wrap="square" lIns="0" tIns="0" rIns="0" bIns="0" rtlCol="0" anchor="ctr"/>
           <a:lstStyle/>
           <a:p>
-            <a:pPr marL="0" indent="0">
-              <a:buNone/>
-            </a:pPr>
-            <a:r>
-              <a:rPr lang="en-US" sz="1200" b="1" kern="0" spc="300" dirty="0">
+            <a:pPr indent="0" marL="0">
+              <a:buNone/>
+            </a:pPr>
+            <a:r>
+              <a:rPr lang="en-US" sz="1200" b="1" spc="300" kern="0" dirty="0">
                 <a:solidFill>
                   <a:srgbClr val="1FA598"/>
                 </a:solidFill>
@@ -2257,7 +2518,7 @@
                 <a:ea typeface="Calibri" pitchFamily="34" charset="-122"/>
                 <a:cs typeface="Calibri" pitchFamily="34" charset="-120"/>
               </a:rPr>
-              <a:t>THE LEVERAGE</a:t>
+              <a:t>WHO IT HELPS</a:t>
             </a:r>
             <a:endParaRPr lang="en-US" sz="1200" dirty="0"/>
           </a:p>
@@ -2284,7 +2545,7 @@
           <a:bodyPr wrap="square" lIns="0" tIns="0" rIns="0" bIns="0" rtlCol="0" anchor="ctr"/>
           <a:lstStyle/>
           <a:p>
-            <a:pPr marL="0" indent="0">
+            <a:pPr indent="0" marL="0">
               <a:buNone/>
             </a:pPr>
             <a:r>
@@ -2296,7 +2557,7 @@
                 <a:ea typeface="Cambria" pitchFamily="34" charset="-122"/>
                 <a:cs typeface="Cambria" pitchFamily="34" charset="-120"/>
               </a:rPr>
-              <a:t>One skill, compounding across three teams</a:t>
+              <a:t>One skill, three kinds of team</a:t>
             </a:r>
             <a:endParaRPr lang="en-US" sz="3000" dirty="0"/>
           </a:p>
@@ -2323,20 +2584,13 @@
           </a:solidFill>
           <a:ln/>
           <a:effectLst>
-            <a:outerShdw blurRad="114300" dist="38100" dir="5400000" algn="bl" rotWithShape="0">
+            <a:outerShdw sx="100000" sy="100000" kx="0" ky="0" algn="bl" rotWithShape="0" blurRad="114300" dist="38100" dir="5400000">
               <a:srgbClr val="0A2A31">
                 <a:alpha val="11000"/>
               </a:srgbClr>
             </a:outerShdw>
           </a:effectLst>
         </p:spPr>
-        <p:txBody>
-          <a:bodyPr/>
-          <a:lstStyle/>
-          <a:p>
-            <a:endParaRPr lang="en-CH"/>
-          </a:p>
-        </p:txBody>
       </p:sp>
       <p:sp>
         <p:nvSpPr>
@@ -2359,13 +2613,6 @@
           </a:solidFill>
           <a:ln/>
         </p:spPr>
-        <p:txBody>
-          <a:bodyPr/>
-          <a:lstStyle/>
-          <a:p>
-            <a:endParaRPr lang="en-CH"/>
-          </a:p>
-        </p:txBody>
       </p:sp>
       <p:sp>
         <p:nvSpPr>
@@ -2388,7 +2635,7 @@
           <a:bodyPr wrap="square" lIns="0" tIns="0" rIns="0" bIns="0" rtlCol="0" anchor="ctr"/>
           <a:lstStyle/>
           <a:p>
-            <a:pPr marL="0" indent="0">
+            <a:pPr indent="0" marL="0">
               <a:lnSpc>
                 <a:spcPct val="95000"/>
               </a:lnSpc>
@@ -2524,20 +2771,13 @@
           </a:solidFill>
           <a:ln/>
           <a:effectLst>
-            <a:outerShdw blurRad="114300" dist="38100" dir="5400000" algn="bl" rotWithShape="0">
+            <a:outerShdw sx="100000" sy="100000" kx="0" ky="0" algn="bl" rotWithShape="0" blurRad="114300" dist="38100" dir="5400000">
               <a:srgbClr val="0A2A31">
                 <a:alpha val="11000"/>
               </a:srgbClr>
             </a:outerShdw>
           </a:effectLst>
         </p:spPr>
-        <p:txBody>
-          <a:bodyPr/>
-          <a:lstStyle/>
-          <a:p>
-            <a:endParaRPr lang="en-CH"/>
-          </a:p>
-        </p:txBody>
       </p:sp>
       <p:sp>
         <p:nvSpPr>
@@ -2560,13 +2800,6 @@
           </a:solidFill>
           <a:ln/>
         </p:spPr>
-        <p:txBody>
-          <a:bodyPr/>
-          <a:lstStyle/>
-          <a:p>
-            <a:endParaRPr lang="en-CH"/>
-          </a:p>
-        </p:txBody>
       </p:sp>
       <p:sp>
         <p:nvSpPr>
@@ -2589,7 +2822,7 @@
           <a:bodyPr wrap="square" lIns="0" tIns="0" rIns="0" bIns="0" rtlCol="0" anchor="ctr"/>
           <a:lstStyle/>
           <a:p>
-            <a:pPr marL="0" indent="0">
+            <a:pPr indent="0" marL="0">
               <a:lnSpc>
                 <a:spcPct val="95000"/>
               </a:lnSpc>
@@ -2725,20 +2958,13 @@
           </a:solidFill>
           <a:ln/>
           <a:effectLst>
-            <a:outerShdw blurRad="114300" dist="38100" dir="5400000" algn="bl" rotWithShape="0">
+            <a:outerShdw sx="100000" sy="100000" kx="0" ky="0" algn="bl" rotWithShape="0" blurRad="114300" dist="38100" dir="5400000">
               <a:srgbClr val="0A2A31">
                 <a:alpha val="11000"/>
               </a:srgbClr>
             </a:outerShdw>
           </a:effectLst>
         </p:spPr>
-        <p:txBody>
-          <a:bodyPr/>
-          <a:lstStyle/>
-          <a:p>
-            <a:endParaRPr lang="en-CH"/>
-          </a:p>
-        </p:txBody>
       </p:sp>
       <p:sp>
         <p:nvSpPr>
@@ -2761,13 +2987,6 @@
           </a:solidFill>
           <a:ln/>
         </p:spPr>
-        <p:txBody>
-          <a:bodyPr/>
-          <a:lstStyle/>
-          <a:p>
-            <a:endParaRPr lang="en-CH"/>
-          </a:p>
-        </p:txBody>
       </p:sp>
       <p:sp>
         <p:nvSpPr>
@@ -2790,7 +3009,7 @@
           <a:bodyPr wrap="square" lIns="0" tIns="0" rIns="0" bIns="0" rtlCol="0" anchor="ctr"/>
           <a:lstStyle/>
           <a:p>
-            <a:pPr marL="0" indent="0">
+            <a:pPr indent="0" marL="0">
               <a:lnSpc>
                 <a:spcPct val="95000"/>
               </a:lnSpc>
@@ -2914,19 +3133,19 @@
         <p:spPr>
           <a:xfrm>
             <a:off x="548640" y="6473952"/>
-            <a:ext cx="4572000" cy="274320"/>
-          </a:xfrm>
-          <a:prstGeom prst="rect">
-            <a:avLst/>
-          </a:prstGeom>
-          <a:noFill/>
-          <a:ln/>
-        </p:spPr>
-        <p:txBody>
-          <a:bodyPr wrap="square" lIns="0" tIns="0" rIns="0" bIns="0" rtlCol="0" anchor="ctr"/>
-          <a:lstStyle/>
-          <a:p>
-            <a:pPr marL="0" indent="0" algn="l">
+            <a:ext cx="5486400" cy="274320"/>
+          </a:xfrm>
+          <a:prstGeom prst="rect">
+            <a:avLst/>
+          </a:prstGeom>
+          <a:noFill/>
+          <a:ln/>
+        </p:spPr>
+        <p:txBody>
+          <a:bodyPr wrap="square" lIns="0" tIns="0" rIns="0" bIns="0" rtlCol="0" anchor="ctr"/>
+          <a:lstStyle/>
+          <a:p>
+            <a:pPr algn="l" indent="0" marL="0">
               <a:buNone/>
             </a:pPr>
             <a:r>
@@ -2938,7 +3157,7 @@
                 <a:ea typeface="Calibri" pitchFamily="34" charset="-122"/>
                 <a:cs typeface="Calibri" pitchFamily="34" charset="-120"/>
               </a:rPr>
-              <a:t>AI Skills · Executive Briefing</a:t>
+              <a:t>Evidence-Appraisal Skill · an open explainer</a:t>
             </a:r>
             <a:endParaRPr lang="en-US" sz="900" dirty="0"/>
           </a:p>
@@ -2965,7 +3184,7 @@
           <a:bodyPr wrap="square" lIns="0" tIns="0" rIns="0" bIns="0" rtlCol="0" anchor="ctr"/>
           <a:lstStyle/>
           <a:p>
-            <a:pPr marL="0" indent="0" algn="r">
+            <a:pPr algn="r" indent="0" marL="0">
               <a:buNone/>
             </a:pPr>
             <a:r>
@@ -2999,7 +3218,6 @@
         <a:solidFill>
           <a:srgbClr val="F2F6F7"/>
         </a:solidFill>
-        <a:effectLst/>
       </p:bgPr>
     </p:bg>
     <p:spTree>
@@ -3037,11 +3255,11 @@
           <a:bodyPr wrap="square" lIns="0" tIns="0" rIns="0" bIns="0" rtlCol="0" anchor="ctr"/>
           <a:lstStyle/>
           <a:p>
-            <a:pPr marL="0" indent="0">
-              <a:buNone/>
-            </a:pPr>
-            <a:r>
-              <a:rPr lang="en-US" sz="1200" b="1" kern="0" spc="300" dirty="0">
+            <a:pPr indent="0" marL="0">
+              <a:buNone/>
+            </a:pPr>
+            <a:r>
+              <a:rPr lang="en-US" sz="1200" b="1" spc="300" kern="0" dirty="0">
                 <a:solidFill>
                   <a:srgbClr val="1FA598"/>
                 </a:solidFill>
@@ -3076,7 +3294,7 @@
           <a:bodyPr wrap="square" lIns="0" tIns="0" rIns="0" bIns="0" rtlCol="0" anchor="ctr"/>
           <a:lstStyle/>
           <a:p>
-            <a:pPr marL="0" indent="0">
+            <a:pPr indent="0" marL="0">
               <a:buNone/>
             </a:pPr>
             <a:r>
@@ -3115,7 +3333,7 @@
           <a:bodyPr wrap="square" lIns="0" tIns="0" rIns="0" bIns="0" rtlCol="0" anchor="ctr"/>
           <a:lstStyle/>
           <a:p>
-            <a:pPr marL="0" indent="0">
+            <a:pPr indent="0" marL="0">
               <a:buNone/>
             </a:pPr>
             <a:r>
@@ -3154,20 +3372,13 @@
           </a:solidFill>
           <a:ln/>
           <a:effectLst>
-            <a:outerShdw blurRad="114300" dist="38100" dir="5400000" algn="bl" rotWithShape="0">
+            <a:outerShdw sx="100000" sy="100000" kx="0" ky="0" algn="bl" rotWithShape="0" blurRad="114300" dist="38100" dir="5400000">
               <a:srgbClr val="0A2A31">
                 <a:alpha val="11000"/>
               </a:srgbClr>
             </a:outerShdw>
           </a:effectLst>
         </p:spPr>
-        <p:txBody>
-          <a:bodyPr/>
-          <a:lstStyle/>
-          <a:p>
-            <a:endParaRPr lang="en-CH"/>
-          </a:p>
-        </p:txBody>
       </p:sp>
       <p:sp>
         <p:nvSpPr>
@@ -3188,13 +3399,6 @@
           </a:solidFill>
           <a:ln/>
         </p:spPr>
-        <p:txBody>
-          <a:bodyPr/>
-          <a:lstStyle/>
-          <a:p>
-            <a:endParaRPr lang="en-CH"/>
-          </a:p>
-        </p:txBody>
       </p:sp>
       <p:sp>
         <p:nvSpPr>
@@ -3217,7 +3421,7 @@
           <a:bodyPr wrap="square" lIns="0" tIns="0" rIns="0" bIns="0" rtlCol="0" anchor="ctr"/>
           <a:lstStyle/>
           <a:p>
-            <a:pPr marL="0" indent="0" algn="ctr">
+            <a:pPr algn="ctr" indent="0" marL="0">
               <a:buNone/>
             </a:pPr>
             <a:r>
@@ -3256,7 +3460,7 @@
           <a:bodyPr wrap="square" lIns="0" tIns="0" rIns="0" bIns="0" rtlCol="0" anchor="ctr"/>
           <a:lstStyle/>
           <a:p>
-            <a:pPr marL="0" indent="0" algn="ctr">
+            <a:pPr algn="ctr" indent="0" marL="0">
               <a:lnSpc>
                 <a:spcPct val="95000"/>
               </a:lnSpc>
@@ -3298,7 +3502,7 @@
           <a:bodyPr wrap="square" lIns="0" tIns="0" rIns="0" bIns="0" rtlCol="0" anchor="ctr"/>
           <a:lstStyle/>
           <a:p>
-            <a:pPr marL="0" indent="0" algn="ctr">
+            <a:pPr algn="ctr" indent="0" marL="0">
               <a:lnSpc>
                 <a:spcPct val="102000"/>
               </a:lnSpc>
@@ -3340,7 +3544,7 @@
           <a:bodyPr wrap="square" lIns="0" tIns="0" rIns="0" bIns="0" rtlCol="0" anchor="ctr"/>
           <a:lstStyle/>
           <a:p>
-            <a:pPr marL="0" indent="0" algn="ctr">
+            <a:pPr algn="ctr" indent="0" marL="0">
               <a:buNone/>
             </a:pPr>
             <a:r>
@@ -3379,20 +3583,13 @@
           </a:solidFill>
           <a:ln/>
           <a:effectLst>
-            <a:outerShdw blurRad="114300" dist="38100" dir="5400000" algn="bl" rotWithShape="0">
+            <a:outerShdw sx="100000" sy="100000" kx="0" ky="0" algn="bl" rotWithShape="0" blurRad="114300" dist="38100" dir="5400000">
               <a:srgbClr val="0A2A31">
                 <a:alpha val="11000"/>
               </a:srgbClr>
             </a:outerShdw>
           </a:effectLst>
         </p:spPr>
-        <p:txBody>
-          <a:bodyPr/>
-          <a:lstStyle/>
-          <a:p>
-            <a:endParaRPr lang="en-CH"/>
-          </a:p>
-        </p:txBody>
       </p:sp>
       <p:sp>
         <p:nvSpPr>
@@ -3413,13 +3610,6 @@
           </a:solidFill>
           <a:ln/>
         </p:spPr>
-        <p:txBody>
-          <a:bodyPr/>
-          <a:lstStyle/>
-          <a:p>
-            <a:endParaRPr lang="en-CH"/>
-          </a:p>
-        </p:txBody>
       </p:sp>
       <p:sp>
         <p:nvSpPr>
@@ -3442,7 +3632,7 @@
           <a:bodyPr wrap="square" lIns="0" tIns="0" rIns="0" bIns="0" rtlCol="0" anchor="ctr"/>
           <a:lstStyle/>
           <a:p>
-            <a:pPr marL="0" indent="0" algn="ctr">
+            <a:pPr algn="ctr" indent="0" marL="0">
               <a:buNone/>
             </a:pPr>
             <a:r>
@@ -3481,7 +3671,7 @@
           <a:bodyPr wrap="square" lIns="0" tIns="0" rIns="0" bIns="0" rtlCol="0" anchor="ctr"/>
           <a:lstStyle/>
           <a:p>
-            <a:pPr marL="0" indent="0" algn="ctr">
+            <a:pPr algn="ctr" indent="0" marL="0">
               <a:lnSpc>
                 <a:spcPct val="95000"/>
               </a:lnSpc>
@@ -3523,7 +3713,7 @@
           <a:bodyPr wrap="square" lIns="0" tIns="0" rIns="0" bIns="0" rtlCol="0" anchor="ctr"/>
           <a:lstStyle/>
           <a:p>
-            <a:pPr marL="0" indent="0" algn="ctr">
+            <a:pPr algn="ctr" indent="0" marL="0">
               <a:lnSpc>
                 <a:spcPct val="102000"/>
               </a:lnSpc>
@@ -3565,7 +3755,7 @@
           <a:bodyPr wrap="square" lIns="0" tIns="0" rIns="0" bIns="0" rtlCol="0" anchor="ctr"/>
           <a:lstStyle/>
           <a:p>
-            <a:pPr marL="0" indent="0" algn="ctr">
+            <a:pPr algn="ctr" indent="0" marL="0">
               <a:buNone/>
             </a:pPr>
             <a:r>
@@ -3604,20 +3794,13 @@
           </a:solidFill>
           <a:ln/>
           <a:effectLst>
-            <a:outerShdw blurRad="114300" dist="38100" dir="5400000" algn="bl" rotWithShape="0">
+            <a:outerShdw sx="100000" sy="100000" kx="0" ky="0" algn="bl" rotWithShape="0" blurRad="114300" dist="38100" dir="5400000">
               <a:srgbClr val="0A2A31">
                 <a:alpha val="11000"/>
               </a:srgbClr>
             </a:outerShdw>
           </a:effectLst>
         </p:spPr>
-        <p:txBody>
-          <a:bodyPr/>
-          <a:lstStyle/>
-          <a:p>
-            <a:endParaRPr lang="en-CH"/>
-          </a:p>
-        </p:txBody>
       </p:sp>
       <p:sp>
         <p:nvSpPr>
@@ -3638,13 +3821,6 @@
           </a:solidFill>
           <a:ln/>
         </p:spPr>
-        <p:txBody>
-          <a:bodyPr/>
-          <a:lstStyle/>
-          <a:p>
-            <a:endParaRPr lang="en-CH"/>
-          </a:p>
-        </p:txBody>
       </p:sp>
       <p:sp>
         <p:nvSpPr>
@@ -3667,7 +3843,7 @@
           <a:bodyPr wrap="square" lIns="0" tIns="0" rIns="0" bIns="0" rtlCol="0" anchor="ctr"/>
           <a:lstStyle/>
           <a:p>
-            <a:pPr marL="0" indent="0" algn="ctr">
+            <a:pPr algn="ctr" indent="0" marL="0">
               <a:buNone/>
             </a:pPr>
             <a:r>
@@ -3706,7 +3882,7 @@
           <a:bodyPr wrap="square" lIns="0" tIns="0" rIns="0" bIns="0" rtlCol="0" anchor="ctr"/>
           <a:lstStyle/>
           <a:p>
-            <a:pPr marL="0" indent="0" algn="ctr">
+            <a:pPr algn="ctr" indent="0" marL="0">
               <a:lnSpc>
                 <a:spcPct val="95000"/>
               </a:lnSpc>
@@ -3748,7 +3924,7 @@
           <a:bodyPr wrap="square" lIns="0" tIns="0" rIns="0" bIns="0" rtlCol="0" anchor="ctr"/>
           <a:lstStyle/>
           <a:p>
-            <a:pPr marL="0" indent="0" algn="ctr">
+            <a:pPr algn="ctr" indent="0" marL="0">
               <a:lnSpc>
                 <a:spcPct val="102000"/>
               </a:lnSpc>
@@ -3790,7 +3966,7 @@
           <a:bodyPr wrap="square" lIns="0" tIns="0" rIns="0" bIns="0" rtlCol="0" anchor="ctr"/>
           <a:lstStyle/>
           <a:p>
-            <a:pPr marL="0" indent="0" algn="ctr">
+            <a:pPr algn="ctr" indent="0" marL="0">
               <a:buNone/>
             </a:pPr>
             <a:r>
@@ -3829,20 +4005,13 @@
           </a:solidFill>
           <a:ln/>
           <a:effectLst>
-            <a:outerShdw blurRad="114300" dist="38100" dir="5400000" algn="bl" rotWithShape="0">
+            <a:outerShdw sx="100000" sy="100000" kx="0" ky="0" algn="bl" rotWithShape="0" blurRad="114300" dist="38100" dir="5400000">
               <a:srgbClr val="0A2A31">
                 <a:alpha val="11000"/>
               </a:srgbClr>
             </a:outerShdw>
           </a:effectLst>
         </p:spPr>
-        <p:txBody>
-          <a:bodyPr/>
-          <a:lstStyle/>
-          <a:p>
-            <a:endParaRPr lang="en-CH"/>
-          </a:p>
-        </p:txBody>
       </p:sp>
       <p:sp>
         <p:nvSpPr>
@@ -3863,13 +4032,6 @@
           </a:solidFill>
           <a:ln/>
         </p:spPr>
-        <p:txBody>
-          <a:bodyPr/>
-          <a:lstStyle/>
-          <a:p>
-            <a:endParaRPr lang="en-CH"/>
-          </a:p>
-        </p:txBody>
       </p:sp>
       <p:sp>
         <p:nvSpPr>
@@ -3892,7 +4054,7 @@
           <a:bodyPr wrap="square" lIns="0" tIns="0" rIns="0" bIns="0" rtlCol="0" anchor="ctr"/>
           <a:lstStyle/>
           <a:p>
-            <a:pPr marL="0" indent="0" algn="ctr">
+            <a:pPr algn="ctr" indent="0" marL="0">
               <a:buNone/>
             </a:pPr>
             <a:r>
@@ -3931,7 +4093,7 @@
           <a:bodyPr wrap="square" lIns="0" tIns="0" rIns="0" bIns="0" rtlCol="0" anchor="ctr"/>
           <a:lstStyle/>
           <a:p>
-            <a:pPr marL="0" indent="0" algn="ctr">
+            <a:pPr algn="ctr" indent="0" marL="0">
               <a:lnSpc>
                 <a:spcPct val="95000"/>
               </a:lnSpc>
@@ -3973,7 +4135,7 @@
           <a:bodyPr wrap="square" lIns="0" tIns="0" rIns="0" bIns="0" rtlCol="0" anchor="ctr"/>
           <a:lstStyle/>
           <a:p>
-            <a:pPr marL="0" indent="0" algn="ctr">
+            <a:pPr algn="ctr" indent="0" marL="0">
               <a:lnSpc>
                 <a:spcPct val="102000"/>
               </a:lnSpc>
@@ -4015,7 +4177,7 @@
           <a:bodyPr wrap="square" lIns="0" tIns="0" rIns="0" bIns="0" rtlCol="0" anchor="ctr"/>
           <a:lstStyle/>
           <a:p>
-            <a:pPr marL="0" indent="0" algn="ctr">
+            <a:pPr algn="ctr" indent="0" marL="0">
               <a:buNone/>
             </a:pPr>
             <a:r>
@@ -4054,20 +4216,13 @@
           </a:solidFill>
           <a:ln/>
           <a:effectLst>
-            <a:outerShdw blurRad="114300" dist="38100" dir="5400000" algn="bl" rotWithShape="0">
+            <a:outerShdw sx="100000" sy="100000" kx="0" ky="0" algn="bl" rotWithShape="0" blurRad="114300" dist="38100" dir="5400000">
               <a:srgbClr val="0A2A31">
                 <a:alpha val="11000"/>
               </a:srgbClr>
             </a:outerShdw>
           </a:effectLst>
         </p:spPr>
-        <p:txBody>
-          <a:bodyPr/>
-          <a:lstStyle/>
-          <a:p>
-            <a:endParaRPr lang="en-CH"/>
-          </a:p>
-        </p:txBody>
       </p:sp>
       <p:sp>
         <p:nvSpPr>
@@ -4088,13 +4243,6 @@
           </a:solidFill>
           <a:ln/>
         </p:spPr>
-        <p:txBody>
-          <a:bodyPr/>
-          <a:lstStyle/>
-          <a:p>
-            <a:endParaRPr lang="en-CH"/>
-          </a:p>
-        </p:txBody>
       </p:sp>
       <p:sp>
         <p:nvSpPr>
@@ -4117,7 +4265,7 @@
           <a:bodyPr wrap="square" lIns="0" tIns="0" rIns="0" bIns="0" rtlCol="0" anchor="ctr"/>
           <a:lstStyle/>
           <a:p>
-            <a:pPr marL="0" indent="0" algn="ctr">
+            <a:pPr algn="ctr" indent="0" marL="0">
               <a:buNone/>
             </a:pPr>
             <a:r>
@@ -4156,7 +4304,7 @@
           <a:bodyPr wrap="square" lIns="0" tIns="0" rIns="0" bIns="0" rtlCol="0" anchor="ctr"/>
           <a:lstStyle/>
           <a:p>
-            <a:pPr marL="0" indent="0" algn="ctr">
+            <a:pPr algn="ctr" indent="0" marL="0">
               <a:lnSpc>
                 <a:spcPct val="95000"/>
               </a:lnSpc>
@@ -4198,7 +4346,7 @@
           <a:bodyPr wrap="square" lIns="0" tIns="0" rIns="0" bIns="0" rtlCol="0" anchor="ctr"/>
           <a:lstStyle/>
           <a:p>
-            <a:pPr marL="0" indent="0" algn="ctr">
+            <a:pPr algn="ctr" indent="0" marL="0">
               <a:lnSpc>
                 <a:spcPct val="102000"/>
               </a:lnSpc>
@@ -4240,20 +4388,13 @@
           </a:solidFill>
           <a:ln/>
           <a:effectLst>
-            <a:outerShdw blurRad="114300" dist="38100" dir="5400000" algn="bl" rotWithShape="0">
+            <a:outerShdw sx="100000" sy="100000" kx="0" ky="0" algn="bl" rotWithShape="0" blurRad="114300" dist="38100" dir="5400000">
               <a:srgbClr val="0A2A31">
                 <a:alpha val="11000"/>
               </a:srgbClr>
             </a:outerShdw>
           </a:effectLst>
         </p:spPr>
-        <p:txBody>
-          <a:bodyPr/>
-          <a:lstStyle/>
-          <a:p>
-            <a:endParaRPr lang="en-CH"/>
-          </a:p>
-        </p:txBody>
       </p:sp>
       <p:sp>
         <p:nvSpPr>
@@ -4276,7 +4417,7 @@
           <a:bodyPr wrap="square" lIns="0" tIns="0" rIns="0" bIns="0" rtlCol="0" anchor="ctr"/>
           <a:lstStyle/>
           <a:p>
-            <a:pPr marL="0" indent="0">
+            <a:pPr indent="0" marL="0">
               <a:lnSpc>
                 <a:spcPct val="105000"/>
               </a:lnSpc>
@@ -4293,6 +4434,12 @@
               </a:rPr>
               <a:t>Head start:  </a:t>
             </a:r>
+            <a:pPr indent="0" marL="0">
+              <a:lnSpc>
+                <a:spcPct val="105000"/>
+              </a:lnSpc>
+              <a:buNone/>
+            </a:pPr>
             <a:r>
               <a:rPr lang="en-US" sz="1400" dirty="0">
                 <a:solidFill>
@@ -4317,19 +4464,19 @@
         <p:spPr>
           <a:xfrm>
             <a:off x="548640" y="6473952"/>
-            <a:ext cx="4572000" cy="274320"/>
-          </a:xfrm>
-          <a:prstGeom prst="rect">
-            <a:avLst/>
-          </a:prstGeom>
-          <a:noFill/>
-          <a:ln/>
-        </p:spPr>
-        <p:txBody>
-          <a:bodyPr wrap="square" lIns="0" tIns="0" rIns="0" bIns="0" rtlCol="0" anchor="ctr"/>
-          <a:lstStyle/>
-          <a:p>
-            <a:pPr marL="0" indent="0" algn="l">
+            <a:ext cx="5486400" cy="274320"/>
+          </a:xfrm>
+          <a:prstGeom prst="rect">
+            <a:avLst/>
+          </a:prstGeom>
+          <a:noFill/>
+          <a:ln/>
+        </p:spPr>
+        <p:txBody>
+          <a:bodyPr wrap="square" lIns="0" tIns="0" rIns="0" bIns="0" rtlCol="0" anchor="ctr"/>
+          <a:lstStyle/>
+          <a:p>
+            <a:pPr algn="l" indent="0" marL="0">
               <a:buNone/>
             </a:pPr>
             <a:r>
@@ -4341,7 +4488,7 @@
                 <a:ea typeface="Calibri" pitchFamily="34" charset="-122"/>
                 <a:cs typeface="Calibri" pitchFamily="34" charset="-120"/>
               </a:rPr>
-              <a:t>AI Skills · Executive Briefing</a:t>
+              <a:t>Evidence-Appraisal Skill · an open explainer</a:t>
             </a:r>
             <a:endParaRPr lang="en-US" sz="900" dirty="0"/>
           </a:p>
@@ -4368,7 +4515,7 @@
           <a:bodyPr wrap="square" lIns="0" tIns="0" rIns="0" bIns="0" rtlCol="0" anchor="ctr"/>
           <a:lstStyle/>
           <a:p>
-            <a:pPr marL="0" indent="0" algn="r">
+            <a:pPr algn="r" indent="0" marL="0">
               <a:buNone/>
             </a:pPr>
             <a:r>
@@ -4402,7 +4549,6 @@
         <a:solidFill>
           <a:srgbClr val="0E2E36"/>
         </a:solidFill>
-        <a:effectLst/>
       </p:bgPr>
     </p:bg>
     <p:spTree>
@@ -4440,13 +4586,6 @@
           </a:solidFill>
           <a:ln/>
         </p:spPr>
-        <p:txBody>
-          <a:bodyPr/>
-          <a:lstStyle/>
-          <a:p>
-            <a:endParaRPr lang="en-CH"/>
-          </a:p>
-        </p:txBody>
       </p:sp>
       <p:sp>
         <p:nvSpPr>
@@ -4469,11 +4608,11 @@
           <a:bodyPr wrap="square" lIns="0" tIns="0" rIns="0" bIns="0" rtlCol="0" anchor="ctr"/>
           <a:lstStyle/>
           <a:p>
-            <a:pPr marL="0" indent="0">
-              <a:buNone/>
-            </a:pPr>
-            <a:r>
-              <a:rPr lang="en-US" sz="1300" b="1" kern="0" spc="300" dirty="0">
+            <a:pPr indent="0" marL="0">
+              <a:buNone/>
+            </a:pPr>
+            <a:r>
+              <a:rPr lang="en-US" sz="1300" b="1" spc="300" kern="0" dirty="0">
                 <a:solidFill>
                   <a:srgbClr val="1FA598"/>
                 </a:solidFill>
@@ -4508,7 +4647,7 @@
           <a:bodyPr wrap="square" lIns="0" tIns="0" rIns="0" bIns="0" rtlCol="0" anchor="ctr"/>
           <a:lstStyle/>
           <a:p>
-            <a:pPr marL="0" indent="0">
+            <a:pPr indent="0" marL="0">
               <a:buNone/>
             </a:pPr>
             <a:r>
@@ -4547,7 +4686,7 @@
           <a:bodyPr wrap="square" lIns="0" tIns="0" rIns="0" bIns="0" rtlCol="0" anchor="ctr"/>
           <a:lstStyle/>
           <a:p>
-            <a:pPr marL="0" indent="0">
+            <a:pPr indent="0" marL="0">
               <a:lnSpc>
                 <a:spcPct val="106000"/>
               </a:lnSpc>
@@ -4589,13 +4728,6 @@
           </a:solidFill>
           <a:ln/>
         </p:spPr>
-        <p:txBody>
-          <a:bodyPr/>
-          <a:lstStyle/>
-          <a:p>
-            <a:endParaRPr lang="en-CH"/>
-          </a:p>
-        </p:txBody>
       </p:sp>
       <p:sp>
         <p:nvSpPr>
@@ -4618,7 +4750,7 @@
           <a:bodyPr wrap="square" lIns="0" tIns="0" rIns="0" bIns="0" rtlCol="0" anchor="ctr"/>
           <a:lstStyle/>
           <a:p>
-            <a:pPr marL="0" indent="0">
+            <a:pPr indent="0" marL="0">
               <a:buNone/>
             </a:pPr>
             <a:r>
@@ -4657,7 +4789,7 @@
           <a:bodyPr wrap="square" lIns="0" tIns="0" rIns="0" bIns="0" rtlCol="0" anchor="ctr"/>
           <a:lstStyle/>
           <a:p>
-            <a:pPr marL="0" indent="0">
+            <a:pPr indent="0" marL="0">
               <a:lnSpc>
                 <a:spcPct val="105000"/>
               </a:lnSpc>
@@ -4699,13 +4831,6 @@
           </a:solidFill>
           <a:ln/>
         </p:spPr>
-        <p:txBody>
-          <a:bodyPr/>
-          <a:lstStyle/>
-          <a:p>
-            <a:endParaRPr lang="en-CH"/>
-          </a:p>
-        </p:txBody>
       </p:sp>
       <p:sp>
         <p:nvSpPr>
@@ -4728,7 +4853,7 @@
           <a:bodyPr wrap="square" lIns="0" tIns="0" rIns="0" bIns="0" rtlCol="0" anchor="ctr"/>
           <a:lstStyle/>
           <a:p>
-            <a:pPr marL="0" indent="0">
+            <a:pPr indent="0" marL="0">
               <a:buNone/>
             </a:pPr>
             <a:r>
@@ -4767,7 +4892,7 @@
           <a:bodyPr wrap="square" lIns="0" tIns="0" rIns="0" bIns="0" rtlCol="0" anchor="ctr"/>
           <a:lstStyle/>
           <a:p>
-            <a:pPr marL="0" indent="0">
+            <a:pPr indent="0" marL="0">
               <a:lnSpc>
                 <a:spcPct val="105000"/>
               </a:lnSpc>
@@ -4809,13 +4934,6 @@
           </a:solidFill>
           <a:ln/>
         </p:spPr>
-        <p:txBody>
-          <a:bodyPr/>
-          <a:lstStyle/>
-          <a:p>
-            <a:endParaRPr lang="en-CH"/>
-          </a:p>
-        </p:txBody>
       </p:sp>
       <p:sp>
         <p:nvSpPr>
@@ -4838,7 +4956,7 @@
           <a:bodyPr wrap="square" lIns="0" tIns="0" rIns="0" bIns="0" rtlCol="0" anchor="ctr"/>
           <a:lstStyle/>
           <a:p>
-            <a:pPr marL="0" indent="0">
+            <a:pPr indent="0" marL="0">
               <a:buNone/>
             </a:pPr>
             <a:r>
@@ -4877,7 +4995,7 @@
           <a:bodyPr wrap="square" lIns="0" tIns="0" rIns="0" bIns="0" rtlCol="0" anchor="ctr"/>
           <a:lstStyle/>
           <a:p>
-            <a:pPr marL="0" indent="0">
+            <a:pPr indent="0" marL="0">
               <a:lnSpc>
                 <a:spcPct val="105000"/>
               </a:lnSpc>
@@ -4919,13 +5037,6 @@
           </a:solidFill>
           <a:ln/>
         </p:spPr>
-        <p:txBody>
-          <a:bodyPr/>
-          <a:lstStyle/>
-          <a:p>
-            <a:endParaRPr lang="en-CH"/>
-          </a:p>
-        </p:txBody>
       </p:sp>
       <p:sp>
         <p:nvSpPr>
@@ -4948,7 +5059,7 @@
           <a:bodyPr wrap="square" lIns="0" tIns="0" rIns="0" bIns="0" rtlCol="0" anchor="ctr"/>
           <a:lstStyle/>
           <a:p>
-            <a:pPr marL="0" indent="0">
+            <a:pPr indent="0" marL="0">
               <a:buNone/>
             </a:pPr>
             <a:r>
@@ -4987,7 +5098,7 @@
           <a:bodyPr wrap="square" lIns="0" tIns="0" rIns="0" bIns="0" rtlCol="0" anchor="ctr"/>
           <a:lstStyle/>
           <a:p>
-            <a:pPr marL="0" indent="0">
+            <a:pPr indent="0" marL="0">
               <a:lnSpc>
                 <a:spcPct val="105000"/>
               </a:lnSpc>
@@ -5029,7 +5140,7 @@
           <a:bodyPr wrap="square" lIns="0" tIns="0" rIns="0" bIns="0" rtlCol="0" anchor="ctr"/>
           <a:lstStyle/>
           <a:p>
-            <a:pPr marL="0" indent="0">
+            <a:pPr indent="0" marL="0">
               <a:buNone/>
             </a:pPr>
             <a:r>
@@ -5043,6 +5154,9 @@
               </a:rPr>
               <a:t>Next steps:   </a:t>
             </a:r>
+            <a:pPr indent="0" marL="0">
+              <a:buNone/>
+            </a:pPr>
             <a:r>
               <a:rPr lang="en-US" sz="1500" dirty="0">
                 <a:solidFill>
@@ -5052,7 +5166,7 @@
                 <a:ea typeface="Calibri" pitchFamily="34" charset="-122"/>
                 <a:cs typeface="Calibri" pitchFamily="34" charset="-120"/>
               </a:rPr>
-              <a:t>pilot on live reviews  ·  assign a skill-library owner  ·  prioritise the next three workflows to encode</a:t>
+              <a:t>try it on a review  ·  adapt the checklists to your field  ·  share improvements back</a:t>
             </a:r>
             <a:endParaRPr lang="en-US" sz="1500" dirty="0"/>
           </a:p>
@@ -5079,7 +5193,7 @@
           <a:bodyPr wrap="square" lIns="0" tIns="0" rIns="0" bIns="0" rtlCol="0" anchor="ctr"/>
           <a:lstStyle/>
           <a:p>
-            <a:pPr marL="0" indent="0">
+            <a:pPr indent="0" marL="0">
               <a:buNone/>
             </a:pPr>
             <a:r>
@@ -5091,7 +5205,7 @@
                 <a:ea typeface="Calibri" pitchFamily="34" charset="-122"/>
                 <a:cs typeface="Calibri" pitchFamily="34" charset="-120"/>
               </a:rPr>
-              <a:t>Yvonne  ·  Health Economics &amp; Value  ·  Happy to demo it live</a:t>
+              <a:t>Yvonne  ·  Health Economics &amp; Value  ·  Open to feedback &amp; contributions</a:t>
             </a:r>
             <a:endParaRPr lang="en-US" sz="1200" dirty="0"/>
           </a:p>
@@ -5113,7 +5227,6 @@
         <a:solidFill>
           <a:srgbClr val="F2F6F7"/>
         </a:solidFill>
-        <a:effectLst/>
       </p:bgPr>
     </p:bg>
     <p:spTree>
@@ -5151,11 +5264,11 @@
           <a:bodyPr wrap="square" lIns="0" tIns="0" rIns="0" bIns="0" rtlCol="0" anchor="ctr"/>
           <a:lstStyle/>
           <a:p>
-            <a:pPr marL="0" indent="0">
-              <a:buNone/>
-            </a:pPr>
-            <a:r>
-              <a:rPr lang="en-US" sz="1200" b="1" kern="0" spc="300" dirty="0">
+            <a:pPr indent="0" marL="0">
+              <a:buNone/>
+            </a:pPr>
+            <a:r>
+              <a:rPr lang="en-US" sz="1200" b="1" spc="300" kern="0" dirty="0">
                 <a:solidFill>
                   <a:srgbClr val="1FA598"/>
                 </a:solidFill>
@@ -5190,7 +5303,7 @@
           <a:bodyPr wrap="square" lIns="0" tIns="0" rIns="0" bIns="0" rtlCol="0" anchor="ctr"/>
           <a:lstStyle/>
           <a:p>
-            <a:pPr marL="0" indent="0">
+            <a:pPr indent="0" marL="0">
               <a:buNone/>
             </a:pPr>
             <a:r>
@@ -5229,7 +5342,7 @@
           <a:bodyPr wrap="square" lIns="0" tIns="0" rIns="0" bIns="0" rtlCol="0" anchor="ctr"/>
           <a:lstStyle/>
           <a:p>
-            <a:pPr marL="0" indent="0">
+            <a:pPr indent="0" marL="0">
               <a:buNone/>
             </a:pPr>
             <a:r>
@@ -5268,20 +5381,13 @@
           </a:solidFill>
           <a:ln/>
           <a:effectLst>
-            <a:outerShdw blurRad="114300" dist="38100" dir="5400000" algn="bl" rotWithShape="0">
+            <a:outerShdw sx="100000" sy="100000" kx="0" ky="0" algn="bl" rotWithShape="0" blurRad="114300" dist="38100" dir="5400000">
               <a:srgbClr val="0A2A31">
                 <a:alpha val="11000"/>
               </a:srgbClr>
             </a:outerShdw>
           </a:effectLst>
         </p:spPr>
-        <p:txBody>
-          <a:bodyPr/>
-          <a:lstStyle/>
-          <a:p>
-            <a:endParaRPr lang="en-CH"/>
-          </a:p>
-        </p:txBody>
       </p:sp>
       <p:sp>
         <p:nvSpPr>
@@ -5302,13 +5408,6 @@
           </a:solidFill>
           <a:ln/>
         </p:spPr>
-        <p:txBody>
-          <a:bodyPr/>
-          <a:lstStyle/>
-          <a:p>
-            <a:endParaRPr lang="en-CH"/>
-          </a:p>
-        </p:txBody>
       </p:sp>
       <p:sp>
         <p:nvSpPr>
@@ -5331,7 +5430,7 @@
           <a:bodyPr wrap="square" lIns="0" tIns="0" rIns="0" bIns="0" rtlCol="0" anchor="ctr"/>
           <a:lstStyle/>
           <a:p>
-            <a:pPr marL="0" indent="0" algn="ctr">
+            <a:pPr algn="ctr" indent="0" marL="0">
               <a:buNone/>
             </a:pPr>
             <a:r>
@@ -5370,7 +5469,7 @@
           <a:bodyPr wrap="square" lIns="0" tIns="0" rIns="0" bIns="0" rtlCol="0" anchor="ctr"/>
           <a:lstStyle/>
           <a:p>
-            <a:pPr marL="0" indent="0">
+            <a:pPr indent="0" marL="0">
               <a:buNone/>
             </a:pPr>
             <a:r>
@@ -5409,7 +5508,7 @@
           <a:bodyPr wrap="square" lIns="0" tIns="0" rIns="0" bIns="0" rtlCol="0" anchor="ctr"/>
           <a:lstStyle/>
           <a:p>
-            <a:pPr marL="0" indent="0">
+            <a:pPr indent="0" marL="0">
               <a:lnSpc>
                 <a:spcPct val="103000"/>
               </a:lnSpc>
@@ -5451,20 +5550,13 @@
           </a:solidFill>
           <a:ln/>
           <a:effectLst>
-            <a:outerShdw blurRad="114300" dist="38100" dir="5400000" algn="bl" rotWithShape="0">
+            <a:outerShdw sx="100000" sy="100000" kx="0" ky="0" algn="bl" rotWithShape="0" blurRad="114300" dist="38100" dir="5400000">
               <a:srgbClr val="0A2A31">
                 <a:alpha val="11000"/>
               </a:srgbClr>
             </a:outerShdw>
           </a:effectLst>
         </p:spPr>
-        <p:txBody>
-          <a:bodyPr/>
-          <a:lstStyle/>
-          <a:p>
-            <a:endParaRPr lang="en-CH"/>
-          </a:p>
-        </p:txBody>
       </p:sp>
       <p:sp>
         <p:nvSpPr>
@@ -5485,13 +5577,6 @@
           </a:solidFill>
           <a:ln/>
         </p:spPr>
-        <p:txBody>
-          <a:bodyPr/>
-          <a:lstStyle/>
-          <a:p>
-            <a:endParaRPr lang="en-CH"/>
-          </a:p>
-        </p:txBody>
       </p:sp>
       <p:sp>
         <p:nvSpPr>
@@ -5514,7 +5599,7 @@
           <a:bodyPr wrap="square" lIns="0" tIns="0" rIns="0" bIns="0" rtlCol="0" anchor="ctr"/>
           <a:lstStyle/>
           <a:p>
-            <a:pPr marL="0" indent="0" algn="ctr">
+            <a:pPr algn="ctr" indent="0" marL="0">
               <a:buNone/>
             </a:pPr>
             <a:r>
@@ -5553,7 +5638,7 @@
           <a:bodyPr wrap="square" lIns="0" tIns="0" rIns="0" bIns="0" rtlCol="0" anchor="ctr"/>
           <a:lstStyle/>
           <a:p>
-            <a:pPr marL="0" indent="0">
+            <a:pPr indent="0" marL="0">
               <a:buNone/>
             </a:pPr>
             <a:r>
@@ -5592,7 +5677,7 @@
           <a:bodyPr wrap="square" lIns="0" tIns="0" rIns="0" bIns="0" rtlCol="0" anchor="ctr"/>
           <a:lstStyle/>
           <a:p>
-            <a:pPr marL="0" indent="0">
+            <a:pPr indent="0" marL="0">
               <a:lnSpc>
                 <a:spcPct val="103000"/>
               </a:lnSpc>
@@ -5634,20 +5719,13 @@
           </a:solidFill>
           <a:ln/>
           <a:effectLst>
-            <a:outerShdw blurRad="114300" dist="38100" dir="5400000" algn="bl" rotWithShape="0">
+            <a:outerShdw sx="100000" sy="100000" kx="0" ky="0" algn="bl" rotWithShape="0" blurRad="114300" dist="38100" dir="5400000">
               <a:srgbClr val="0A2A31">
                 <a:alpha val="11000"/>
               </a:srgbClr>
             </a:outerShdw>
           </a:effectLst>
         </p:spPr>
-        <p:txBody>
-          <a:bodyPr/>
-          <a:lstStyle/>
-          <a:p>
-            <a:endParaRPr lang="en-CH"/>
-          </a:p>
-        </p:txBody>
       </p:sp>
       <p:sp>
         <p:nvSpPr>
@@ -5668,13 +5746,6 @@
           </a:solidFill>
           <a:ln/>
         </p:spPr>
-        <p:txBody>
-          <a:bodyPr/>
-          <a:lstStyle/>
-          <a:p>
-            <a:endParaRPr lang="en-CH"/>
-          </a:p>
-        </p:txBody>
       </p:sp>
       <p:sp>
         <p:nvSpPr>
@@ -5697,7 +5768,7 @@
           <a:bodyPr wrap="square" lIns="0" tIns="0" rIns="0" bIns="0" rtlCol="0" anchor="ctr"/>
           <a:lstStyle/>
           <a:p>
-            <a:pPr marL="0" indent="0" algn="ctr">
+            <a:pPr algn="ctr" indent="0" marL="0">
               <a:buNone/>
             </a:pPr>
             <a:r>
@@ -5736,7 +5807,7 @@
           <a:bodyPr wrap="square" lIns="0" tIns="0" rIns="0" bIns="0" rtlCol="0" anchor="ctr"/>
           <a:lstStyle/>
           <a:p>
-            <a:pPr marL="0" indent="0">
+            <a:pPr indent="0" marL="0">
               <a:buNone/>
             </a:pPr>
             <a:r>
@@ -5775,7 +5846,7 @@
           <a:bodyPr wrap="square" lIns="0" tIns="0" rIns="0" bIns="0" rtlCol="0" anchor="ctr"/>
           <a:lstStyle/>
           <a:p>
-            <a:pPr marL="0" indent="0">
+            <a:pPr indent="0" marL="0">
               <a:lnSpc>
                 <a:spcPct val="103000"/>
               </a:lnSpc>
@@ -5817,20 +5888,13 @@
           </a:solidFill>
           <a:ln/>
           <a:effectLst>
-            <a:outerShdw blurRad="114300" dist="38100" dir="5400000" algn="bl" rotWithShape="0">
+            <a:outerShdw sx="100000" sy="100000" kx="0" ky="0" algn="bl" rotWithShape="0" blurRad="114300" dist="38100" dir="5400000">
               <a:srgbClr val="0A2A31">
                 <a:alpha val="11000"/>
               </a:srgbClr>
             </a:outerShdw>
           </a:effectLst>
         </p:spPr>
-        <p:txBody>
-          <a:bodyPr/>
-          <a:lstStyle/>
-          <a:p>
-            <a:endParaRPr lang="en-CH"/>
-          </a:p>
-        </p:txBody>
       </p:sp>
       <p:sp>
         <p:nvSpPr>
@@ -5853,7 +5917,7 @@
           <a:bodyPr wrap="square" lIns="0" tIns="0" rIns="0" bIns="0" rtlCol="0" anchor="ctr"/>
           <a:lstStyle/>
           <a:p>
-            <a:pPr marL="0" indent="0">
+            <a:pPr indent="0" marL="0">
               <a:lnSpc>
                 <a:spcPct val="105000"/>
               </a:lnSpc>
@@ -5870,6 +5934,12 @@
               </a:rPr>
               <a:t>Think of it as a Standard Operating Procedure the AI follows</a:t>
             </a:r>
+            <a:pPr indent="0" marL="0">
+              <a:lnSpc>
+                <a:spcPct val="105000"/>
+              </a:lnSpc>
+              <a:buNone/>
+            </a:pPr>
             <a:r>
               <a:rPr lang="en-US" sz="1500" dirty="0">
                 <a:solidFill>
@@ -5894,19 +5964,19 @@
         <p:spPr>
           <a:xfrm>
             <a:off x="548640" y="6473952"/>
-            <a:ext cx="4572000" cy="274320"/>
-          </a:xfrm>
-          <a:prstGeom prst="rect">
-            <a:avLst/>
-          </a:prstGeom>
-          <a:noFill/>
-          <a:ln/>
-        </p:spPr>
-        <p:txBody>
-          <a:bodyPr wrap="square" lIns="0" tIns="0" rIns="0" bIns="0" rtlCol="0" anchor="ctr"/>
-          <a:lstStyle/>
-          <a:p>
-            <a:pPr marL="0" indent="0" algn="l">
+            <a:ext cx="5486400" cy="274320"/>
+          </a:xfrm>
+          <a:prstGeom prst="rect">
+            <a:avLst/>
+          </a:prstGeom>
+          <a:noFill/>
+          <a:ln/>
+        </p:spPr>
+        <p:txBody>
+          <a:bodyPr wrap="square" lIns="0" tIns="0" rIns="0" bIns="0" rtlCol="0" anchor="ctr"/>
+          <a:lstStyle/>
+          <a:p>
+            <a:pPr algn="l" indent="0" marL="0">
               <a:buNone/>
             </a:pPr>
             <a:r>
@@ -5918,7 +5988,7 @@
                 <a:ea typeface="Calibri" pitchFamily="34" charset="-122"/>
                 <a:cs typeface="Calibri" pitchFamily="34" charset="-120"/>
               </a:rPr>
-              <a:t>AI Skills · Executive Briefing</a:t>
+              <a:t>Evidence-Appraisal Skill · an open explainer</a:t>
             </a:r>
             <a:endParaRPr lang="en-US" sz="900" dirty="0"/>
           </a:p>
@@ -5945,7 +6015,7 @@
           <a:bodyPr wrap="square" lIns="0" tIns="0" rIns="0" bIns="0" rtlCol="0" anchor="ctr"/>
           <a:lstStyle/>
           <a:p>
-            <a:pPr marL="0" indent="0" algn="r">
+            <a:pPr algn="r" indent="0" marL="0">
               <a:buNone/>
             </a:pPr>
             <a:r>
@@ -5979,7 +6049,6 @@
         <a:solidFill>
           <a:srgbClr val="F2F6F7"/>
         </a:solidFill>
-        <a:effectLst/>
       </p:bgPr>
     </p:bg>
     <p:spTree>
@@ -6017,11 +6086,11 @@
           <a:bodyPr wrap="square" lIns="0" tIns="0" rIns="0" bIns="0" rtlCol="0" anchor="ctr"/>
           <a:lstStyle/>
           <a:p>
-            <a:pPr marL="0" indent="0">
-              <a:buNone/>
-            </a:pPr>
-            <a:r>
-              <a:rPr lang="en-US" sz="1200" b="1" kern="0" spc="300" dirty="0">
+            <a:pPr indent="0" marL="0">
+              <a:buNone/>
+            </a:pPr>
+            <a:r>
+              <a:rPr lang="en-US" sz="1200" b="1" spc="300" kern="0" dirty="0">
                 <a:solidFill>
                   <a:srgbClr val="1FA598"/>
                 </a:solidFill>
@@ -6056,7 +6125,7 @@
           <a:bodyPr wrap="square" lIns="0" tIns="0" rIns="0" bIns="0" rtlCol="0" anchor="ctr"/>
           <a:lstStyle/>
           <a:p>
-            <a:pPr marL="0" indent="0">
+            <a:pPr indent="0" marL="0">
               <a:buNone/>
             </a:pPr>
             <a:r>
@@ -6095,20 +6164,13 @@
           </a:solidFill>
           <a:ln/>
           <a:effectLst>
-            <a:outerShdw blurRad="114300" dist="38100" dir="5400000" algn="bl" rotWithShape="0">
+            <a:outerShdw sx="100000" sy="100000" kx="0" ky="0" algn="bl" rotWithShape="0" blurRad="114300" dist="38100" dir="5400000">
               <a:srgbClr val="0A2A31">
                 <a:alpha val="11000"/>
               </a:srgbClr>
             </a:outerShdw>
           </a:effectLst>
         </p:spPr>
-        <p:txBody>
-          <a:bodyPr/>
-          <a:lstStyle/>
-          <a:p>
-            <a:endParaRPr lang="en-CH"/>
-          </a:p>
-        </p:txBody>
       </p:sp>
       <p:sp>
         <p:nvSpPr>
@@ -6131,7 +6193,7 @@
           <a:bodyPr wrap="square" lIns="0" tIns="0" rIns="0" bIns="0" rtlCol="0" anchor="ctr"/>
           <a:lstStyle/>
           <a:p>
-            <a:pPr marL="0" indent="0">
+            <a:pPr indent="0" marL="0">
               <a:buNone/>
             </a:pPr>
             <a:r>
@@ -6170,7 +6232,7 @@
           <a:bodyPr wrap="square" lIns="0" tIns="0" rIns="0" bIns="0" rtlCol="0" anchor="ctr"/>
           <a:lstStyle/>
           <a:p>
-            <a:pPr marL="0" indent="0">
+            <a:pPr indent="0" marL="0">
               <a:lnSpc>
                 <a:spcPct val="105000"/>
               </a:lnSpc>
@@ -6212,20 +6274,13 @@
           </a:solidFill>
           <a:ln/>
           <a:effectLst>
-            <a:outerShdw blurRad="114300" dist="38100" dir="5400000" algn="bl" rotWithShape="0">
+            <a:outerShdw sx="100000" sy="100000" kx="0" ky="0" algn="bl" rotWithShape="0" blurRad="114300" dist="38100" dir="5400000">
               <a:srgbClr val="0A2A31">
                 <a:alpha val="11000"/>
               </a:srgbClr>
             </a:outerShdw>
           </a:effectLst>
         </p:spPr>
-        <p:txBody>
-          <a:bodyPr/>
-          <a:lstStyle/>
-          <a:p>
-            <a:endParaRPr lang="en-CH"/>
-          </a:p>
-        </p:txBody>
       </p:sp>
       <p:sp>
         <p:nvSpPr>
@@ -6248,7 +6303,7 @@
           <a:bodyPr wrap="square" lIns="0" tIns="0" rIns="0" bIns="0" rtlCol="0" anchor="ctr"/>
           <a:lstStyle/>
           <a:p>
-            <a:pPr marL="0" indent="0">
+            <a:pPr indent="0" marL="0">
               <a:buNone/>
             </a:pPr>
             <a:r>
@@ -6287,7 +6342,7 @@
           <a:bodyPr wrap="square" lIns="0" tIns="0" rIns="0" bIns="0" rtlCol="0" anchor="ctr"/>
           <a:lstStyle/>
           <a:p>
-            <a:pPr marL="0" indent="0">
+            <a:pPr indent="0" marL="0">
               <a:lnSpc>
                 <a:spcPct val="105000"/>
               </a:lnSpc>
@@ -6329,20 +6384,13 @@
           </a:solidFill>
           <a:ln/>
           <a:effectLst>
-            <a:outerShdw blurRad="114300" dist="38100" dir="5400000" algn="bl" rotWithShape="0">
+            <a:outerShdw sx="100000" sy="100000" kx="0" ky="0" algn="bl" rotWithShape="0" blurRad="114300" dist="38100" dir="5400000">
               <a:srgbClr val="0A2A31">
                 <a:alpha val="11000"/>
               </a:srgbClr>
             </a:outerShdw>
           </a:effectLst>
         </p:spPr>
-        <p:txBody>
-          <a:bodyPr/>
-          <a:lstStyle/>
-          <a:p>
-            <a:endParaRPr lang="en-CH"/>
-          </a:p>
-        </p:txBody>
       </p:sp>
       <p:sp>
         <p:nvSpPr>
@@ -6365,7 +6413,7 @@
           <a:bodyPr wrap="square" lIns="0" tIns="0" rIns="0" bIns="0" rtlCol="0" anchor="ctr"/>
           <a:lstStyle/>
           <a:p>
-            <a:pPr marL="0" indent="0">
+            <a:pPr indent="0" marL="0">
               <a:buNone/>
             </a:pPr>
             <a:r>
@@ -6404,7 +6452,7 @@
           <a:bodyPr wrap="square" lIns="0" tIns="0" rIns="0" bIns="0" rtlCol="0" anchor="ctr"/>
           <a:lstStyle/>
           <a:p>
-            <a:pPr marL="0" indent="0">
+            <a:pPr indent="0" marL="0">
               <a:lnSpc>
                 <a:spcPct val="105000"/>
               </a:lnSpc>
@@ -6446,20 +6494,13 @@
           </a:solidFill>
           <a:ln/>
           <a:effectLst>
-            <a:outerShdw blurRad="114300" dist="38100" dir="5400000" algn="bl" rotWithShape="0">
+            <a:outerShdw sx="100000" sy="100000" kx="0" ky="0" algn="bl" rotWithShape="0" blurRad="114300" dist="38100" dir="5400000">
               <a:srgbClr val="0A2A31">
                 <a:alpha val="11000"/>
               </a:srgbClr>
             </a:outerShdw>
           </a:effectLst>
         </p:spPr>
-        <p:txBody>
-          <a:bodyPr/>
-          <a:lstStyle/>
-          <a:p>
-            <a:endParaRPr lang="en-CH"/>
-          </a:p>
-        </p:txBody>
       </p:sp>
       <p:sp>
         <p:nvSpPr>
@@ -6482,7 +6523,7 @@
           <a:bodyPr wrap="square" lIns="0" tIns="0" rIns="0" bIns="0" rtlCol="0" anchor="ctr"/>
           <a:lstStyle/>
           <a:p>
-            <a:pPr marL="0" indent="0">
+            <a:pPr indent="0" marL="0">
               <a:buNone/>
             </a:pPr>
             <a:r>
@@ -6521,7 +6562,7 @@
           <a:bodyPr wrap="square" lIns="0" tIns="0" rIns="0" bIns="0" rtlCol="0" anchor="ctr"/>
           <a:lstStyle/>
           <a:p>
-            <a:pPr marL="0" indent="0">
+            <a:pPr indent="0" marL="0">
               <a:lnSpc>
                 <a:spcPct val="105000"/>
               </a:lnSpc>
@@ -6563,7 +6604,7 @@
           <a:bodyPr wrap="square" lIns="0" tIns="0" rIns="0" bIns="0" rtlCol="0" anchor="ctr"/>
           <a:lstStyle/>
           <a:p>
-            <a:pPr marL="0" indent="0" algn="ctr">
+            <a:pPr algn="ctr" indent="0" marL="0">
               <a:buNone/>
             </a:pPr>
             <a:r>
@@ -6577,6 +6618,9 @@
               </a:rPr>
               <a:t>Bottom line:  </a:t>
             </a:r>
+            <a:pPr algn="ctr" indent="0" marL="0">
+              <a:buNone/>
+            </a:pPr>
             <a:r>
               <a:rPr lang="en-US" sz="1500" i="1" dirty="0">
                 <a:solidFill>
@@ -6601,19 +6645,19 @@
         <p:spPr>
           <a:xfrm>
             <a:off x="548640" y="6473952"/>
-            <a:ext cx="4572000" cy="274320"/>
-          </a:xfrm>
-          <a:prstGeom prst="rect">
-            <a:avLst/>
-          </a:prstGeom>
-          <a:noFill/>
-          <a:ln/>
-        </p:spPr>
-        <p:txBody>
-          <a:bodyPr wrap="square" lIns="0" tIns="0" rIns="0" bIns="0" rtlCol="0" anchor="ctr"/>
-          <a:lstStyle/>
-          <a:p>
-            <a:pPr marL="0" indent="0" algn="l">
+            <a:ext cx="5486400" cy="274320"/>
+          </a:xfrm>
+          <a:prstGeom prst="rect">
+            <a:avLst/>
+          </a:prstGeom>
+          <a:noFill/>
+          <a:ln/>
+        </p:spPr>
+        <p:txBody>
+          <a:bodyPr wrap="square" lIns="0" tIns="0" rIns="0" bIns="0" rtlCol="0" anchor="ctr"/>
+          <a:lstStyle/>
+          <a:p>
+            <a:pPr algn="l" indent="0" marL="0">
               <a:buNone/>
             </a:pPr>
             <a:r>
@@ -6625,7 +6669,7 @@
                 <a:ea typeface="Calibri" pitchFamily="34" charset="-122"/>
                 <a:cs typeface="Calibri" pitchFamily="34" charset="-120"/>
               </a:rPr>
-              <a:t>AI Skills · Executive Briefing</a:t>
+              <a:t>Evidence-Appraisal Skill · an open explainer</a:t>
             </a:r>
             <a:endParaRPr lang="en-US" sz="900" dirty="0"/>
           </a:p>
@@ -6652,7 +6696,7 @@
           <a:bodyPr wrap="square" lIns="0" tIns="0" rIns="0" bIns="0" rtlCol="0" anchor="ctr"/>
           <a:lstStyle/>
           <a:p>
-            <a:pPr marL="0" indent="0" algn="r">
+            <a:pPr algn="r" indent="0" marL="0">
               <a:buNone/>
             </a:pPr>
             <a:r>
@@ -6686,7 +6730,6 @@
         <a:solidFill>
           <a:srgbClr val="F2F6F7"/>
         </a:solidFill>
-        <a:effectLst/>
       </p:bgPr>
     </p:bg>
     <p:spTree>
@@ -6724,11 +6767,11 @@
           <a:bodyPr wrap="square" lIns="0" tIns="0" rIns="0" bIns="0" rtlCol="0" anchor="ctr"/>
           <a:lstStyle/>
           <a:p>
-            <a:pPr marL="0" indent="0">
-              <a:buNone/>
-            </a:pPr>
-            <a:r>
-              <a:rPr lang="en-US" sz="1200" b="1" kern="0" spc="300" dirty="0">
+            <a:pPr indent="0" marL="0">
+              <a:buNone/>
+            </a:pPr>
+            <a:r>
+              <a:rPr lang="en-US" sz="1200" b="1" spc="300" kern="0" dirty="0">
                 <a:solidFill>
                   <a:srgbClr val="C67A22"/>
                 </a:solidFill>
@@ -6763,7 +6806,7 @@
           <a:bodyPr wrap="square" lIns="0" tIns="0" rIns="0" bIns="0" rtlCol="0" anchor="ctr"/>
           <a:lstStyle/>
           <a:p>
-            <a:pPr marL="0" indent="0">
+            <a:pPr indent="0" marL="0">
               <a:buNone/>
             </a:pPr>
             <a:r>
@@ -6802,20 +6845,13 @@
           </a:solidFill>
           <a:ln/>
           <a:effectLst>
-            <a:outerShdw blurRad="114300" dist="38100" dir="5400000" algn="bl" rotWithShape="0">
+            <a:outerShdw sx="100000" sy="100000" kx="0" ky="0" algn="bl" rotWithShape="0" blurRad="114300" dist="38100" dir="5400000">
               <a:srgbClr val="0A2A31">
                 <a:alpha val="11000"/>
               </a:srgbClr>
             </a:outerShdw>
           </a:effectLst>
         </p:spPr>
-        <p:txBody>
-          <a:bodyPr/>
-          <a:lstStyle/>
-          <a:p>
-            <a:endParaRPr lang="en-CH"/>
-          </a:p>
-        </p:txBody>
       </p:sp>
       <p:sp>
         <p:nvSpPr>
@@ -6838,7 +6874,7 @@
           <a:bodyPr wrap="square" lIns="0" tIns="0" rIns="0" bIns="0" rtlCol="0" anchor="ctr"/>
           <a:lstStyle/>
           <a:p>
-            <a:pPr marL="0" indent="0">
+            <a:pPr indent="0" marL="0">
               <a:lnSpc>
                 <a:spcPct val="98000"/>
               </a:lnSpc>
@@ -6880,7 +6916,7 @@
           <a:bodyPr wrap="square" lIns="0" tIns="0" rIns="0" bIns="0" rtlCol="0" anchor="ctr"/>
           <a:lstStyle/>
           <a:p>
-            <a:pPr marL="0" indent="0">
+            <a:pPr indent="0" marL="0">
               <a:lnSpc>
                 <a:spcPct val="105000"/>
               </a:lnSpc>
@@ -6922,20 +6958,13 @@
           </a:solidFill>
           <a:ln/>
           <a:effectLst>
-            <a:outerShdw blurRad="114300" dist="38100" dir="5400000" algn="bl" rotWithShape="0">
+            <a:outerShdw sx="100000" sy="100000" kx="0" ky="0" algn="bl" rotWithShape="0" blurRad="114300" dist="38100" dir="5400000">
               <a:srgbClr val="0A2A31">
                 <a:alpha val="11000"/>
               </a:srgbClr>
             </a:outerShdw>
           </a:effectLst>
         </p:spPr>
-        <p:txBody>
-          <a:bodyPr/>
-          <a:lstStyle/>
-          <a:p>
-            <a:endParaRPr lang="en-CH"/>
-          </a:p>
-        </p:txBody>
       </p:sp>
       <p:sp>
         <p:nvSpPr>
@@ -6958,7 +6987,7 @@
           <a:bodyPr wrap="square" lIns="0" tIns="0" rIns="0" bIns="0" rtlCol="0" anchor="ctr"/>
           <a:lstStyle/>
           <a:p>
-            <a:pPr marL="0" indent="0">
+            <a:pPr indent="0" marL="0">
               <a:lnSpc>
                 <a:spcPct val="98000"/>
               </a:lnSpc>
@@ -7000,7 +7029,7 @@
           <a:bodyPr wrap="square" lIns="0" tIns="0" rIns="0" bIns="0" rtlCol="0" anchor="ctr"/>
           <a:lstStyle/>
           <a:p>
-            <a:pPr marL="0" indent="0">
+            <a:pPr indent="0" marL="0">
               <a:lnSpc>
                 <a:spcPct val="105000"/>
               </a:lnSpc>
@@ -7042,20 +7071,13 @@
           </a:solidFill>
           <a:ln/>
           <a:effectLst>
-            <a:outerShdw blurRad="114300" dist="38100" dir="5400000" algn="bl" rotWithShape="0">
+            <a:outerShdw sx="100000" sy="100000" kx="0" ky="0" algn="bl" rotWithShape="0" blurRad="114300" dist="38100" dir="5400000">
               <a:srgbClr val="0A2A31">
                 <a:alpha val="11000"/>
               </a:srgbClr>
             </a:outerShdw>
           </a:effectLst>
         </p:spPr>
-        <p:txBody>
-          <a:bodyPr/>
-          <a:lstStyle/>
-          <a:p>
-            <a:endParaRPr lang="en-CH"/>
-          </a:p>
-        </p:txBody>
       </p:sp>
       <p:sp>
         <p:nvSpPr>
@@ -7078,7 +7100,7 @@
           <a:bodyPr wrap="square" lIns="0" tIns="0" rIns="0" bIns="0" rtlCol="0" anchor="ctr"/>
           <a:lstStyle/>
           <a:p>
-            <a:pPr marL="0" indent="0">
+            <a:pPr indent="0" marL="0">
               <a:lnSpc>
                 <a:spcPct val="98000"/>
               </a:lnSpc>
@@ -7120,7 +7142,7 @@
           <a:bodyPr wrap="square" lIns="0" tIns="0" rIns="0" bIns="0" rtlCol="0" anchor="ctr"/>
           <a:lstStyle/>
           <a:p>
-            <a:pPr marL="0" indent="0">
+            <a:pPr indent="0" marL="0">
               <a:lnSpc>
                 <a:spcPct val="105000"/>
               </a:lnSpc>
@@ -7162,20 +7184,13 @@
           </a:solidFill>
           <a:ln/>
           <a:effectLst>
-            <a:outerShdw blurRad="114300" dist="38100" dir="5400000" algn="bl" rotWithShape="0">
+            <a:outerShdw sx="100000" sy="100000" kx="0" ky="0" algn="bl" rotWithShape="0" blurRad="114300" dist="38100" dir="5400000">
               <a:srgbClr val="0A2A31">
                 <a:alpha val="11000"/>
               </a:srgbClr>
             </a:outerShdw>
           </a:effectLst>
         </p:spPr>
-        <p:txBody>
-          <a:bodyPr/>
-          <a:lstStyle/>
-          <a:p>
-            <a:endParaRPr lang="en-CH"/>
-          </a:p>
-        </p:txBody>
       </p:sp>
       <p:sp>
         <p:nvSpPr>
@@ -7198,7 +7213,7 @@
           <a:bodyPr wrap="square" lIns="0" tIns="0" rIns="0" bIns="0" rtlCol="0" anchor="ctr"/>
           <a:lstStyle/>
           <a:p>
-            <a:pPr marL="0" indent="0" algn="ctr">
+            <a:pPr algn="ctr" indent="0" marL="0">
               <a:buNone/>
             </a:pPr>
             <a:r>
@@ -7237,7 +7252,7 @@
           <a:bodyPr wrap="square" lIns="0" tIns="0" rIns="0" bIns="0" rtlCol="0" anchor="ctr"/>
           <a:lstStyle/>
           <a:p>
-            <a:pPr marL="0" indent="0">
+            <a:pPr indent="0" marL="0">
               <a:lnSpc>
                 <a:spcPct val="108000"/>
               </a:lnSpc>
@@ -7257,7 +7272,7 @@
             <a:endParaRPr lang="en-US" sz="1500" dirty="0"/>
           </a:p>
           <a:p>
-            <a:pPr marL="0" indent="0">
+            <a:pPr indent="0" marL="0">
               <a:lnSpc>
                 <a:spcPct val="108000"/>
               </a:lnSpc>
@@ -7287,19 +7302,19 @@
         <p:spPr>
           <a:xfrm>
             <a:off x="548640" y="6473952"/>
-            <a:ext cx="4572000" cy="274320"/>
-          </a:xfrm>
-          <a:prstGeom prst="rect">
-            <a:avLst/>
-          </a:prstGeom>
-          <a:noFill/>
-          <a:ln/>
-        </p:spPr>
-        <p:txBody>
-          <a:bodyPr wrap="square" lIns="0" tIns="0" rIns="0" bIns="0" rtlCol="0" anchor="ctr"/>
-          <a:lstStyle/>
-          <a:p>
-            <a:pPr marL="0" indent="0" algn="l">
+            <a:ext cx="5486400" cy="274320"/>
+          </a:xfrm>
+          <a:prstGeom prst="rect">
+            <a:avLst/>
+          </a:prstGeom>
+          <a:noFill/>
+          <a:ln/>
+        </p:spPr>
+        <p:txBody>
+          <a:bodyPr wrap="square" lIns="0" tIns="0" rIns="0" bIns="0" rtlCol="0" anchor="ctr"/>
+          <a:lstStyle/>
+          <a:p>
+            <a:pPr algn="l" indent="0" marL="0">
               <a:buNone/>
             </a:pPr>
             <a:r>
@@ -7311,7 +7326,7 @@
                 <a:ea typeface="Calibri" pitchFamily="34" charset="-122"/>
                 <a:cs typeface="Calibri" pitchFamily="34" charset="-120"/>
               </a:rPr>
-              <a:t>AI Skills · Executive Briefing</a:t>
+              <a:t>Evidence-Appraisal Skill · an open explainer</a:t>
             </a:r>
             <a:endParaRPr lang="en-US" sz="900" dirty="0"/>
           </a:p>
@@ -7338,7 +7353,7 @@
           <a:bodyPr wrap="square" lIns="0" tIns="0" rIns="0" bIns="0" rtlCol="0" anchor="ctr"/>
           <a:lstStyle/>
           <a:p>
-            <a:pPr marL="0" indent="0" algn="r">
+            <a:pPr algn="r" indent="0" marL="0">
               <a:buNone/>
             </a:pPr>
             <a:r>
@@ -7372,7 +7387,6 @@
         <a:solidFill>
           <a:srgbClr val="F2F6F7"/>
         </a:solidFill>
-        <a:effectLst/>
       </p:bgPr>
     </p:bg>
     <p:spTree>
@@ -7410,11 +7424,11 @@
           <a:bodyPr wrap="square" lIns="0" tIns="0" rIns="0" bIns="0" rtlCol="0" anchor="ctr"/>
           <a:lstStyle/>
           <a:p>
-            <a:pPr marL="0" indent="0">
-              <a:buNone/>
-            </a:pPr>
-            <a:r>
-              <a:rPr lang="en-US" sz="1200" b="1" kern="0" spc="300" dirty="0">
+            <a:pPr indent="0" marL="0">
+              <a:buNone/>
+            </a:pPr>
+            <a:r>
+              <a:rPr lang="en-US" sz="1200" b="1" spc="300" kern="0" dirty="0">
                 <a:solidFill>
                   <a:srgbClr val="1FA598"/>
                 </a:solidFill>
@@ -7449,7 +7463,7 @@
           <a:bodyPr wrap="square" lIns="0" tIns="0" rIns="0" bIns="0" rtlCol="0" anchor="ctr"/>
           <a:lstStyle/>
           <a:p>
-            <a:pPr marL="0" indent="0">
+            <a:pPr indent="0" marL="0">
               <a:buNone/>
             </a:pPr>
             <a:r>
@@ -7488,7 +7502,7 @@
           <a:bodyPr wrap="square" lIns="0" tIns="0" rIns="0" bIns="0" rtlCol="0" anchor="ctr"/>
           <a:lstStyle/>
           <a:p>
-            <a:pPr marL="0" indent="0">
+            <a:pPr indent="0" marL="0">
               <a:buNone/>
             </a:pPr>
             <a:r>
@@ -7527,20 +7541,13 @@
           </a:solidFill>
           <a:ln/>
           <a:effectLst>
-            <a:outerShdw blurRad="114300" dist="38100" dir="5400000" algn="bl" rotWithShape="0">
+            <a:outerShdw sx="100000" sy="100000" kx="0" ky="0" algn="bl" rotWithShape="0" blurRad="114300" dist="38100" dir="5400000">
               <a:srgbClr val="0A2A31">
                 <a:alpha val="11000"/>
               </a:srgbClr>
             </a:outerShdw>
           </a:effectLst>
         </p:spPr>
-        <p:txBody>
-          <a:bodyPr/>
-          <a:lstStyle/>
-          <a:p>
-            <a:endParaRPr lang="en-CH"/>
-          </a:p>
-        </p:txBody>
       </p:sp>
       <p:sp>
         <p:nvSpPr>
@@ -7563,7 +7570,7 @@
           <a:bodyPr wrap="square" lIns="0" tIns="0" rIns="0" bIns="0" rtlCol="0" anchor="ctr"/>
           <a:lstStyle/>
           <a:p>
-            <a:pPr marL="0" indent="0">
+            <a:pPr indent="0" marL="0">
               <a:buNone/>
             </a:pPr>
             <a:r>
@@ -7602,7 +7609,7 @@
           <a:bodyPr wrap="square" lIns="0" tIns="0" rIns="0" bIns="0" rtlCol="0" anchor="ctr"/>
           <a:lstStyle/>
           <a:p>
-            <a:pPr marL="0" indent="0">
+            <a:pPr indent="0" marL="0">
               <a:buNone/>
             </a:pPr>
             <a:r>
@@ -7641,7 +7648,7 @@
           <a:bodyPr wrap="square" lIns="0" tIns="0" rIns="0" bIns="0" rtlCol="0" anchor="ctr"/>
           <a:lstStyle/>
           <a:p>
-            <a:pPr marL="0" indent="0">
+            <a:pPr indent="0" marL="0">
               <a:lnSpc>
                 <a:spcPct val="102000"/>
               </a:lnSpc>
@@ -7683,7 +7690,7 @@
           <a:bodyPr wrap="square" lIns="0" tIns="0" rIns="0" bIns="0" rtlCol="0" anchor="ctr"/>
           <a:lstStyle/>
           <a:p>
-            <a:pPr marL="0" indent="0" algn="ctr">
+            <a:pPr algn="ctr" indent="0" marL="0">
               <a:buNone/>
             </a:pPr>
             <a:r>
@@ -7722,20 +7729,13 @@
           </a:solidFill>
           <a:ln/>
           <a:effectLst>
-            <a:outerShdw blurRad="114300" dist="38100" dir="5400000" algn="bl" rotWithShape="0">
+            <a:outerShdw sx="100000" sy="100000" kx="0" ky="0" algn="bl" rotWithShape="0" blurRad="114300" dist="38100" dir="5400000">
               <a:srgbClr val="0A2A31">
                 <a:alpha val="11000"/>
               </a:srgbClr>
             </a:outerShdw>
           </a:effectLst>
         </p:spPr>
-        <p:txBody>
-          <a:bodyPr/>
-          <a:lstStyle/>
-          <a:p>
-            <a:endParaRPr lang="en-CH"/>
-          </a:p>
-        </p:txBody>
       </p:sp>
       <p:sp>
         <p:nvSpPr>
@@ -7758,7 +7758,7 @@
           <a:bodyPr wrap="square" lIns="0" tIns="0" rIns="0" bIns="0" rtlCol="0" anchor="ctr"/>
           <a:lstStyle/>
           <a:p>
-            <a:pPr marL="0" indent="0">
+            <a:pPr indent="0" marL="0">
               <a:buNone/>
             </a:pPr>
             <a:r>
@@ -7797,7 +7797,7 @@
           <a:bodyPr wrap="square" lIns="0" tIns="0" rIns="0" bIns="0" rtlCol="0" anchor="ctr"/>
           <a:lstStyle/>
           <a:p>
-            <a:pPr marL="0" indent="0">
+            <a:pPr indent="0" marL="0">
               <a:buNone/>
             </a:pPr>
             <a:r>
@@ -7836,7 +7836,7 @@
           <a:bodyPr wrap="square" lIns="0" tIns="0" rIns="0" bIns="0" rtlCol="0" anchor="ctr"/>
           <a:lstStyle/>
           <a:p>
-            <a:pPr marL="0" indent="0">
+            <a:pPr indent="0" marL="0">
               <a:lnSpc>
                 <a:spcPct val="102000"/>
               </a:lnSpc>
@@ -7878,7 +7878,7 @@
           <a:bodyPr wrap="square" lIns="0" tIns="0" rIns="0" bIns="0" rtlCol="0" anchor="ctr"/>
           <a:lstStyle/>
           <a:p>
-            <a:pPr marL="0" indent="0" algn="ctr">
+            <a:pPr algn="ctr" indent="0" marL="0">
               <a:buNone/>
             </a:pPr>
             <a:r>
@@ -7917,20 +7917,13 @@
           </a:solidFill>
           <a:ln/>
           <a:effectLst>
-            <a:outerShdw blurRad="114300" dist="38100" dir="5400000" algn="bl" rotWithShape="0">
+            <a:outerShdw sx="100000" sy="100000" kx="0" ky="0" algn="bl" rotWithShape="0" blurRad="114300" dist="38100" dir="5400000">
               <a:srgbClr val="0A2A31">
                 <a:alpha val="11000"/>
               </a:srgbClr>
             </a:outerShdw>
           </a:effectLst>
         </p:spPr>
-        <p:txBody>
-          <a:bodyPr/>
-          <a:lstStyle/>
-          <a:p>
-            <a:endParaRPr lang="en-CH"/>
-          </a:p>
-        </p:txBody>
       </p:sp>
       <p:sp>
         <p:nvSpPr>
@@ -7953,7 +7946,7 @@
           <a:bodyPr wrap="square" lIns="0" tIns="0" rIns="0" bIns="0" rtlCol="0" anchor="ctr"/>
           <a:lstStyle/>
           <a:p>
-            <a:pPr marL="0" indent="0">
+            <a:pPr indent="0" marL="0">
               <a:buNone/>
             </a:pPr>
             <a:r>
@@ -7992,7 +7985,7 @@
           <a:bodyPr wrap="square" lIns="0" tIns="0" rIns="0" bIns="0" rtlCol="0" anchor="ctr"/>
           <a:lstStyle/>
           <a:p>
-            <a:pPr marL="0" indent="0">
+            <a:pPr indent="0" marL="0">
               <a:buNone/>
             </a:pPr>
             <a:r>
@@ -8031,7 +8024,7 @@
           <a:bodyPr wrap="square" lIns="0" tIns="0" rIns="0" bIns="0" rtlCol="0" anchor="ctr"/>
           <a:lstStyle/>
           <a:p>
-            <a:pPr marL="0" indent="0">
+            <a:pPr indent="0" marL="0">
               <a:lnSpc>
                 <a:spcPct val="102000"/>
               </a:lnSpc>
@@ -8073,7 +8066,7 @@
           <a:bodyPr wrap="square" lIns="0" tIns="0" rIns="0" bIns="0" rtlCol="0" anchor="ctr"/>
           <a:lstStyle/>
           <a:p>
-            <a:pPr marL="0" indent="0" algn="ctr">
+            <a:pPr algn="ctr" indent="0" marL="0">
               <a:buNone/>
             </a:pPr>
             <a:r>
@@ -8112,20 +8105,13 @@
           </a:solidFill>
           <a:ln/>
           <a:effectLst>
-            <a:outerShdw blurRad="114300" dist="38100" dir="5400000" algn="bl" rotWithShape="0">
+            <a:outerShdw sx="100000" sy="100000" kx="0" ky="0" algn="bl" rotWithShape="0" blurRad="114300" dist="38100" dir="5400000">
               <a:srgbClr val="0A2A31">
                 <a:alpha val="11000"/>
               </a:srgbClr>
             </a:outerShdw>
           </a:effectLst>
         </p:spPr>
-        <p:txBody>
-          <a:bodyPr/>
-          <a:lstStyle/>
-          <a:p>
-            <a:endParaRPr lang="en-CH"/>
-          </a:p>
-        </p:txBody>
       </p:sp>
       <p:sp>
         <p:nvSpPr>
@@ -8148,7 +8134,7 @@
           <a:bodyPr wrap="square" lIns="0" tIns="0" rIns="0" bIns="0" rtlCol="0" anchor="ctr"/>
           <a:lstStyle/>
           <a:p>
-            <a:pPr marL="0" indent="0">
+            <a:pPr indent="0" marL="0">
               <a:buNone/>
             </a:pPr>
             <a:r>
@@ -8187,7 +8173,7 @@
           <a:bodyPr wrap="square" lIns="0" tIns="0" rIns="0" bIns="0" rtlCol="0" anchor="ctr"/>
           <a:lstStyle/>
           <a:p>
-            <a:pPr marL="0" indent="0">
+            <a:pPr indent="0" marL="0">
               <a:buNone/>
             </a:pPr>
             <a:r>
@@ -8226,7 +8212,7 @@
           <a:bodyPr wrap="square" lIns="0" tIns="0" rIns="0" bIns="0" rtlCol="0" anchor="ctr"/>
           <a:lstStyle/>
           <a:p>
-            <a:pPr marL="0" indent="0">
+            <a:pPr indent="0" marL="0">
               <a:lnSpc>
                 <a:spcPct val="102000"/>
               </a:lnSpc>
@@ -8268,7 +8254,7 @@
           <a:bodyPr wrap="square" lIns="0" tIns="0" rIns="0" bIns="0" rtlCol="0" anchor="ctr"/>
           <a:lstStyle/>
           <a:p>
-            <a:pPr marL="0" indent="0">
+            <a:pPr indent="0" marL="0">
               <a:buNone/>
             </a:pPr>
             <a:r>
@@ -8307,13 +8293,6 @@
           </a:solidFill>
           <a:ln/>
         </p:spPr>
-        <p:txBody>
-          <a:bodyPr/>
-          <a:lstStyle/>
-          <a:p>
-            <a:endParaRPr lang="en-CH"/>
-          </a:p>
-        </p:txBody>
       </p:sp>
       <p:sp>
         <p:nvSpPr>
@@ -8336,7 +8315,7 @@
           <a:bodyPr wrap="square" lIns="0" tIns="0" rIns="0" bIns="0" rtlCol="0" anchor="ctr"/>
           <a:lstStyle/>
           <a:p>
-            <a:pPr marL="0" indent="0" algn="ctr">
+            <a:pPr algn="ctr" indent="0" marL="0">
               <a:buNone/>
             </a:pPr>
             <a:r>
@@ -8375,13 +8354,6 @@
           </a:solidFill>
           <a:ln/>
         </p:spPr>
-        <p:txBody>
-          <a:bodyPr/>
-          <a:lstStyle/>
-          <a:p>
-            <a:endParaRPr lang="en-CH"/>
-          </a:p>
-        </p:txBody>
       </p:sp>
       <p:sp>
         <p:nvSpPr>
@@ -8404,7 +8376,7 @@
           <a:bodyPr wrap="square" lIns="0" tIns="0" rIns="0" bIns="0" rtlCol="0" anchor="ctr"/>
           <a:lstStyle/>
           <a:p>
-            <a:pPr marL="0" indent="0" algn="ctr">
+            <a:pPr algn="ctr" indent="0" marL="0">
               <a:buNone/>
             </a:pPr>
             <a:r>
@@ -8443,13 +8415,6 @@
           </a:solidFill>
           <a:ln/>
         </p:spPr>
-        <p:txBody>
-          <a:bodyPr/>
-          <a:lstStyle/>
-          <a:p>
-            <a:endParaRPr lang="en-CH"/>
-          </a:p>
-        </p:txBody>
       </p:sp>
       <p:sp>
         <p:nvSpPr>
@@ -8472,7 +8437,7 @@
           <a:bodyPr wrap="square" lIns="0" tIns="0" rIns="0" bIns="0" rtlCol="0" anchor="ctr"/>
           <a:lstStyle/>
           <a:p>
-            <a:pPr marL="0" indent="0" algn="ctr">
+            <a:pPr algn="ctr" indent="0" marL="0">
               <a:buNone/>
             </a:pPr>
             <a:r>
@@ -8511,13 +8476,6 @@
           </a:solidFill>
           <a:ln/>
         </p:spPr>
-        <p:txBody>
-          <a:bodyPr/>
-          <a:lstStyle/>
-          <a:p>
-            <a:endParaRPr lang="en-CH"/>
-          </a:p>
-        </p:txBody>
       </p:sp>
       <p:sp>
         <p:nvSpPr>
@@ -8540,7 +8498,7 @@
           <a:bodyPr wrap="square" lIns="0" tIns="0" rIns="0" bIns="0" rtlCol="0" anchor="ctr"/>
           <a:lstStyle/>
           <a:p>
-            <a:pPr marL="0" indent="0" algn="ctr">
+            <a:pPr algn="ctr" indent="0" marL="0">
               <a:buNone/>
             </a:pPr>
             <a:r>
@@ -8579,13 +8537,6 @@
           </a:solidFill>
           <a:ln/>
         </p:spPr>
-        <p:txBody>
-          <a:bodyPr/>
-          <a:lstStyle/>
-          <a:p>
-            <a:endParaRPr lang="en-CH"/>
-          </a:p>
-        </p:txBody>
       </p:sp>
       <p:sp>
         <p:nvSpPr>
@@ -8608,7 +8559,7 @@
           <a:bodyPr wrap="square" lIns="0" tIns="0" rIns="0" bIns="0" rtlCol="0" anchor="ctr"/>
           <a:lstStyle/>
           <a:p>
-            <a:pPr marL="0" indent="0" algn="ctr">
+            <a:pPr algn="ctr" indent="0" marL="0">
               <a:buNone/>
             </a:pPr>
             <a:r>
@@ -8647,13 +8598,6 @@
           </a:solidFill>
           <a:ln/>
         </p:spPr>
-        <p:txBody>
-          <a:bodyPr/>
-          <a:lstStyle/>
-          <a:p>
-            <a:endParaRPr lang="en-CH"/>
-          </a:p>
-        </p:txBody>
       </p:sp>
       <p:sp>
         <p:nvSpPr>
@@ -8676,7 +8620,7 @@
           <a:bodyPr wrap="square" lIns="0" tIns="0" rIns="0" bIns="0" rtlCol="0" anchor="ctr"/>
           <a:lstStyle/>
           <a:p>
-            <a:pPr marL="0" indent="0" algn="ctr">
+            <a:pPr algn="ctr" indent="0" marL="0">
               <a:buNone/>
             </a:pPr>
             <a:r>
@@ -8715,7 +8659,7 @@
           <a:bodyPr wrap="square" lIns="0" tIns="0" rIns="0" bIns="0" rtlCol="0" anchor="ctr"/>
           <a:lstStyle/>
           <a:p>
-            <a:pPr marL="0" indent="0">
+            <a:pPr indent="0" marL="0">
               <a:buNone/>
             </a:pPr>
             <a:r>
@@ -8742,19 +8686,19 @@
         <p:spPr>
           <a:xfrm>
             <a:off x="548640" y="6473952"/>
-            <a:ext cx="4572000" cy="274320"/>
-          </a:xfrm>
-          <a:prstGeom prst="rect">
-            <a:avLst/>
-          </a:prstGeom>
-          <a:noFill/>
-          <a:ln/>
-        </p:spPr>
-        <p:txBody>
-          <a:bodyPr wrap="square" lIns="0" tIns="0" rIns="0" bIns="0" rtlCol="0" anchor="ctr"/>
-          <a:lstStyle/>
-          <a:p>
-            <a:pPr marL="0" indent="0" algn="l">
+            <a:ext cx="5486400" cy="274320"/>
+          </a:xfrm>
+          <a:prstGeom prst="rect">
+            <a:avLst/>
+          </a:prstGeom>
+          <a:noFill/>
+          <a:ln/>
+        </p:spPr>
+        <p:txBody>
+          <a:bodyPr wrap="square" lIns="0" tIns="0" rIns="0" bIns="0" rtlCol="0" anchor="ctr"/>
+          <a:lstStyle/>
+          <a:p>
+            <a:pPr algn="l" indent="0" marL="0">
               <a:buNone/>
             </a:pPr>
             <a:r>
@@ -8766,7 +8710,7 @@
                 <a:ea typeface="Calibri" pitchFamily="34" charset="-122"/>
                 <a:cs typeface="Calibri" pitchFamily="34" charset="-120"/>
               </a:rPr>
-              <a:t>AI Skills · Executive Briefing</a:t>
+              <a:t>Evidence-Appraisal Skill · an open explainer</a:t>
             </a:r>
             <a:endParaRPr lang="en-US" sz="900" dirty="0"/>
           </a:p>
@@ -8793,7 +8737,7 @@
           <a:bodyPr wrap="square" lIns="0" tIns="0" rIns="0" bIns="0" rtlCol="0" anchor="ctr"/>
           <a:lstStyle/>
           <a:p>
-            <a:pPr marL="0" indent="0" algn="r">
+            <a:pPr algn="r" indent="0" marL="0">
               <a:buNone/>
             </a:pPr>
             <a:r>
@@ -8827,7 +8771,6 @@
         <a:solidFill>
           <a:srgbClr val="F2F6F7"/>
         </a:solidFill>
-        <a:effectLst/>
       </p:bgPr>
     </p:bg>
     <p:spTree>
@@ -8865,11 +8808,11 @@
           <a:bodyPr wrap="square" lIns="0" tIns="0" rIns="0" bIns="0" rtlCol="0" anchor="ctr"/>
           <a:lstStyle/>
           <a:p>
-            <a:pPr marL="0" indent="0">
-              <a:buNone/>
-            </a:pPr>
-            <a:r>
-              <a:rPr lang="en-US" sz="1200" b="1" kern="0" spc="300" dirty="0">
+            <a:pPr indent="0" marL="0">
+              <a:buNone/>
+            </a:pPr>
+            <a:r>
+              <a:rPr lang="en-US" sz="1200" b="1" spc="300" kern="0" dirty="0">
                 <a:solidFill>
                   <a:srgbClr val="1FA598"/>
                 </a:solidFill>
@@ -8904,7 +8847,7 @@
           <a:bodyPr wrap="square" lIns="0" tIns="0" rIns="0" bIns="0" rtlCol="0" anchor="ctr"/>
           <a:lstStyle/>
           <a:p>
-            <a:pPr marL="0" indent="0">
+            <a:pPr indent="0" marL="0">
               <a:buNone/>
             </a:pPr>
             <a:r>
@@ -8945,20 +8888,8 @@
             <a:tbl>
               <a:tblPr/>
               <a:tblGrid>
-                <a:gridCol w="5486400">
-                  <a:extLst>
-                    <a:ext uri="{9D8B030D-6E8A-4147-A177-3AD203B41FA5}">
-                      <a16:colId xmlns:a16="http://schemas.microsoft.com/office/drawing/2014/main" val="20000"/>
-                    </a:ext>
-                  </a:extLst>
-                </a:gridCol>
-                <a:gridCol w="5605272">
-                  <a:extLst>
-                    <a:ext uri="{9D8B030D-6E8A-4147-A177-3AD203B41FA5}">
-                      <a16:colId xmlns:a16="http://schemas.microsoft.com/office/drawing/2014/main" val="20001"/>
-                    </a:ext>
-                  </a:extLst>
-                </a:gridCol>
+                <a:gridCol w="5486400"/>
+                <a:gridCol w="5605272"/>
               </a:tblGrid>
               <a:tr h="502920">
                 <a:tc>
@@ -8966,7 +8897,7 @@
                     <a:bodyPr/>
                     <a:lstStyle/>
                     <a:p>
-                      <a:pPr marL="0" indent="0" algn="l">
+                      <a:pPr algn="l" indent="0" marL="0">
                         <a:buNone/>
                       </a:pPr>
                       <a:r>
@@ -8987,7 +8918,7 @@
                       </a:endParaRPr>
                     </a:p>
                   </a:txBody>
-                  <a:tcPr anchor="ctr">
+                  <a:tcPr marL="91440" marR="91440" marT="45720" marB="45720" anchor="ctr">
                     <a:lnL w="12700" cap="flat" cmpd="sng" algn="ctr">
                       <a:solidFill>
                         <a:srgbClr val="D9E2E5"/>
@@ -9034,7 +8965,7 @@
                     <a:bodyPr/>
                     <a:lstStyle/>
                     <a:p>
-                      <a:pPr marL="0" indent="0" algn="l">
+                      <a:pPr algn="l" indent="0" marL="0">
                         <a:buNone/>
                       </a:pPr>
                       <a:r>
@@ -9055,7 +8986,7 @@
                       </a:endParaRPr>
                     </a:p>
                   </a:txBody>
-                  <a:tcPr anchor="ctr">
+                  <a:tcPr marL="91440" marR="91440" marT="45720" marB="45720" anchor="ctr">
                     <a:lnL w="12700" cap="flat" cmpd="sng" algn="ctr">
                       <a:solidFill>
                         <a:srgbClr val="D9E2E5"/>
@@ -9097,11 +9028,6 @@
                     </a:solidFill>
                   </a:tcPr>
                 </a:tc>
-                <a:extLst>
-                  <a:ext uri="{0D108BD9-81ED-4DB2-BD59-A6C34878D82A}">
-                    <a16:rowId xmlns:a16="http://schemas.microsoft.com/office/drawing/2014/main" val="10000"/>
-                  </a:ext>
-                </a:extLst>
               </a:tr>
               <a:tr h="658368">
                 <a:tc>
@@ -9109,7 +9035,7 @@
                     <a:bodyPr/>
                     <a:lstStyle/>
                     <a:p>
-                      <a:pPr marL="0" indent="0" algn="l">
+                      <a:pPr algn="l" indent="0" marL="0">
                         <a:buNone/>
                       </a:pPr>
                       <a:r>
@@ -9177,7 +9103,7 @@
                     <a:bodyPr/>
                     <a:lstStyle/>
                     <a:p>
-                      <a:pPr marL="0" indent="0" algn="l">
+                      <a:pPr algn="l" indent="0" marL="0">
                         <a:buNone/>
                       </a:pPr>
                       <a:r>
@@ -9240,11 +9166,6 @@
                     </a:solidFill>
                   </a:tcPr>
                 </a:tc>
-                <a:extLst>
-                  <a:ext uri="{0D108BD9-81ED-4DB2-BD59-A6C34878D82A}">
-                    <a16:rowId xmlns:a16="http://schemas.microsoft.com/office/drawing/2014/main" val="10001"/>
-                  </a:ext>
-                </a:extLst>
               </a:tr>
               <a:tr h="658368">
                 <a:tc>
@@ -9252,7 +9173,7 @@
                     <a:bodyPr/>
                     <a:lstStyle/>
                     <a:p>
-                      <a:pPr marL="0" indent="0" algn="l">
+                      <a:pPr algn="l" indent="0" marL="0">
                         <a:buNone/>
                       </a:pPr>
                       <a:r>
@@ -9320,7 +9241,7 @@
                     <a:bodyPr/>
                     <a:lstStyle/>
                     <a:p>
-                      <a:pPr marL="0" indent="0" algn="l">
+                      <a:pPr algn="l" indent="0" marL="0">
                         <a:buNone/>
                       </a:pPr>
                       <a:r>
@@ -9383,11 +9304,6 @@
                     </a:solidFill>
                   </a:tcPr>
                 </a:tc>
-                <a:extLst>
-                  <a:ext uri="{0D108BD9-81ED-4DB2-BD59-A6C34878D82A}">
-                    <a16:rowId xmlns:a16="http://schemas.microsoft.com/office/drawing/2014/main" val="10002"/>
-                  </a:ext>
-                </a:extLst>
               </a:tr>
               <a:tr h="658368">
                 <a:tc>
@@ -9395,7 +9311,7 @@
                     <a:bodyPr/>
                     <a:lstStyle/>
                     <a:p>
-                      <a:pPr marL="0" indent="0" algn="l">
+                      <a:pPr algn="l" indent="0" marL="0">
                         <a:buNone/>
                       </a:pPr>
                       <a:r>
@@ -9463,7 +9379,7 @@
                     <a:bodyPr/>
                     <a:lstStyle/>
                     <a:p>
-                      <a:pPr marL="0" indent="0" algn="l">
+                      <a:pPr algn="l" indent="0" marL="0">
                         <a:buNone/>
                       </a:pPr>
                       <a:r>
@@ -9526,11 +9442,6 @@
                     </a:solidFill>
                   </a:tcPr>
                 </a:tc>
-                <a:extLst>
-                  <a:ext uri="{0D108BD9-81ED-4DB2-BD59-A6C34878D82A}">
-                    <a16:rowId xmlns:a16="http://schemas.microsoft.com/office/drawing/2014/main" val="10003"/>
-                  </a:ext>
-                </a:extLst>
               </a:tr>
               <a:tr h="658368">
                 <a:tc>
@@ -9538,7 +9449,7 @@
                     <a:bodyPr/>
                     <a:lstStyle/>
                     <a:p>
-                      <a:pPr marL="0" indent="0" algn="l">
+                      <a:pPr algn="l" indent="0" marL="0">
                         <a:buNone/>
                       </a:pPr>
                       <a:r>
@@ -9606,7 +9517,7 @@
                     <a:bodyPr/>
                     <a:lstStyle/>
                     <a:p>
-                      <a:pPr marL="0" indent="0" algn="l">
+                      <a:pPr algn="l" indent="0" marL="0">
                         <a:buNone/>
                       </a:pPr>
                       <a:r>
@@ -9669,11 +9580,6 @@
                     </a:solidFill>
                   </a:tcPr>
                 </a:tc>
-                <a:extLst>
-                  <a:ext uri="{0D108BD9-81ED-4DB2-BD59-A6C34878D82A}">
-                    <a16:rowId xmlns:a16="http://schemas.microsoft.com/office/drawing/2014/main" val="10004"/>
-                  </a:ext>
-                </a:extLst>
               </a:tr>
             </a:tbl>
           </a:graphicData>
@@ -9700,20 +9606,13 @@
           </a:solidFill>
           <a:ln/>
           <a:effectLst>
-            <a:outerShdw blurRad="114300" dist="38100" dir="5400000" algn="bl" rotWithShape="0">
+            <a:outerShdw sx="100000" sy="100000" kx="0" ky="0" algn="bl" rotWithShape="0" blurRad="114300" dist="38100" dir="5400000">
               <a:srgbClr val="0A2A31">
                 <a:alpha val="11000"/>
               </a:srgbClr>
             </a:outerShdw>
           </a:effectLst>
         </p:spPr>
-        <p:txBody>
-          <a:bodyPr/>
-          <a:lstStyle/>
-          <a:p>
-            <a:endParaRPr lang="en-CH"/>
-          </a:p>
-        </p:txBody>
       </p:sp>
       <p:sp>
         <p:nvSpPr>
@@ -9736,7 +9635,7 @@
           <a:bodyPr wrap="square" lIns="0" tIns="0" rIns="0" bIns="0" rtlCol="0" anchor="ctr"/>
           <a:lstStyle/>
           <a:p>
-            <a:pPr marL="0" indent="0">
+            <a:pPr indent="0" marL="0">
               <a:lnSpc>
                 <a:spcPct val="104000"/>
               </a:lnSpc>
@@ -9753,6 +9652,12 @@
               </a:rPr>
               <a:t>Judgement, encoded:  </a:t>
             </a:r>
+            <a:pPr indent="0" marL="0">
+              <a:lnSpc>
+                <a:spcPct val="104000"/>
+              </a:lnSpc>
+              <a:buNone/>
+            </a:pPr>
             <a:r>
               <a:rPr lang="en-US" sz="1350" dirty="0">
                 <a:solidFill>
@@ -9770,26 +9675,26 @@
       </p:sp>
       <p:sp>
         <p:nvSpPr>
-          <p:cNvPr id="4" name="Text 4"/>
+          <p:cNvPr id="7" name="Text 4"/>
           <p:cNvSpPr/>
           <p:nvPr/>
         </p:nvSpPr>
         <p:spPr>
           <a:xfrm>
             <a:off x="548640" y="6473952"/>
-            <a:ext cx="4572000" cy="274320"/>
-          </a:xfrm>
-          <a:prstGeom prst="rect">
-            <a:avLst/>
-          </a:prstGeom>
-          <a:noFill/>
-          <a:ln/>
-        </p:spPr>
-        <p:txBody>
-          <a:bodyPr wrap="square" lIns="0" tIns="0" rIns="0" bIns="0" rtlCol="0" anchor="ctr"/>
-          <a:lstStyle/>
-          <a:p>
-            <a:pPr marL="0" indent="0" algn="l">
+            <a:ext cx="5486400" cy="274320"/>
+          </a:xfrm>
+          <a:prstGeom prst="rect">
+            <a:avLst/>
+          </a:prstGeom>
+          <a:noFill/>
+          <a:ln/>
+        </p:spPr>
+        <p:txBody>
+          <a:bodyPr wrap="square" lIns="0" tIns="0" rIns="0" bIns="0" rtlCol="0" anchor="ctr"/>
+          <a:lstStyle/>
+          <a:p>
+            <a:pPr algn="l" indent="0" marL="0">
               <a:buNone/>
             </a:pPr>
             <a:r>
@@ -9801,7 +9706,7 @@
                 <a:ea typeface="Calibri" pitchFamily="34" charset="-122"/>
                 <a:cs typeface="Calibri" pitchFamily="34" charset="-120"/>
               </a:rPr>
-              <a:t>AI Skills · Executive Briefing</a:t>
+              <a:t>Evidence-Appraisal Skill · an open explainer</a:t>
             </a:r>
             <a:endParaRPr lang="en-US" sz="900" dirty="0"/>
           </a:p>
@@ -9828,7 +9733,7 @@
           <a:bodyPr wrap="square" lIns="0" tIns="0" rIns="0" bIns="0" rtlCol="0" anchor="ctr"/>
           <a:lstStyle/>
           <a:p>
-            <a:pPr marL="0" indent="0" algn="r">
+            <a:pPr algn="r" indent="0" marL="0">
               <a:buNone/>
             </a:pPr>
             <a:r>
@@ -9862,7 +9767,6 @@
         <a:solidFill>
           <a:srgbClr val="F2F6F7"/>
         </a:solidFill>
-        <a:effectLst/>
       </p:bgPr>
     </p:bg>
     <p:spTree>
@@ -9900,11 +9804,11 @@
           <a:bodyPr wrap="square" lIns="0" tIns="0" rIns="0" bIns="0" rtlCol="0" anchor="ctr"/>
           <a:lstStyle/>
           <a:p>
-            <a:pPr marL="0" indent="0">
-              <a:buNone/>
-            </a:pPr>
-            <a:r>
-              <a:rPr lang="en-US" sz="1200" b="1" kern="0" spc="300" dirty="0">
+            <a:pPr indent="0" marL="0">
+              <a:buNone/>
+            </a:pPr>
+            <a:r>
+              <a:rPr lang="en-US" sz="1200" b="1" spc="300" kern="0" dirty="0">
                 <a:solidFill>
                   <a:srgbClr val="1FA598"/>
                 </a:solidFill>
@@ -9939,7 +9843,7 @@
           <a:bodyPr wrap="square" lIns="0" tIns="0" rIns="0" bIns="0" rtlCol="0" anchor="ctr"/>
           <a:lstStyle/>
           <a:p>
-            <a:pPr marL="0" indent="0">
+            <a:pPr indent="0" marL="0">
               <a:buNone/>
             </a:pPr>
             <a:r>
@@ -9978,20 +9882,13 @@
           </a:solidFill>
           <a:ln/>
           <a:effectLst>
-            <a:outerShdw blurRad="114300" dist="38100" dir="5400000" algn="bl" rotWithShape="0">
+            <a:outerShdw sx="100000" sy="100000" kx="0" ky="0" algn="bl" rotWithShape="0" blurRad="114300" dist="38100" dir="5400000">
               <a:srgbClr val="0A2A31">
                 <a:alpha val="11000"/>
               </a:srgbClr>
             </a:outerShdw>
           </a:effectLst>
         </p:spPr>
-        <p:txBody>
-          <a:bodyPr/>
-          <a:lstStyle/>
-          <a:p>
-            <a:endParaRPr lang="en-CH"/>
-          </a:p>
-        </p:txBody>
       </p:sp>
       <p:sp>
         <p:nvSpPr>
@@ -10014,7 +9911,7 @@
           <a:bodyPr wrap="square" lIns="0" tIns="0" rIns="0" bIns="0" rtlCol="0" anchor="ctr"/>
           <a:lstStyle/>
           <a:p>
-            <a:pPr marL="0" indent="0">
+            <a:pPr indent="0" marL="0">
               <a:buNone/>
             </a:pPr>
             <a:r>
@@ -10053,7 +9950,7 @@
           <a:bodyPr wrap="square" lIns="0" tIns="0" rIns="0" bIns="0" rtlCol="0" anchor="ctr"/>
           <a:lstStyle/>
           <a:p>
-            <a:pPr marL="0" indent="0">
+            <a:pPr indent="0" marL="0">
               <a:buNone/>
             </a:pPr>
             <a:r>
@@ -10092,7 +9989,7 @@
           <a:bodyPr wrap="square" lIns="0" tIns="0" rIns="0" bIns="0" rtlCol="0" anchor="ctr"/>
           <a:lstStyle/>
           <a:p>
-            <a:pPr marL="0" indent="0">
+            <a:pPr indent="0" marL="0">
               <a:lnSpc>
                 <a:spcPct val="110000"/>
               </a:lnSpc>
@@ -10112,7 +10009,7 @@
             <a:endParaRPr lang="en-US" sz="1400" dirty="0"/>
           </a:p>
           <a:p>
-            <a:pPr marL="0" indent="0">
+            <a:pPr indent="0" marL="0">
               <a:lnSpc>
                 <a:spcPct val="110000"/>
               </a:lnSpc>
@@ -10132,7 +10029,7 @@
             <a:endParaRPr lang="en-US" sz="1400" dirty="0"/>
           </a:p>
           <a:p>
-            <a:pPr marL="0" indent="0">
+            <a:pPr indent="0" marL="0">
               <a:lnSpc>
                 <a:spcPct val="110000"/>
               </a:lnSpc>
@@ -10152,7 +10049,7 @@
             <a:endParaRPr lang="en-US" sz="1400" dirty="0"/>
           </a:p>
           <a:p>
-            <a:pPr marL="0" indent="0">
+            <a:pPr indent="0" marL="0">
               <a:lnSpc>
                 <a:spcPct val="110000"/>
               </a:lnSpc>
@@ -10194,20 +10091,13 @@
           </a:solidFill>
           <a:ln/>
           <a:effectLst>
-            <a:outerShdw blurRad="114300" dist="38100" dir="5400000" algn="bl" rotWithShape="0">
+            <a:outerShdw sx="100000" sy="100000" kx="0" ky="0" algn="bl" rotWithShape="0" blurRad="114300" dist="38100" dir="5400000">
               <a:srgbClr val="0A2A31">
                 <a:alpha val="11000"/>
               </a:srgbClr>
             </a:outerShdw>
           </a:effectLst>
         </p:spPr>
-        <p:txBody>
-          <a:bodyPr/>
-          <a:lstStyle/>
-          <a:p>
-            <a:endParaRPr lang="en-CH"/>
-          </a:p>
-        </p:txBody>
       </p:sp>
       <p:sp>
         <p:nvSpPr>
@@ -10230,7 +10120,7 @@
           <a:bodyPr wrap="square" lIns="0" tIns="0" rIns="0" bIns="0" rtlCol="0" anchor="ctr"/>
           <a:lstStyle/>
           <a:p>
-            <a:pPr marL="0" indent="0">
+            <a:pPr indent="0" marL="0">
               <a:buNone/>
             </a:pPr>
             <a:r>
@@ -10269,7 +10159,7 @@
           <a:bodyPr wrap="square" lIns="0" tIns="0" rIns="0" bIns="0" rtlCol="0" anchor="ctr"/>
           <a:lstStyle/>
           <a:p>
-            <a:pPr marL="0" indent="0">
+            <a:pPr indent="0" marL="0">
               <a:buNone/>
             </a:pPr>
             <a:r>
@@ -10308,7 +10198,7 @@
           <a:bodyPr wrap="square" lIns="0" tIns="0" rIns="0" bIns="0" rtlCol="0" anchor="ctr"/>
           <a:lstStyle/>
           <a:p>
-            <a:pPr marL="0" indent="0">
+            <a:pPr indent="0" marL="0">
               <a:lnSpc>
                 <a:spcPct val="110000"/>
               </a:lnSpc>
@@ -10328,7 +10218,7 @@
             <a:endParaRPr lang="en-US" sz="1400" dirty="0"/>
           </a:p>
           <a:p>
-            <a:pPr marL="0" indent="0">
+            <a:pPr indent="0" marL="0">
               <a:lnSpc>
                 <a:spcPct val="110000"/>
               </a:lnSpc>
@@ -10348,7 +10238,7 @@
             <a:endParaRPr lang="en-US" sz="1400" dirty="0"/>
           </a:p>
           <a:p>
-            <a:pPr marL="0" indent="0">
+            <a:pPr indent="0" marL="0">
               <a:lnSpc>
                 <a:spcPct val="110000"/>
               </a:lnSpc>
@@ -10368,7 +10258,7 @@
             <a:endParaRPr lang="en-US" sz="1400" dirty="0"/>
           </a:p>
           <a:p>
-            <a:pPr marL="0" indent="0">
+            <a:pPr indent="0" marL="0">
               <a:lnSpc>
                 <a:spcPct val="110000"/>
               </a:lnSpc>
@@ -10410,20 +10300,13 @@
           </a:solidFill>
           <a:ln/>
           <a:effectLst>
-            <a:outerShdw blurRad="114300" dist="38100" dir="5400000" algn="bl" rotWithShape="0">
+            <a:outerShdw sx="100000" sy="100000" kx="0" ky="0" algn="bl" rotWithShape="0" blurRad="114300" dist="38100" dir="5400000">
               <a:srgbClr val="0A2A31">
                 <a:alpha val="11000"/>
               </a:srgbClr>
             </a:outerShdw>
           </a:effectLst>
         </p:spPr>
-        <p:txBody>
-          <a:bodyPr/>
-          <a:lstStyle/>
-          <a:p>
-            <a:endParaRPr lang="en-CH"/>
-          </a:p>
-        </p:txBody>
       </p:sp>
       <p:sp>
         <p:nvSpPr>
@@ -10446,7 +10329,7 @@
           <a:bodyPr wrap="square" lIns="0" tIns="0" rIns="0" bIns="0" rtlCol="0" anchor="ctr"/>
           <a:lstStyle/>
           <a:p>
-            <a:pPr marL="0" indent="0">
+            <a:pPr indent="0" marL="0">
               <a:lnSpc>
                 <a:spcPct val="105000"/>
               </a:lnSpc>
@@ -10463,6 +10346,12 @@
               </a:rPr>
               <a:t>A review can be beautifully written yet still at high risk of bias.  </a:t>
             </a:r>
+            <a:pPr indent="0" marL="0">
+              <a:lnSpc>
+                <a:spcPct val="105000"/>
+              </a:lnSpc>
+              <a:buNone/>
+            </a:pPr>
             <a:r>
               <a:rPr lang="en-US" sz="1500" dirty="0">
                 <a:solidFill>
@@ -10487,19 +10376,19 @@
         <p:spPr>
           <a:xfrm>
             <a:off x="548640" y="6473952"/>
-            <a:ext cx="4572000" cy="274320"/>
-          </a:xfrm>
-          <a:prstGeom prst="rect">
-            <a:avLst/>
-          </a:prstGeom>
-          <a:noFill/>
-          <a:ln/>
-        </p:spPr>
-        <p:txBody>
-          <a:bodyPr wrap="square" lIns="0" tIns="0" rIns="0" bIns="0" rtlCol="0" anchor="ctr"/>
-          <a:lstStyle/>
-          <a:p>
-            <a:pPr marL="0" indent="0" algn="l">
+            <a:ext cx="5486400" cy="274320"/>
+          </a:xfrm>
+          <a:prstGeom prst="rect">
+            <a:avLst/>
+          </a:prstGeom>
+          <a:noFill/>
+          <a:ln/>
+        </p:spPr>
+        <p:txBody>
+          <a:bodyPr wrap="square" lIns="0" tIns="0" rIns="0" bIns="0" rtlCol="0" anchor="ctr"/>
+          <a:lstStyle/>
+          <a:p>
+            <a:pPr algn="l" indent="0" marL="0">
               <a:buNone/>
             </a:pPr>
             <a:r>
@@ -10511,7 +10400,7 @@
                 <a:ea typeface="Calibri" pitchFamily="34" charset="-122"/>
                 <a:cs typeface="Calibri" pitchFamily="34" charset="-120"/>
               </a:rPr>
-              <a:t>AI Skills · Executive Briefing</a:t>
+              <a:t>Evidence-Appraisal Skill · an open explainer</a:t>
             </a:r>
             <a:endParaRPr lang="en-US" sz="900" dirty="0"/>
           </a:p>
@@ -10538,7 +10427,7 @@
           <a:bodyPr wrap="square" lIns="0" tIns="0" rIns="0" bIns="0" rtlCol="0" anchor="ctr"/>
           <a:lstStyle/>
           <a:p>
-            <a:pPr marL="0" indent="0" algn="r">
+            <a:pPr algn="r" indent="0" marL="0">
               <a:buNone/>
             </a:pPr>
             <a:r>
@@ -10572,7 +10461,6 @@
         <a:solidFill>
           <a:srgbClr val="F2F6F7"/>
         </a:solidFill>
-        <a:effectLst/>
       </p:bgPr>
     </p:bg>
     <p:spTree>
@@ -10610,11 +10498,11 @@
           <a:bodyPr wrap="square" lIns="0" tIns="0" rIns="0" bIns="0" rtlCol="0" anchor="ctr"/>
           <a:lstStyle/>
           <a:p>
-            <a:pPr marL="0" indent="0">
-              <a:buNone/>
-            </a:pPr>
-            <a:r>
-              <a:rPr lang="en-US" sz="1200" b="1" kern="0" spc="300" dirty="0">
+            <a:pPr indent="0" marL="0">
+              <a:buNone/>
+            </a:pPr>
+            <a:r>
+              <a:rPr lang="en-US" sz="1200" b="1" spc="300" kern="0" dirty="0">
                 <a:solidFill>
                   <a:srgbClr val="1FA598"/>
                 </a:solidFill>
@@ -10649,7 +10537,7 @@
           <a:bodyPr wrap="square" lIns="0" tIns="0" rIns="0" bIns="0" rtlCol="0" anchor="ctr"/>
           <a:lstStyle/>
           <a:p>
-            <a:pPr marL="0" indent="0">
+            <a:pPr indent="0" marL="0">
               <a:buNone/>
             </a:pPr>
             <a:r>
@@ -10688,7 +10576,7 @@
           <a:bodyPr wrap="square" lIns="0" tIns="0" rIns="0" bIns="0" rtlCol="0" anchor="ctr"/>
           <a:lstStyle/>
           <a:p>
-            <a:pPr marL="0" indent="0">
+            <a:pPr indent="0" marL="0">
               <a:buNone/>
             </a:pPr>
             <a:r>
@@ -10727,20 +10615,13 @@
           </a:solidFill>
           <a:ln/>
           <a:effectLst>
-            <a:outerShdw blurRad="114300" dist="38100" dir="5400000" algn="bl" rotWithShape="0">
+            <a:outerShdw sx="100000" sy="100000" kx="0" ky="0" algn="bl" rotWithShape="0" blurRad="114300" dist="38100" dir="5400000">
               <a:srgbClr val="0A2A31">
                 <a:alpha val="11000"/>
               </a:srgbClr>
             </a:outerShdw>
           </a:effectLst>
         </p:spPr>
-        <p:txBody>
-          <a:bodyPr/>
-          <a:lstStyle/>
-          <a:p>
-            <a:endParaRPr lang="en-CH"/>
-          </a:p>
-        </p:txBody>
       </p:sp>
       <p:sp>
         <p:nvSpPr>
@@ -10763,7 +10644,7 @@
           <a:bodyPr wrap="square" lIns="0" tIns="0" rIns="0" bIns="0" rtlCol="0" anchor="ctr"/>
           <a:lstStyle/>
           <a:p>
-            <a:pPr marL="0" indent="0">
+            <a:pPr indent="0" marL="0">
               <a:lnSpc>
                 <a:spcPct val="100000"/>
               </a:lnSpc>
@@ -10786,7 +10667,7 @@
       </p:sp>
       <p:graphicFrame>
         <p:nvGraphicFramePr>
-          <p:cNvPr id="7" name="Chart 0"/>
+          <p:cNvPr id="7" name="Chart 0" descr=""/>
           <p:cNvGraphicFramePr/>
           <p:nvPr/>
         </p:nvGraphicFramePr>
@@ -10794,9 +10675,9 @@
           <a:off x="685800" y="2743200"/>
           <a:ext cx="5806440" cy="3063240"/>
         </p:xfrm>
-        <a:graphic>
+        <a:graphic xmlns:a="http://schemas.openxmlformats.org/drawingml/2006/main">
           <a:graphicData uri="http://schemas.openxmlformats.org/drawingml/2006/chart">
-            <c:chart xmlns:c="http://schemas.openxmlformats.org/drawingml/2006/chart" xmlns:r="http://schemas.openxmlformats.org/officeDocument/2006/relationships" r:id="rId3"/>
+            <c:chart xmlns:c="http://schemas.openxmlformats.org/drawingml/2006/chart" r:id="rId1"/>
           </a:graphicData>
         </a:graphic>
       </p:graphicFrame>
@@ -10821,20 +10702,13 @@
           </a:solidFill>
           <a:ln/>
           <a:effectLst>
-            <a:outerShdw blurRad="114300" dist="38100" dir="5400000" algn="bl" rotWithShape="0">
+            <a:outerShdw sx="100000" sy="100000" kx="0" ky="0" algn="bl" rotWithShape="0" blurRad="114300" dist="38100" dir="5400000">
               <a:srgbClr val="0A2A31">
                 <a:alpha val="11000"/>
               </a:srgbClr>
             </a:outerShdw>
           </a:effectLst>
         </p:spPr>
-        <p:txBody>
-          <a:bodyPr/>
-          <a:lstStyle/>
-          <a:p>
-            <a:endParaRPr lang="en-CH"/>
-          </a:p>
-        </p:txBody>
       </p:sp>
       <p:sp>
         <p:nvSpPr>
@@ -10855,13 +10729,6 @@
           </a:solidFill>
           <a:ln/>
         </p:spPr>
-        <p:txBody>
-          <a:bodyPr/>
-          <a:lstStyle/>
-          <a:p>
-            <a:endParaRPr lang="en-CH"/>
-          </a:p>
-        </p:txBody>
       </p:sp>
       <p:sp>
         <p:nvSpPr>
@@ -10884,7 +10751,7 @@
           <a:bodyPr wrap="square" lIns="0" tIns="0" rIns="0" bIns="0" rtlCol="0" anchor="ctr"/>
           <a:lstStyle/>
           <a:p>
-            <a:pPr marL="0" indent="0">
+            <a:pPr indent="0" marL="0">
               <a:buNone/>
             </a:pPr>
             <a:r>
@@ -10923,7 +10790,7 @@
           <a:bodyPr wrap="square" lIns="0" tIns="0" rIns="0" bIns="0" rtlCol="0" anchor="ctr"/>
           <a:lstStyle/>
           <a:p>
-            <a:pPr marL="0" indent="0">
+            <a:pPr indent="0" marL="0">
               <a:buNone/>
             </a:pPr>
             <a:r>
@@ -10962,20 +10829,13 @@
           </a:solidFill>
           <a:ln/>
           <a:effectLst>
-            <a:outerShdw blurRad="114300" dist="38100" dir="5400000" algn="bl" rotWithShape="0">
+            <a:outerShdw sx="100000" sy="100000" kx="0" ky="0" algn="bl" rotWithShape="0" blurRad="114300" dist="38100" dir="5400000">
               <a:srgbClr val="0A2A31">
                 <a:alpha val="11000"/>
               </a:srgbClr>
             </a:outerShdw>
           </a:effectLst>
         </p:spPr>
-        <p:txBody>
-          <a:bodyPr/>
-          <a:lstStyle/>
-          <a:p>
-            <a:endParaRPr lang="en-CH"/>
-          </a:p>
-        </p:txBody>
       </p:sp>
       <p:sp>
         <p:nvSpPr>
@@ -10996,13 +10856,6 @@
           </a:solidFill>
           <a:ln/>
         </p:spPr>
-        <p:txBody>
-          <a:bodyPr/>
-          <a:lstStyle/>
-          <a:p>
-            <a:endParaRPr lang="en-CH"/>
-          </a:p>
-        </p:txBody>
       </p:sp>
       <p:sp>
         <p:nvSpPr>
@@ -11025,7 +10878,7 @@
           <a:bodyPr wrap="square" lIns="0" tIns="0" rIns="0" bIns="0" rtlCol="0" anchor="ctr"/>
           <a:lstStyle/>
           <a:p>
-            <a:pPr marL="0" indent="0">
+            <a:pPr indent="0" marL="0">
               <a:buNone/>
             </a:pPr>
             <a:r>
@@ -11064,7 +10917,7 @@
           <a:bodyPr wrap="square" lIns="0" tIns="0" rIns="0" bIns="0" rtlCol="0" anchor="ctr"/>
           <a:lstStyle/>
           <a:p>
-            <a:pPr marL="0" indent="0">
+            <a:pPr indent="0" marL="0">
               <a:buNone/>
             </a:pPr>
             <a:r>
@@ -11103,20 +10956,13 @@
           </a:solidFill>
           <a:ln/>
           <a:effectLst>
-            <a:outerShdw blurRad="114300" dist="38100" dir="5400000" algn="bl" rotWithShape="0">
+            <a:outerShdw sx="100000" sy="100000" kx="0" ky="0" algn="bl" rotWithShape="0" blurRad="114300" dist="38100" dir="5400000">
               <a:srgbClr val="0A2A31">
                 <a:alpha val="11000"/>
               </a:srgbClr>
             </a:outerShdw>
           </a:effectLst>
         </p:spPr>
-        <p:txBody>
-          <a:bodyPr/>
-          <a:lstStyle/>
-          <a:p>
-            <a:endParaRPr lang="en-CH"/>
-          </a:p>
-        </p:txBody>
       </p:sp>
       <p:sp>
         <p:nvSpPr>
@@ -11137,13 +10983,6 @@
           </a:solidFill>
           <a:ln/>
         </p:spPr>
-        <p:txBody>
-          <a:bodyPr/>
-          <a:lstStyle/>
-          <a:p>
-            <a:endParaRPr lang="en-CH"/>
-          </a:p>
-        </p:txBody>
       </p:sp>
       <p:sp>
         <p:nvSpPr>
@@ -11166,7 +11005,7 @@
           <a:bodyPr wrap="square" lIns="0" tIns="0" rIns="0" bIns="0" rtlCol="0" anchor="ctr"/>
           <a:lstStyle/>
           <a:p>
-            <a:pPr marL="0" indent="0">
+            <a:pPr indent="0" marL="0">
               <a:buNone/>
             </a:pPr>
             <a:r>
@@ -11205,7 +11044,7 @@
           <a:bodyPr wrap="square" lIns="0" tIns="0" rIns="0" bIns="0" rtlCol="0" anchor="ctr"/>
           <a:lstStyle/>
           <a:p>
-            <a:pPr marL="0" indent="0">
+            <a:pPr indent="0" marL="0">
               <a:buNone/>
             </a:pPr>
             <a:r>
@@ -11232,19 +11071,19 @@
         <p:spPr>
           <a:xfrm>
             <a:off x="548640" y="6473952"/>
-            <a:ext cx="4572000" cy="274320"/>
-          </a:xfrm>
-          <a:prstGeom prst="rect">
-            <a:avLst/>
-          </a:prstGeom>
-          <a:noFill/>
-          <a:ln/>
-        </p:spPr>
-        <p:txBody>
-          <a:bodyPr wrap="square" lIns="0" tIns="0" rIns="0" bIns="0" rtlCol="0" anchor="ctr"/>
-          <a:lstStyle/>
-          <a:p>
-            <a:pPr marL="0" indent="0" algn="l">
+            <a:ext cx="5486400" cy="274320"/>
+          </a:xfrm>
+          <a:prstGeom prst="rect">
+            <a:avLst/>
+          </a:prstGeom>
+          <a:noFill/>
+          <a:ln/>
+        </p:spPr>
+        <p:txBody>
+          <a:bodyPr wrap="square" lIns="0" tIns="0" rIns="0" bIns="0" rtlCol="0" anchor="ctr"/>
+          <a:lstStyle/>
+          <a:p>
+            <a:pPr algn="l" indent="0" marL="0">
               <a:buNone/>
             </a:pPr>
             <a:r>
@@ -11256,7 +11095,7 @@
                 <a:ea typeface="Calibri" pitchFamily="34" charset="-122"/>
                 <a:cs typeface="Calibri" pitchFamily="34" charset="-120"/>
               </a:rPr>
-              <a:t>AI Skills · Executive Briefing</a:t>
+              <a:t>Evidence-Appraisal Skill · an open explainer</a:t>
             </a:r>
             <a:endParaRPr lang="en-US" sz="900" dirty="0"/>
           </a:p>
@@ -11283,7 +11122,7 @@
           <a:bodyPr wrap="square" lIns="0" tIns="0" rIns="0" bIns="0" rtlCol="0" anchor="ctr"/>
           <a:lstStyle/>
           <a:p>
-            <a:pPr marL="0" indent="0" algn="r">
+            <a:pPr algn="r" indent="0" marL="0">
               <a:buNone/>
             </a:pPr>
             <a:r>
@@ -11317,7 +11156,6 @@
         <a:solidFill>
           <a:srgbClr val="F2F6F7"/>
         </a:solidFill>
-        <a:effectLst/>
       </p:bgPr>
     </p:bg>
     <p:spTree>
@@ -11355,11 +11193,11 @@
           <a:bodyPr wrap="square" lIns="0" tIns="0" rIns="0" bIns="0" rtlCol="0" anchor="ctr"/>
           <a:lstStyle/>
           <a:p>
-            <a:pPr marL="0" indent="0">
-              <a:buNone/>
-            </a:pPr>
-            <a:r>
-              <a:rPr lang="en-US" sz="1200" b="1" kern="0" spc="300" dirty="0">
+            <a:pPr indent="0" marL="0">
+              <a:buNone/>
+            </a:pPr>
+            <a:r>
+              <a:rPr lang="en-US" sz="1200" b="1" spc="300" kern="0" dirty="0">
                 <a:solidFill>
                   <a:srgbClr val="C67A22"/>
                 </a:solidFill>
@@ -11394,7 +11232,7 @@
           <a:bodyPr wrap="square" lIns="0" tIns="0" rIns="0" bIns="0" rtlCol="0" anchor="ctr"/>
           <a:lstStyle/>
           <a:p>
-            <a:pPr marL="0" indent="0">
+            <a:pPr indent="0" marL="0">
               <a:buNone/>
             </a:pPr>
             <a:r>
@@ -11433,7 +11271,7 @@
           <a:bodyPr wrap="square" lIns="0" tIns="0" rIns="0" bIns="0" rtlCol="0" anchor="ctr"/>
           <a:lstStyle/>
           <a:p>
-            <a:pPr marL="0" indent="0">
+            <a:pPr indent="0" marL="0">
               <a:lnSpc>
                 <a:spcPct val="112000"/>
               </a:lnSpc>
@@ -11453,7 +11291,7 @@
             <a:endParaRPr lang="en-US" sz="1500" dirty="0"/>
           </a:p>
           <a:p>
-            <a:pPr marL="0" indent="0">
+            <a:pPr indent="0" marL="0">
               <a:lnSpc>
                 <a:spcPct val="112000"/>
               </a:lnSpc>
@@ -11473,7 +11311,7 @@
             <a:endParaRPr lang="en-US" sz="1500" dirty="0"/>
           </a:p>
           <a:p>
-            <a:pPr marL="0" indent="0">
+            <a:pPr indent="0" marL="0">
               <a:lnSpc>
                 <a:spcPct val="112000"/>
               </a:lnSpc>
@@ -11493,7 +11331,7 @@
             <a:endParaRPr lang="en-US" sz="1500" dirty="0"/>
           </a:p>
           <a:p>
-            <a:pPr marL="0" indent="0">
+            <a:pPr indent="0" marL="0">
               <a:lnSpc>
                 <a:spcPct val="112000"/>
               </a:lnSpc>
@@ -11535,20 +11373,13 @@
           </a:solidFill>
           <a:ln/>
           <a:effectLst>
-            <a:outerShdw blurRad="114300" dist="38100" dir="5400000" algn="bl" rotWithShape="0">
+            <a:outerShdw sx="100000" sy="100000" kx="0" ky="0" algn="bl" rotWithShape="0" blurRad="114300" dist="38100" dir="5400000">
               <a:srgbClr val="0A2A31">
                 <a:alpha val="11000"/>
               </a:srgbClr>
             </a:outerShdw>
           </a:effectLst>
         </p:spPr>
-        <p:txBody>
-          <a:bodyPr/>
-          <a:lstStyle/>
-          <a:p>
-            <a:endParaRPr lang="en-CH"/>
-          </a:p>
-        </p:txBody>
       </p:sp>
       <p:sp>
         <p:nvSpPr>
@@ -11571,7 +11402,7 @@
           <a:bodyPr wrap="square" lIns="0" tIns="0" rIns="0" bIns="0" rtlCol="0" anchor="ctr"/>
           <a:lstStyle/>
           <a:p>
-            <a:pPr marL="0" indent="0">
+            <a:pPr indent="0" marL="0">
               <a:buNone/>
             </a:pPr>
             <a:r>
@@ -11716,19 +11547,19 @@
         <p:spPr>
           <a:xfrm>
             <a:off x="548640" y="6473952"/>
-            <a:ext cx="4572000" cy="274320"/>
-          </a:xfrm>
-          <a:prstGeom prst="rect">
-            <a:avLst/>
-          </a:prstGeom>
-          <a:noFill/>
-          <a:ln/>
-        </p:spPr>
-        <p:txBody>
-          <a:bodyPr wrap="square" lIns="0" tIns="0" rIns="0" bIns="0" rtlCol="0" anchor="ctr"/>
-          <a:lstStyle/>
-          <a:p>
-            <a:pPr marL="0" indent="0" algn="l">
+            <a:ext cx="5486400" cy="274320"/>
+          </a:xfrm>
+          <a:prstGeom prst="rect">
+            <a:avLst/>
+          </a:prstGeom>
+          <a:noFill/>
+          <a:ln/>
+        </p:spPr>
+        <p:txBody>
+          <a:bodyPr wrap="square" lIns="0" tIns="0" rIns="0" bIns="0" rtlCol="0" anchor="ctr"/>
+          <a:lstStyle/>
+          <a:p>
+            <a:pPr algn="l" indent="0" marL="0">
               <a:buNone/>
             </a:pPr>
             <a:r>
@@ -11740,7 +11571,7 @@
                 <a:ea typeface="Calibri" pitchFamily="34" charset="-122"/>
                 <a:cs typeface="Calibri" pitchFamily="34" charset="-120"/>
               </a:rPr>
-              <a:t>AI Skills · Executive Briefing</a:t>
+              <a:t>Evidence-Appraisal Skill · an open explainer</a:t>
             </a:r>
             <a:endParaRPr lang="en-US" sz="900" dirty="0"/>
           </a:p>
@@ -11767,7 +11598,7 @@
           <a:bodyPr wrap="square" lIns="0" tIns="0" rIns="0" bIns="0" rtlCol="0" anchor="ctr"/>
           <a:lstStyle/>
           <a:p>
-            <a:pPr marL="0" indent="0" algn="r">
+            <a:pPr algn="r" indent="0" marL="0">
               <a:buNone/>
             </a:pPr>
             <a:r>
@@ -12086,319 +11917,4 @@
     </a:ext>
   </a:extLst>
 </a:theme>
-</file>
-
-<file path=ppt/theme/theme2.xml><?xml version="1.0" encoding="utf-8"?>
-<a:theme xmlns:a="http://schemas.openxmlformats.org/drawingml/2006/main" name="Office Theme">
-  <a:themeElements>
-    <a:clrScheme name="Office">
-      <a:dk1>
-        <a:sysClr val="windowText" lastClr="000000"/>
-      </a:dk1>
-      <a:lt1>
-        <a:sysClr val="window" lastClr="FFFFFF"/>
-      </a:lt1>
-      <a:dk2>
-        <a:srgbClr val="0E2841"/>
-      </a:dk2>
-      <a:lt2>
-        <a:srgbClr val="E8E8E8"/>
-      </a:lt2>
-      <a:accent1>
-        <a:srgbClr val="156082"/>
-      </a:accent1>
-      <a:accent2>
-        <a:srgbClr val="E97132"/>
-      </a:accent2>
-      <a:accent3>
-        <a:srgbClr val="196B24"/>
-      </a:accent3>
-      <a:accent4>
-        <a:srgbClr val="0F9ED5"/>
-      </a:accent4>
-      <a:accent5>
-        <a:srgbClr val="A02B93"/>
-      </a:accent5>
-      <a:accent6>
-        <a:srgbClr val="4EA72E"/>
-      </a:accent6>
-      <a:hlink>
-        <a:srgbClr val="467886"/>
-      </a:hlink>
-      <a:folHlink>
-        <a:srgbClr val="96607D"/>
-      </a:folHlink>
-    </a:clrScheme>
-    <a:fontScheme name="Office">
-      <a:majorFont>
-        <a:latin typeface="Aptos Display" panose="02110004020202020204"/>
-        <a:ea typeface=""/>
-        <a:cs typeface=""/>
-        <a:font script="Jpan" typeface="游ゴシック Light"/>
-        <a:font script="Hang" typeface="맑은 고딕"/>
-        <a:font script="Hans" typeface="等线 Light"/>
-        <a:font script="Hant" typeface="新細明體"/>
-        <a:font script="Arab" typeface="Times New Roman"/>
-        <a:font script="Hebr" typeface="Times New Roman"/>
-        <a:font script="Thai" typeface="Angsana New"/>
-        <a:font script="Ethi" typeface="Nyala"/>
-        <a:font script="Beng" typeface="Vrinda"/>
-        <a:font script="Gujr" typeface="Shruti"/>
-        <a:font script="Khmr" typeface="MoolBoran"/>
-        <a:font script="Knda" typeface="Tunga"/>
-        <a:font script="Guru" typeface="Raavi"/>
-        <a:font script="Cans" typeface="Euphemia"/>
-        <a:font script="Cher" typeface="Plantagenet Cherokee"/>
-        <a:font script="Yiii" typeface="Microsoft Yi Baiti"/>
-        <a:font script="Tibt" typeface="Microsoft Himalaya"/>
-        <a:font script="Thaa" typeface="MV Boli"/>
-        <a:font script="Deva" typeface="Mangal"/>
-        <a:font script="Telu" typeface="Gautami"/>
-        <a:font script="Taml" typeface="Latha"/>
-        <a:font script="Syrc" typeface="Estrangelo Edessa"/>
-        <a:font script="Orya" typeface="Kalinga"/>
-        <a:font script="Mlym" typeface="Kartika"/>
-        <a:font script="Laoo" typeface="DokChampa"/>
-        <a:font script="Sinh" typeface="Iskoola Pota"/>
-        <a:font script="Mong" typeface="Mongolian Baiti"/>
-        <a:font script="Viet" typeface="Times New Roman"/>
-        <a:font script="Uigh" typeface="Microsoft Uighur"/>
-        <a:font script="Geor" typeface="Sylfaen"/>
-        <a:font script="Armn" typeface="Arial"/>
-        <a:font script="Bugi" typeface="Leelawadee UI"/>
-        <a:font script="Bopo" typeface="Microsoft JhengHei"/>
-        <a:font script="Java" typeface="Javanese Text"/>
-        <a:font script="Lisu" typeface="Segoe UI"/>
-        <a:font script="Mymr" typeface="Myanmar Text"/>
-        <a:font script="Nkoo" typeface="Ebrima"/>
-        <a:font script="Olck" typeface="Nirmala UI"/>
-        <a:font script="Osma" typeface="Ebrima"/>
-        <a:font script="Phag" typeface="Phagspa"/>
-        <a:font script="Syrn" typeface="Estrangelo Edessa"/>
-        <a:font script="Syrj" typeface="Estrangelo Edessa"/>
-        <a:font script="Syre" typeface="Estrangelo Edessa"/>
-        <a:font script="Sora" typeface="Nirmala UI"/>
-        <a:font script="Tale" typeface="Microsoft Tai Le"/>
-        <a:font script="Talu" typeface="Microsoft New Tai Lue"/>
-        <a:font script="Tfng" typeface="Ebrima"/>
-      </a:majorFont>
-      <a:minorFont>
-        <a:latin typeface="Aptos" panose="02110004020202020204"/>
-        <a:ea typeface=""/>
-        <a:cs typeface=""/>
-        <a:font script="Jpan" typeface="游ゴシック"/>
-        <a:font script="Hang" typeface="맑은 고딕"/>
-        <a:font script="Hans" typeface="等线"/>
-        <a:font script="Hant" typeface="新細明體"/>
-        <a:font script="Arab" typeface="Arial"/>
-        <a:font script="Hebr" typeface="Arial"/>
-        <a:font script="Thai" typeface="Cordia New"/>
-        <a:font script="Ethi" typeface="Nyala"/>
-        <a:font script="Beng" typeface="Vrinda"/>
-        <a:font script="Gujr" typeface="Shruti"/>
-        <a:font script="Khmr" typeface="DaunPenh"/>
-        <a:font script="Knda" typeface="Tunga"/>
-        <a:font script="Guru" typeface="Raavi"/>
-        <a:font script="Cans" typeface="Euphemia"/>
-        <a:font script="Cher" typeface="Plantagenet Cherokee"/>
-        <a:font script="Yiii" typeface="Microsoft Yi Baiti"/>
-        <a:font script="Tibt" typeface="Microsoft Himalaya"/>
-        <a:font script="Thaa" typeface="MV Boli"/>
-        <a:font script="Deva" typeface="Mangal"/>
-        <a:font script="Telu" typeface="Gautami"/>
-        <a:font script="Taml" typeface="Latha"/>
-        <a:font script="Syrc" typeface="Estrangelo Edessa"/>
-        <a:font script="Orya" typeface="Kalinga"/>
-        <a:font script="Mlym" typeface="Kartika"/>
-        <a:font script="Laoo" typeface="DokChampa"/>
-        <a:font script="Sinh" typeface="Iskoola Pota"/>
-        <a:font script="Mong" typeface="Mongolian Baiti"/>
-        <a:font script="Viet" typeface="Arial"/>
-        <a:font script="Uigh" typeface="Microsoft Uighur"/>
-        <a:font script="Geor" typeface="Sylfaen"/>
-        <a:font script="Armn" typeface="Arial"/>
-        <a:font script="Bugi" typeface="Leelawadee UI"/>
-        <a:font script="Bopo" typeface="Microsoft JhengHei"/>
-        <a:font script="Java" typeface="Javanese Text"/>
-        <a:font script="Lisu" typeface="Segoe UI"/>
-        <a:font script="Mymr" typeface="Myanmar Text"/>
-        <a:font script="Nkoo" typeface="Ebrima"/>
-        <a:font script="Olck" typeface="Nirmala UI"/>
-        <a:font script="Osma" typeface="Ebrima"/>
-        <a:font script="Phag" typeface="Phagspa"/>
-        <a:font script="Syrn" typeface="Estrangelo Edessa"/>
-        <a:font script="Syrj" typeface="Estrangelo Edessa"/>
-        <a:font script="Syre" typeface="Estrangelo Edessa"/>
-        <a:font script="Sora" typeface="Nirmala UI"/>
-        <a:font script="Tale" typeface="Microsoft Tai Le"/>
-        <a:font script="Talu" typeface="Microsoft New Tai Lue"/>
-        <a:font script="Tfng" typeface="Ebrima"/>
-      </a:minorFont>
-    </a:fontScheme>
-    <a:fmtScheme name="Office">
-      <a:fillStyleLst>
-        <a:solidFill>
-          <a:schemeClr val="phClr"/>
-        </a:solidFill>
-        <a:gradFill rotWithShape="1">
-          <a:gsLst>
-            <a:gs pos="0">
-              <a:schemeClr val="phClr">
-                <a:lumMod val="110000"/>
-                <a:satMod val="105000"/>
-                <a:tint val="67000"/>
-              </a:schemeClr>
-            </a:gs>
-            <a:gs pos="50000">
-              <a:schemeClr val="phClr">
-                <a:lumMod val="105000"/>
-                <a:satMod val="103000"/>
-                <a:tint val="73000"/>
-              </a:schemeClr>
-            </a:gs>
-            <a:gs pos="100000">
-              <a:schemeClr val="phClr">
-                <a:lumMod val="105000"/>
-                <a:satMod val="109000"/>
-                <a:tint val="81000"/>
-              </a:schemeClr>
-            </a:gs>
-          </a:gsLst>
-          <a:lin ang="5400000" scaled="0"/>
-        </a:gradFill>
-        <a:gradFill rotWithShape="1">
-          <a:gsLst>
-            <a:gs pos="0">
-              <a:schemeClr val="phClr">
-                <a:satMod val="103000"/>
-                <a:lumMod val="102000"/>
-                <a:tint val="94000"/>
-              </a:schemeClr>
-            </a:gs>
-            <a:gs pos="50000">
-              <a:schemeClr val="phClr">
-                <a:satMod val="110000"/>
-                <a:lumMod val="100000"/>
-                <a:shade val="100000"/>
-              </a:schemeClr>
-            </a:gs>
-            <a:gs pos="100000">
-              <a:schemeClr val="phClr">
-                <a:lumMod val="99000"/>
-                <a:satMod val="120000"/>
-                <a:shade val="78000"/>
-              </a:schemeClr>
-            </a:gs>
-          </a:gsLst>
-          <a:lin ang="5400000" scaled="0"/>
-        </a:gradFill>
-      </a:fillStyleLst>
-      <a:lnStyleLst>
-        <a:ln w="12700" cap="flat" cmpd="sng" algn="ctr">
-          <a:solidFill>
-            <a:schemeClr val="phClr"/>
-          </a:solidFill>
-          <a:prstDash val="solid"/>
-          <a:miter lim="800000"/>
-        </a:ln>
-        <a:ln w="19050" cap="flat" cmpd="sng" algn="ctr">
-          <a:solidFill>
-            <a:schemeClr val="phClr"/>
-          </a:solidFill>
-          <a:prstDash val="solid"/>
-          <a:miter lim="800000"/>
-        </a:ln>
-        <a:ln w="25400" cap="flat" cmpd="sng" algn="ctr">
-          <a:solidFill>
-            <a:schemeClr val="phClr"/>
-          </a:solidFill>
-          <a:prstDash val="solid"/>
-          <a:miter lim="800000"/>
-        </a:ln>
-      </a:lnStyleLst>
-      <a:effectStyleLst>
-        <a:effectStyle>
-          <a:effectLst/>
-        </a:effectStyle>
-        <a:effectStyle>
-          <a:effectLst/>
-        </a:effectStyle>
-        <a:effectStyle>
-          <a:effectLst>
-            <a:outerShdw blurRad="57150" dist="19050" dir="5400000" algn="ctr" rotWithShape="0">
-              <a:srgbClr val="000000">
-                <a:alpha val="63000"/>
-              </a:srgbClr>
-            </a:outerShdw>
-          </a:effectLst>
-        </a:effectStyle>
-      </a:effectStyleLst>
-      <a:bgFillStyleLst>
-        <a:solidFill>
-          <a:schemeClr val="phClr"/>
-        </a:solidFill>
-        <a:solidFill>
-          <a:schemeClr val="phClr">
-            <a:tint val="95000"/>
-            <a:satMod val="170000"/>
-          </a:schemeClr>
-        </a:solidFill>
-        <a:gradFill rotWithShape="1">
-          <a:gsLst>
-            <a:gs pos="0">
-              <a:schemeClr val="phClr">
-                <a:tint val="93000"/>
-                <a:satMod val="150000"/>
-                <a:shade val="98000"/>
-                <a:lumMod val="102000"/>
-              </a:schemeClr>
-            </a:gs>
-            <a:gs pos="50000">
-              <a:schemeClr val="phClr">
-                <a:tint val="98000"/>
-                <a:satMod val="130000"/>
-                <a:shade val="90000"/>
-                <a:lumMod val="103000"/>
-              </a:schemeClr>
-            </a:gs>
-            <a:gs pos="100000">
-              <a:schemeClr val="phClr">
-                <a:shade val="63000"/>
-                <a:satMod val="120000"/>
-              </a:schemeClr>
-            </a:gs>
-          </a:gsLst>
-          <a:lin ang="5400000" scaled="0"/>
-        </a:gradFill>
-      </a:bgFillStyleLst>
-    </a:fmtScheme>
-  </a:themeElements>
-  <a:objectDefaults>
-    <a:lnDef>
-      <a:spPr/>
-      <a:bodyPr/>
-      <a:lstStyle/>
-      <a:style>
-        <a:lnRef idx="2">
-          <a:schemeClr val="accent1"/>
-        </a:lnRef>
-        <a:fillRef idx="0">
-          <a:schemeClr val="accent1"/>
-        </a:fillRef>
-        <a:effectRef idx="1">
-          <a:schemeClr val="accent1"/>
-        </a:effectRef>
-        <a:fontRef idx="minor">
-          <a:schemeClr val="tx1"/>
-        </a:fontRef>
-      </a:style>
-    </a:lnDef>
-  </a:objectDefaults>
-  <a:extraClrSchemeLst/>
-  <a:extLst>
-    <a:ext uri="{05A4C25C-085E-4340-85A3-A5531E510DB2}">
-      <thm15:themeFamily xmlns:thm15="http://schemas.microsoft.com/office/thememl/2012/main" name="Office Theme" id="{2E142A2C-CD16-42D6-873A-C26D2A0506FA}" vid="{1BDDFF52-6CD6-40A5-AB3C-68EB2F1E4D0A}"/>
-    </a:ext>
-  </a:extLst>
-</a:theme>
 </file>
</xml_diff>

<commit_message>
v1.2: add CONSORT 2010 for randomised trial reports
- New references/consort-2010.md (25-item checklist); SKILL.md routing row,
  detection cue, tool list/description updated; version -> 1.2; CHANGELOG 1.2
- Updated the 3 docs: README.md, README.html (tool lists, routing, version,
  "Auditable by design" note), and the deck (CONSORT chip + routing row)
- Refreshed the Microsoft 365 pack (agent routing + regenerated knowledge .md/.docx)
- Repackaged installer (now 10 files)

Co-Authored-By: Claude Opus 4.8 <noreply@anthropic.com>
</commit_message>
<xml_diff>
--- a/Evidence_Appraisal_Skill_explainer.pptx
+++ b/Evidence_Appraisal_Skill_explainer.pptx
@@ -8266,7 +8266,7 @@
                 <a:ea typeface="Calibri" pitchFamily="34" charset="-122"/>
                 <a:cs typeface="Calibri" pitchFamily="34" charset="-120"/>
               </a:rPr>
-              <a:t>Six expert tools built in:</a:t>
+              <a:t>Seven expert tools built in:</a:t>
             </a:r>
             <a:endParaRPr lang="en-US" sz="1300" dirty="0"/>
           </a:p>
@@ -8281,7 +8281,7 @@
         <p:spPr>
           <a:xfrm>
             <a:off x="548640" y="4800600"/>
-            <a:ext cx="1659636" cy="384048"/>
+            <a:ext cx="1463040" cy="384048"/>
           </a:xfrm>
           <a:prstGeom prst="roundRect">
             <a:avLst>
@@ -8303,7 +8303,7 @@
         <p:spPr>
           <a:xfrm>
             <a:off x="548640" y="4800600"/>
-            <a:ext cx="1659636" cy="384048"/>
+            <a:ext cx="1463040" cy="384048"/>
           </a:xfrm>
           <a:prstGeom prst="rect">
             <a:avLst/>
@@ -8319,7 +8319,7 @@
               <a:buNone/>
             </a:pPr>
             <a:r>
-              <a:rPr lang="en-US" sz="1200" b="1" dirty="0">
+              <a:rPr lang="en-US" sz="1100" b="1" dirty="0">
                 <a:solidFill>
                   <a:srgbClr val="FFFFFF"/>
                 </a:solidFill>
@@ -8329,7 +8329,7 @@
               </a:rPr>
               <a:t>PRISMA 2020</a:t>
             </a:r>
-            <a:endParaRPr lang="en-US" sz="1200" dirty="0"/>
+            <a:endParaRPr lang="en-US" sz="1100" dirty="0"/>
           </a:p>
         </p:txBody>
       </p:sp>
@@ -8341,8 +8341,8 @@
         </p:nvSpPr>
         <p:spPr>
           <a:xfrm>
-            <a:off x="2436876" y="4800600"/>
-            <a:ext cx="1554480" cy="384048"/>
+            <a:off x="2194560" y="4800600"/>
+            <a:ext cx="1371600" cy="384048"/>
           </a:xfrm>
           <a:prstGeom prst="roundRect">
             <a:avLst>
@@ -8363,8 +8363,8 @@
         </p:nvSpPr>
         <p:spPr>
           <a:xfrm>
-            <a:off x="2436876" y="4800600"/>
-            <a:ext cx="1554480" cy="384048"/>
+            <a:off x="2194560" y="4800600"/>
+            <a:ext cx="1371600" cy="384048"/>
           </a:xfrm>
           <a:prstGeom prst="rect">
             <a:avLst/>
@@ -8380,7 +8380,7 @@
               <a:buNone/>
             </a:pPr>
             <a:r>
-              <a:rPr lang="en-US" sz="1200" b="1" dirty="0">
+              <a:rPr lang="en-US" sz="1100" b="1" dirty="0">
                 <a:solidFill>
                   <a:srgbClr val="FFFFFF"/>
                 </a:solidFill>
@@ -8390,7 +8390,7 @@
               </a:rPr>
               <a:t>PRISMA-NMA</a:t>
             </a:r>
-            <a:endParaRPr lang="en-US" sz="1200" dirty="0"/>
+            <a:endParaRPr lang="en-US" sz="1100" dirty="0"/>
           </a:p>
         </p:txBody>
       </p:sp>
@@ -8402,8 +8402,8 @@
         </p:nvSpPr>
         <p:spPr>
           <a:xfrm>
-            <a:off x="4219956" y="4800600"/>
-            <a:ext cx="1143000" cy="384048"/>
+            <a:off x="3749040" y="4800600"/>
+            <a:ext cx="1051560" cy="384048"/>
           </a:xfrm>
           <a:prstGeom prst="roundRect">
             <a:avLst>
@@ -8424,8 +8424,8 @@
         </p:nvSpPr>
         <p:spPr>
           <a:xfrm>
-            <a:off x="4219956" y="4800600"/>
-            <a:ext cx="1143000" cy="384048"/>
+            <a:off x="3749040" y="4800600"/>
+            <a:ext cx="1051560" cy="384048"/>
           </a:xfrm>
           <a:prstGeom prst="rect">
             <a:avLst/>
@@ -8441,7 +8441,7 @@
               <a:buNone/>
             </a:pPr>
             <a:r>
-              <a:rPr lang="en-US" sz="1200" b="1" dirty="0">
+              <a:rPr lang="en-US" sz="1100" b="1" dirty="0">
                 <a:solidFill>
                   <a:srgbClr val="FFFFFF"/>
                 </a:solidFill>
@@ -8451,7 +8451,7 @@
               </a:rPr>
               <a:t>ROBIS</a:t>
             </a:r>
-            <a:endParaRPr lang="en-US" sz="1200" dirty="0"/>
+            <a:endParaRPr lang="en-US" sz="1100" dirty="0"/>
           </a:p>
         </p:txBody>
       </p:sp>
@@ -8463,8 +8463,8 @@
         </p:nvSpPr>
         <p:spPr>
           <a:xfrm>
-            <a:off x="5591556" y="4800600"/>
-            <a:ext cx="1344168" cy="384048"/>
+            <a:off x="4983480" y="4800600"/>
+            <a:ext cx="1188720" cy="384048"/>
           </a:xfrm>
           <a:prstGeom prst="roundRect">
             <a:avLst>
@@ -8485,8 +8485,8 @@
         </p:nvSpPr>
         <p:spPr>
           <a:xfrm>
-            <a:off x="5591556" y="4800600"/>
-            <a:ext cx="1344168" cy="384048"/>
+            <a:off x="4983480" y="4800600"/>
+            <a:ext cx="1188720" cy="384048"/>
           </a:xfrm>
           <a:prstGeom prst="rect">
             <a:avLst/>
@@ -8502,7 +8502,7 @@
               <a:buNone/>
             </a:pPr>
             <a:r>
-              <a:rPr lang="en-US" sz="1200" b="1" dirty="0">
+              <a:rPr lang="en-US" sz="1100" b="1" dirty="0">
                 <a:solidFill>
                   <a:srgbClr val="FFFFFF"/>
                 </a:solidFill>
@@ -8512,7 +8512,7 @@
               </a:rPr>
               <a:t>AMSTAR-2</a:t>
             </a:r>
-            <a:endParaRPr lang="en-US" sz="1200" dirty="0"/>
+            <a:endParaRPr lang="en-US" sz="1100" dirty="0"/>
           </a:p>
         </p:txBody>
       </p:sp>
@@ -8524,8 +8524,8 @@
         </p:nvSpPr>
         <p:spPr>
           <a:xfrm>
-            <a:off x="7164324" y="4800600"/>
-            <a:ext cx="1344168" cy="384048"/>
+            <a:off x="6355080" y="4800600"/>
+            <a:ext cx="1188720" cy="384048"/>
           </a:xfrm>
           <a:prstGeom prst="roundRect">
             <a:avLst>
@@ -8546,8 +8546,8 @@
         </p:nvSpPr>
         <p:spPr>
           <a:xfrm>
-            <a:off x="7164324" y="4800600"/>
-            <a:ext cx="1344168" cy="384048"/>
+            <a:off x="6355080" y="4800600"/>
+            <a:ext cx="1188720" cy="384048"/>
           </a:xfrm>
           <a:prstGeom prst="rect">
             <a:avLst/>
@@ -8563,7 +8563,7 @@
               <a:buNone/>
             </a:pPr>
             <a:r>
-              <a:rPr lang="en-US" sz="1200" b="1" dirty="0">
+              <a:rPr lang="en-US" sz="1100" b="1" dirty="0">
                 <a:solidFill>
                   <a:srgbClr val="FFFFFF"/>
                 </a:solidFill>
@@ -8573,7 +8573,7 @@
               </a:rPr>
               <a:t>PRISMA-P</a:t>
             </a:r>
-            <a:endParaRPr lang="en-US" sz="1200" dirty="0"/>
+            <a:endParaRPr lang="en-US" sz="1100" dirty="0"/>
           </a:p>
         </p:txBody>
       </p:sp>
@@ -8585,8 +8585,8 @@
         </p:nvSpPr>
         <p:spPr>
           <a:xfrm>
-            <a:off x="8737092" y="4800600"/>
-            <a:ext cx="1659636" cy="384048"/>
+            <a:off x="7726680" y="4800600"/>
+            <a:ext cx="1463040" cy="384048"/>
           </a:xfrm>
           <a:prstGeom prst="roundRect">
             <a:avLst>
@@ -8607,8 +8607,8 @@
         </p:nvSpPr>
         <p:spPr>
           <a:xfrm>
-            <a:off x="8737092" y="4800600"/>
-            <a:ext cx="1659636" cy="384048"/>
+            <a:off x="7726680" y="4800600"/>
+            <a:ext cx="1463040" cy="384048"/>
           </a:xfrm>
           <a:prstGeom prst="rect">
             <a:avLst/>
@@ -8624,7 +8624,7 @@
               <a:buNone/>
             </a:pPr>
             <a:r>
-              <a:rPr lang="en-US" sz="1200" b="1" dirty="0">
+              <a:rPr lang="en-US" sz="1100" b="1" dirty="0">
                 <a:solidFill>
                   <a:srgbClr val="FFFFFF"/>
                 </a:solidFill>
@@ -8634,13 +8634,74 @@
               </a:rPr>
               <a:t>SPIRIT 2013</a:t>
             </a:r>
-            <a:endParaRPr lang="en-US" sz="1200" dirty="0"/>
-          </a:p>
-        </p:txBody>
-      </p:sp>
-      <p:sp>
-        <p:nvSpPr>
-          <p:cNvPr id="37" name="Text 35"/>
+            <a:endParaRPr lang="en-US" sz="1100" dirty="0"/>
+          </a:p>
+        </p:txBody>
+      </p:sp>
+      <p:sp>
+        <p:nvSpPr>
+          <p:cNvPr id="37" name="Shape 35"/>
+          <p:cNvSpPr/>
+          <p:nvPr/>
+        </p:nvSpPr>
+        <p:spPr>
+          <a:xfrm>
+            <a:off x="9372600" y="4800600"/>
+            <a:ext cx="1554480" cy="384048"/>
+          </a:xfrm>
+          <a:prstGeom prst="roundRect">
+            <a:avLst>
+              <a:gd name="adj" fmla="val 50000"/>
+            </a:avLst>
+          </a:prstGeom>
+          <a:solidFill>
+            <a:srgbClr val="1FA598"/>
+          </a:solidFill>
+          <a:ln/>
+        </p:spPr>
+      </p:sp>
+      <p:sp>
+        <p:nvSpPr>
+          <p:cNvPr id="38" name="Text 36"/>
+          <p:cNvSpPr/>
+          <p:nvPr/>
+        </p:nvSpPr>
+        <p:spPr>
+          <a:xfrm>
+            <a:off x="9372600" y="4800600"/>
+            <a:ext cx="1554480" cy="384048"/>
+          </a:xfrm>
+          <a:prstGeom prst="rect">
+            <a:avLst/>
+          </a:prstGeom>
+          <a:noFill/>
+          <a:ln/>
+        </p:spPr>
+        <p:txBody>
+          <a:bodyPr wrap="square" lIns="0" tIns="0" rIns="0" bIns="0" rtlCol="0" anchor="ctr"/>
+          <a:lstStyle/>
+          <a:p>
+            <a:pPr algn="ctr" indent="0" marL="0">
+              <a:buNone/>
+            </a:pPr>
+            <a:r>
+              <a:rPr lang="en-US" sz="1100" b="1" dirty="0">
+                <a:solidFill>
+                  <a:srgbClr val="FFFFFF"/>
+                </a:solidFill>
+                <a:latin typeface="Calibri" pitchFamily="34" charset="0"/>
+                <a:ea typeface="Calibri" pitchFamily="34" charset="-122"/>
+                <a:cs typeface="Calibri" pitchFamily="34" charset="-120"/>
+              </a:rPr>
+              <a:t>CONSORT 2010</a:t>
+            </a:r>
+            <a:endParaRPr lang="en-US" sz="1100" dirty="0"/>
+          </a:p>
+        </p:txBody>
+      </p:sp>
+      <p:sp>
+        <p:nvSpPr>
+          <p:cNvPr id="39" name="Text 37"/>
           <p:cNvSpPr/>
           <p:nvPr/>
         </p:nvSpPr>
@@ -8679,7 +8740,7 @@
       </p:sp>
       <p:sp>
         <p:nvSpPr>
-          <p:cNvPr id="38" name="Text 36"/>
+          <p:cNvPr id="40" name="Text 38"/>
           <p:cNvSpPr/>
           <p:nvPr/>
         </p:nvSpPr>
@@ -8718,7 +8779,7 @@
       </p:sp>
       <p:sp>
         <p:nvSpPr>
-          <p:cNvPr id="39" name="Text 37"/>
+          <p:cNvPr id="41" name="Text 39"/>
           <p:cNvSpPr/>
           <p:nvPr/>
         </p:nvSpPr>
@@ -8880,7 +8941,7 @@
           </p:nvPr>
         </p:nvGraphicFramePr>
         <p:xfrm>
-          <a:off x="548640" y="1828800"/>
+          <a:off x="548640" y="1783080"/>
           <a:ext cx="11094415" cy="914400"/>
         </p:xfrm>
         <a:graphic>
@@ -8891,7 +8952,7 @@
                 <a:gridCol w="5486400"/>
                 <a:gridCol w="5605272"/>
               </a:tblGrid>
-              <a:tr h="502920">
+              <a:tr h="457200">
                 <a:tc>
                   <a:txBody>
                     <a:bodyPr/>
@@ -9029,7 +9090,7 @@
                   </a:tcPr>
                 </a:tc>
               </a:tr>
-              <a:tr h="658368">
+              <a:tr h="548640">
                 <a:tc>
                   <a:txBody>
                     <a:bodyPr/>
@@ -9167,7 +9228,7 @@
                   </a:tcPr>
                 </a:tc>
               </a:tr>
-              <a:tr h="658368">
+              <a:tr h="548640">
                 <a:tc>
                   <a:txBody>
                     <a:bodyPr/>
@@ -9305,7 +9366,7 @@
                   </a:tcPr>
                 </a:tc>
               </a:tr>
-              <a:tr h="658368">
+              <a:tr h="548640">
                 <a:tc>
                   <a:txBody>
                     <a:bodyPr/>
@@ -9443,7 +9504,7 @@
                   </a:tcPr>
                 </a:tc>
               </a:tr>
-              <a:tr h="658368">
+              <a:tr h="548640">
                 <a:tc>
                   <a:txBody>
                     <a:bodyPr/>
@@ -9581,6 +9642,144 @@
                   </a:tcPr>
                 </a:tc>
               </a:tr>
+              <a:tr h="548640">
+                <a:tc>
+                  <a:txBody>
+                    <a:bodyPr/>
+                    <a:lstStyle/>
+                    <a:p>
+                      <a:pPr algn="l" indent="0" marL="0">
+                        <a:buNone/>
+                      </a:pPr>
+                      <a:r>
+                        <a:rPr lang="en-US" sz="1400" dirty="0">
+                          <a:solidFill>
+                            <a:srgbClr val="0E2E36"/>
+                          </a:solidFill>
+                          <a:latin typeface="Calibri" pitchFamily="34" charset="0"/>
+                          <a:ea typeface="Calibri" pitchFamily="34" charset="-122"/>
+                          <a:cs typeface="Calibri" pitchFamily="34" charset="-120"/>
+                        </a:rPr>
+                        <a:t>Individual randomised trial report (single RCT)</a:t>
+                      </a:r>
+                      <a:endParaRPr lang="en-US" sz="1400" dirty="0">
+                        <a:latin typeface="Calibri" charset="0"/>
+                        <a:ea typeface="Calibri" charset="0"/>
+                        <a:cs typeface="Calibri" charset="0"/>
+                      </a:endParaRPr>
+                    </a:p>
+                  </a:txBody>
+                  <a:tcPr marL="101600" marR="101600" marT="50800" marB="50800" anchor="ctr">
+                    <a:lnL w="12700" cap="flat" cmpd="sng" algn="ctr">
+                      <a:solidFill>
+                        <a:srgbClr val="D9E2E5"/>
+                      </a:solidFill>
+                      <a:prstDash val="solid"/>
+                      <a:round/>
+                      <a:headEnd type="none" w="med" len="med"/>
+                      <a:tailEnd type="none" w="med" len="med"/>
+                    </a:lnL>
+                    <a:lnR w="12700" cap="flat" cmpd="sng" algn="ctr">
+                      <a:solidFill>
+                        <a:srgbClr val="D9E2E5"/>
+                      </a:solidFill>
+                      <a:prstDash val="solid"/>
+                      <a:round/>
+                      <a:headEnd type="none" w="med" len="med"/>
+                      <a:tailEnd type="none" w="med" len="med"/>
+                    </a:lnR>
+                    <a:lnT w="12700" cap="flat" cmpd="sng" algn="ctr">
+                      <a:solidFill>
+                        <a:srgbClr val="D9E2E5"/>
+                      </a:solidFill>
+                      <a:prstDash val="solid"/>
+                      <a:round/>
+                      <a:headEnd type="none" w="med" len="med"/>
+                      <a:tailEnd type="none" w="med" len="med"/>
+                    </a:lnT>
+                    <a:lnB w="12700" cap="flat" cmpd="sng" algn="ctr">
+                      <a:solidFill>
+                        <a:srgbClr val="D9E2E5"/>
+                      </a:solidFill>
+                      <a:prstDash val="solid"/>
+                      <a:round/>
+                      <a:headEnd type="none" w="med" len="med"/>
+                      <a:tailEnd type="none" w="med" len="med"/>
+                    </a:lnB>
+                    <a:solidFill>
+                      <a:srgbClr val="EAF1F2"/>
+                    </a:solidFill>
+                  </a:tcPr>
+                </a:tc>
+                <a:tc>
+                  <a:txBody>
+                    <a:bodyPr/>
+                    <a:lstStyle/>
+                    <a:p>
+                      <a:pPr algn="l" indent="0" marL="0">
+                        <a:buNone/>
+                      </a:pPr>
+                      <a:r>
+                        <a:rPr lang="en-US" sz="1400" dirty="0">
+                          <a:solidFill>
+                            <a:srgbClr val="0E2E36"/>
+                          </a:solidFill>
+                          <a:latin typeface="Calibri" pitchFamily="34" charset="0"/>
+                          <a:ea typeface="Calibri" pitchFamily="34" charset="-122"/>
+                          <a:cs typeface="Calibri" pitchFamily="34" charset="-120"/>
+                        </a:rPr>
+                        <a:t>CONSORT 2010</a:t>
+                      </a:r>
+                      <a:endParaRPr lang="en-US" sz="1400" dirty="0">
+                        <a:latin typeface="Calibri" charset="0"/>
+                        <a:ea typeface="Calibri" charset="0"/>
+                        <a:cs typeface="Calibri" charset="0"/>
+                      </a:endParaRPr>
+                    </a:p>
+                  </a:txBody>
+                  <a:tcPr marL="101600" marR="101600" marT="50800" marB="50800" anchor="ctr">
+                    <a:lnL w="12700" cap="flat" cmpd="sng" algn="ctr">
+                      <a:solidFill>
+                        <a:srgbClr val="D9E2E5"/>
+                      </a:solidFill>
+                      <a:prstDash val="solid"/>
+                      <a:round/>
+                      <a:headEnd type="none" w="med" len="med"/>
+                      <a:tailEnd type="none" w="med" len="med"/>
+                    </a:lnL>
+                    <a:lnR w="12700" cap="flat" cmpd="sng" algn="ctr">
+                      <a:solidFill>
+                        <a:srgbClr val="D9E2E5"/>
+                      </a:solidFill>
+                      <a:prstDash val="solid"/>
+                      <a:round/>
+                      <a:headEnd type="none" w="med" len="med"/>
+                      <a:tailEnd type="none" w="med" len="med"/>
+                    </a:lnR>
+                    <a:lnT w="12700" cap="flat" cmpd="sng" algn="ctr">
+                      <a:solidFill>
+                        <a:srgbClr val="D9E2E5"/>
+                      </a:solidFill>
+                      <a:prstDash val="solid"/>
+                      <a:round/>
+                      <a:headEnd type="none" w="med" len="med"/>
+                      <a:tailEnd type="none" w="med" len="med"/>
+                    </a:lnT>
+                    <a:lnB w="12700" cap="flat" cmpd="sng" algn="ctr">
+                      <a:solidFill>
+                        <a:srgbClr val="D9E2E5"/>
+                      </a:solidFill>
+                      <a:prstDash val="solid"/>
+                      <a:round/>
+                      <a:headEnd type="none" w="med" len="med"/>
+                      <a:tailEnd type="none" w="med" len="med"/>
+                    </a:lnB>
+                    <a:solidFill>
+                      <a:srgbClr val="EAF1F2"/>
+                    </a:solidFill>
+                  </a:tcPr>
+                </a:tc>
+              </a:tr>
             </a:tbl>
           </a:graphicData>
         </a:graphic>
@@ -9593,12 +9792,12 @@
         </p:nvSpPr>
         <p:spPr>
           <a:xfrm>
-            <a:off x="548640" y="5257800"/>
-            <a:ext cx="11094415" cy="914400"/>
+            <a:off x="548640" y="5394960"/>
+            <a:ext cx="11094415" cy="868680"/>
           </a:xfrm>
           <a:prstGeom prst="roundRect">
             <a:avLst>
-              <a:gd name="adj" fmla="val 9000"/>
+              <a:gd name="adj" fmla="val 9474"/>
             </a:avLst>
           </a:prstGeom>
           <a:solidFill>
@@ -9622,8 +9821,8 @@
         </p:nvSpPr>
         <p:spPr>
           <a:xfrm>
-            <a:off x="914400" y="5257800"/>
-            <a:ext cx="10362895" cy="914400"/>
+            <a:off x="914400" y="5394960"/>
+            <a:ext cx="10362895" cy="868680"/>
           </a:xfrm>
           <a:prstGeom prst="rect">
             <a:avLst/>
@@ -9637,12 +9836,12 @@
           <a:p>
             <a:pPr indent="0" marL="0">
               <a:lnSpc>
-                <a:spcPct val="104000"/>
+                <a:spcPct val="102000"/>
               </a:lnSpc>
               <a:buNone/>
             </a:pPr>
             <a:r>
-              <a:rPr lang="en-US" sz="1350" b="1" dirty="0">
+              <a:rPr lang="en-US" sz="1300" b="1" dirty="0">
                 <a:solidFill>
                   <a:srgbClr val="C67A22"/>
                 </a:solidFill>
@@ -9654,12 +9853,12 @@
             </a:r>
             <a:pPr indent="0" marL="0">
               <a:lnSpc>
-                <a:spcPct val="104000"/>
+                <a:spcPct val="102000"/>
               </a:lnSpc>
               <a:buNone/>
             </a:pPr>
             <a:r>
-              <a:rPr lang="en-US" sz="1350" dirty="0">
+              <a:rPr lang="en-US" sz="1300" dirty="0">
                 <a:solidFill>
                   <a:srgbClr val="5E727A"/>
                 </a:solidFill>
@@ -9669,7 +9868,7 @@
               </a:rPr>
               <a:t>applying the wrong checklist is a genuine error — the skill makes the expert's routing decision automatically, every time, so no one has to remember.</a:t>
             </a:r>
-            <a:endParaRPr lang="en-US" sz="1350" dirty="0"/>
+            <a:endParaRPr lang="en-US" sz="1300" dirty="0"/>
           </a:p>
         </p:txBody>
       </p:sp>

</xml_diff>